<commit_message>
fix: correct hardware specs and improve slide 4 cost comparison
- Slide 4: M5Stack Core2 -> Basic V2.7 (7990 yen instead of 6600)
- Slide 4: total cost updated to 9570 yen
- Slide 4: market comparison table reduced from 5 to 4 categories
- Slide 4: cost-saving ratio emphasized (1/3.1 of market price)
- Slide 4: layout improved - table compression and box repositioning
- Slide 4: eliminated overlap issues with better spacing
- Slide 5: updated hardware label text
- Slide 7: table spacing improved
- docs/PPTX_SPEC.md: specs updated for all changes
</commit_message>
<xml_diff>
--- a/docs/career/Simple_Temp_Tool_Overview_v2.pptx
+++ b/docs/career/Simple_Temp_Tool_Overview_v2.pptx
@@ -18433,7 +18433,7 @@
                 </a:solidFill>
                 <a:latin typeface="游ゴシック"/>
               </a:rPr>
-              <a:t>本ツールの材料費（推定）</a:t>
+              <a:t>本ツール 品目別コスト</a:t>
             </a:r>
           </a:p>
         </p:txBody>
@@ -18448,7 +18448,7 @@
         </p:nvGraphicFramePr>
         <p:xfrm>
           <a:off x="320040" y="1371600"/>
-          <a:ext cx="5303520" cy="2688336"/>
+          <a:ext cx="5303520" cy="2560320"/>
         </p:xfrm>
         <a:graphic>
           <a:graphicData uri="http://schemas.openxmlformats.org/drawingml/2006/table">
@@ -18461,7 +18461,7 @@
                 <a:gridCol w="1371600"/>
                 <a:gridCol w="1280160"/>
               </a:tblGrid>
-              <a:tr h="384048">
+              <a:tr h="365760">
                 <a:tc>
                   <a:txBody>
                     <a:bodyPr/>
@@ -18532,21 +18532,21 @@
                   </a:tcPr>
                 </a:tc>
               </a:tr>
-              <a:tr h="384048">
-                <a:tc>
-                  <a:txBody>
-                    <a:bodyPr/>
-                    <a:lstStyle/>
-                    <a:p>
-                      <a:pPr algn="l"/>
-                      <a:r>
-                        <a:rPr sz="1200" b="0">
-                          <a:solidFill>
-                            <a:srgbClr val="1A1A2E"/>
-                          </a:solidFill>
-                          <a:latin typeface="游ゴシック"/>
-                        </a:rPr>
-                        <a:t>M5Stack Core2</a:t>
+              <a:tr h="365760">
+                <a:tc>
+                  <a:txBody>
+                    <a:bodyPr/>
+                    <a:lstStyle/>
+                    <a:p>
+                      <a:pPr algn="l"/>
+                      <a:r>
+                        <a:rPr sz="1200" b="0">
+                          <a:solidFill>
+                            <a:srgbClr val="1A1A2E"/>
+                          </a:solidFill>
+                          <a:latin typeface="游ゴシック"/>
+                        </a:rPr>
+                        <a:t>M5Stack Basic V2.7</a:t>
                       </a:r>
                     </a:p>
                   </a:txBody>
@@ -18569,7 +18569,7 @@
                           </a:solidFill>
                           <a:latin typeface="游ゴシック"/>
                         </a:rPr>
-                        <a:t>スイッチサイエンス</a:t>
+                        <a:t>Amazon</a:t>
                       </a:r>
                     </a:p>
                   </a:txBody>
@@ -18592,7 +18592,7 @@
                           </a:solidFill>
                           <a:latin typeface="游ゴシック"/>
                         </a:rPr>
-                        <a:t>¥6,600</a:t>
+                        <a:t>¥7,990</a:t>
                       </a:r>
                     </a:p>
                   </a:txBody>
@@ -18603,7 +18603,7 @@
                   </a:tcPr>
                 </a:tc>
               </a:tr>
-              <a:tr h="384048">
+              <a:tr h="365760">
                 <a:tc>
                   <a:txBody>
                     <a:bodyPr/>
@@ -18674,7 +18674,7 @@
                   </a:tcPr>
                 </a:tc>
               </a:tr>
-              <a:tr h="384048">
+              <a:tr h="365760">
                 <a:tc>
                   <a:txBody>
                     <a:bodyPr/>
@@ -18745,7 +18745,7 @@
                   </a:tcPr>
                 </a:tc>
               </a:tr>
-              <a:tr h="384048">
+              <a:tr h="365760">
                 <a:tc>
                   <a:txBody>
                     <a:bodyPr/>
@@ -18816,7 +18816,7 @@
                   </a:tcPr>
                 </a:tc>
               </a:tr>
-              <a:tr h="384048">
+              <a:tr h="365760">
                 <a:tc>
                   <a:txBody>
                     <a:bodyPr/>
@@ -18887,7 +18887,7 @@
                   </a:tcPr>
                 </a:tc>
               </a:tr>
-              <a:tr h="384048">
+              <a:tr h="365760">
                 <a:tc>
                   <a:txBody>
                     <a:bodyPr/>
@@ -18947,7 +18947,7 @@
                           </a:solidFill>
                           <a:latin typeface="游ゴシック"/>
                         </a:rPr>
-                        <a:t>¥9,080</a:t>
+                        <a:t>¥9,570</a:t>
                       </a:r>
                     </a:p>
                   </a:txBody>
@@ -18992,7 +18992,7 @@
                 </a:solidFill>
                 <a:latin typeface="游ゴシック"/>
               </a:rPr>
-              <a:t>市販温度データロガーとの比較（推定）</a:t>
+              <a:t>市販温度ロガーとの価格比較</a:t>
             </a:r>
           </a:p>
         </p:txBody>
@@ -19007,7 +19007,7 @@
         </p:nvGraphicFramePr>
         <p:xfrm>
           <a:off x="5943600" y="1371600"/>
-          <a:ext cx="5925312" cy="2304288"/>
+          <a:ext cx="5925312" cy="1463040"/>
         </p:xfrm>
         <a:graphic>
           <a:graphicData uri="http://schemas.openxmlformats.org/drawingml/2006/table">
@@ -19020,7 +19020,7 @@
                 <a:gridCol w="1993392"/>
                 <a:gridCol w="1371600"/>
               </a:tblGrid>
-              <a:tr h="384048">
+              <a:tr h="365760">
                 <a:tc>
                   <a:txBody>
                     <a:bodyPr/>
@@ -19034,7 +19034,7 @@
                           </a:solidFill>
                           <a:latin typeface="Segoe UI"/>
                         </a:rPr>
-                        <a:t>製品カテゴリ</a:t>
+                        <a:t>カテゴリ</a:t>
                       </a:r>
                     </a:p>
                   </a:txBody>
@@ -19057,7 +19057,7 @@
                           </a:solidFill>
                           <a:latin typeface="Segoe UI"/>
                         </a:rPr>
-                        <a:t>代表製品例</a:t>
+                        <a:t>代表製品</a:t>
                       </a:r>
                     </a:p>
                   </a:txBody>
@@ -19091,7 +19091,7 @@
                   </a:tcPr>
                 </a:tc>
               </a:tr>
-              <a:tr h="384048">
+              <a:tr h="365760">
                 <a:tc>
                   <a:txBody>
                     <a:bodyPr/>
@@ -19151,7 +19151,7 @@
                           </a:solidFill>
                           <a:latin typeface="游ゴシック"/>
                         </a:rPr>
-                        <a:t>約 ¥9,000</a:t>
+                        <a:t>¥9,570</a:t>
                       </a:r>
                     </a:p>
                   </a:txBody>
@@ -19162,21 +19162,21 @@
                   </a:tcPr>
                 </a:tc>
               </a:tr>
-              <a:tr h="384048">
-                <a:tc>
-                  <a:txBody>
-                    <a:bodyPr/>
-                    <a:lstStyle/>
-                    <a:p>
-                      <a:pPr algn="l"/>
-                      <a:r>
-                        <a:rPr sz="1200" b="0">
-                          <a:solidFill>
-                            <a:srgbClr val="1A1A2E"/>
-                          </a:solidFill>
-                          <a:latin typeface="游ゴシック"/>
-                        </a:rPr>
-                        <a:t>汎用 USB ロガー</a:t>
+              <a:tr h="365760">
+                <a:tc>
+                  <a:txBody>
+                    <a:bodyPr/>
+                    <a:lstStyle/>
+                    <a:p>
+                      <a:pPr algn="l"/>
+                      <a:r>
+                        <a:rPr sz="1200" b="0">
+                          <a:solidFill>
+                            <a:srgbClr val="1A1A2E"/>
+                          </a:solidFill>
+                          <a:latin typeface="游ゴシック"/>
+                        </a:rPr>
+                        <a:t>標準製品</a:t>
                       </a:r>
                     </a:p>
                   </a:txBody>
@@ -19199,7 +19199,7 @@
                           </a:solidFill>
                           <a:latin typeface="游ゴシック"/>
                         </a:rPr>
-                        <a:t>各社標準品</a:t>
+                        <a:t>USB データロガー</a:t>
                       </a:r>
                     </a:p>
                   </a:txBody>
@@ -19233,21 +19233,21 @@
                   </a:tcPr>
                 </a:tc>
               </a:tr>
-              <a:tr h="384048">
-                <a:tc>
-                  <a:txBody>
-                    <a:bodyPr/>
-                    <a:lstStyle/>
-                    <a:p>
-                      <a:pPr algn="l"/>
-                      <a:r>
-                        <a:rPr sz="1200" b="0">
-                          <a:solidFill>
-                            <a:srgbClr val="1A1A2E"/>
-                          </a:solidFill>
-                          <a:latin typeface="游ゴシック"/>
-                        </a:rPr>
-                        <a:t>熱電対ハンディロガー</a:t>
+              <a:tr h="365760">
+                <a:tc>
+                  <a:txBody>
+                    <a:bodyPr/>
+                    <a:lstStyle/>
+                    <a:p>
+                      <a:pPr algn="l"/>
+                      <a:r>
+                        <a:rPr sz="1200" b="0">
+                          <a:solidFill>
+                            <a:srgbClr val="1A1A2E"/>
+                          </a:solidFill>
+                          <a:latin typeface="游ゴシック"/>
+                        </a:rPr>
+                        <a:t>プロフェッショナル</a:t>
                       </a:r>
                     </a:p>
                   </a:txBody>
@@ -19270,149 +19270,7 @@
                           </a:solidFill>
                           <a:latin typeface="游ゴシック"/>
                         </a:rPr>
-                        <a:t>HIOKI LR8520 系</a:t>
-                      </a:r>
-                    </a:p>
-                  </a:txBody>
-                  <a:tcPr>
-                    <a:solidFill>
-                      <a:srgbClr val="FFFFFF"/>
-                    </a:solidFill>
-                  </a:tcPr>
-                </a:tc>
-                <a:tc>
-                  <a:txBody>
-                    <a:bodyPr/>
-                    <a:lstStyle/>
-                    <a:p>
-                      <a:pPr algn="l"/>
-                      <a:r>
-                        <a:rPr sz="1200" b="0">
-                          <a:solidFill>
-                            <a:srgbClr val="1A1A2E"/>
-                          </a:solidFill>
-                          <a:latin typeface="游ゴシック"/>
-                        </a:rPr>
-                        <a:t>¥50,000〜¥120,000</a:t>
-                      </a:r>
-                    </a:p>
-                  </a:txBody>
-                  <a:tcPr>
-                    <a:solidFill>
-                      <a:srgbClr val="FFFFFF"/>
-                    </a:solidFill>
-                  </a:tcPr>
-                </a:tc>
-              </a:tr>
-              <a:tr h="384048">
-                <a:tc>
-                  <a:txBody>
-                    <a:bodyPr/>
-                    <a:lstStyle/>
-                    <a:p>
-                      <a:pPr algn="l"/>
-                      <a:r>
-                        <a:rPr sz="1200" b="0">
-                          <a:solidFill>
-                            <a:srgbClr val="1A1A2E"/>
-                          </a:solidFill>
-                          <a:latin typeface="游ゴシック"/>
-                        </a:rPr>
-                        <a:t>熱電対 SD ロガー</a:t>
-                      </a:r>
-                    </a:p>
-                  </a:txBody>
-                  <a:tcPr>
-                    <a:solidFill>
-                      <a:srgbClr val="F4F4F4"/>
-                    </a:solidFill>
-                  </a:tcPr>
-                </a:tc>
-                <a:tc>
-                  <a:txBody>
-                    <a:bodyPr/>
-                    <a:lstStyle/>
-                    <a:p>
-                      <a:pPr algn="l"/>
-                      <a:r>
-                        <a:rPr sz="1200" b="0">
-                          <a:solidFill>
-                            <a:srgbClr val="1A1A2E"/>
-                          </a:solidFill>
-                          <a:latin typeface="游ゴシック"/>
-                        </a:rPr>
-                        <a:t>グラフテック GL240 等</a:t>
-                      </a:r>
-                    </a:p>
-                  </a:txBody>
-                  <a:tcPr>
-                    <a:solidFill>
-                      <a:srgbClr val="F4F4F4"/>
-                    </a:solidFill>
-                  </a:tcPr>
-                </a:tc>
-                <a:tc>
-                  <a:txBody>
-                    <a:bodyPr/>
-                    <a:lstStyle/>
-                    <a:p>
-                      <a:pPr algn="l"/>
-                      <a:r>
-                        <a:rPr sz="1200" b="0">
-                          <a:solidFill>
-                            <a:srgbClr val="1A1A2E"/>
-                          </a:solidFill>
-                          <a:latin typeface="游ゴシック"/>
-                        </a:rPr>
-                        <a:t>¥80,000〜¥150,000</a:t>
-                      </a:r>
-                    </a:p>
-                  </a:txBody>
-                  <a:tcPr>
-                    <a:solidFill>
-                      <a:srgbClr val="F4F4F4"/>
-                    </a:solidFill>
-                  </a:tcPr>
-                </a:tc>
-              </a:tr>
-              <a:tr h="384048">
-                <a:tc>
-                  <a:txBody>
-                    <a:bodyPr/>
-                    <a:lstStyle/>
-                    <a:p>
-                      <a:pPr algn="l"/>
-                      <a:r>
-                        <a:rPr sz="1200" b="0">
-                          <a:solidFill>
-                            <a:srgbClr val="1A1A2E"/>
-                          </a:solidFill>
-                          <a:latin typeface="游ゴシック"/>
-                        </a:rPr>
                         <a:t>産業用データロガー</a:t>
-                      </a:r>
-                    </a:p>
-                  </a:txBody>
-                  <a:tcPr>
-                    <a:solidFill>
-                      <a:srgbClr val="FFFFFF"/>
-                    </a:solidFill>
-                  </a:tcPr>
-                </a:tc>
-                <a:tc>
-                  <a:txBody>
-                    <a:bodyPr/>
-                    <a:lstStyle/>
-                    <a:p>
-                      <a:pPr algn="l"/>
-                      <a:r>
-                        <a:rPr sz="1200" b="0">
-                          <a:solidFill>
-                            <a:srgbClr val="1A1A2E"/>
-                          </a:solidFill>
-                          <a:latin typeface="游ゴシック"/>
-                        </a:rPr>
-                        <a:t>各社産業グレード</a:t>
                       </a:r>
                     </a:p>
                   </a:txBody>
@@ -19458,8 +19316,8 @@
         </p:nvSpPr>
         <p:spPr>
           <a:xfrm>
-            <a:off x="320040" y="3840480"/>
-            <a:ext cx="11521440" cy="1188720"/>
+            <a:off x="320040" y="2743200"/>
+            <a:ext cx="11521440" cy="1280160"/>
           </a:xfrm>
           <a:prstGeom prst="rect">
             <a:avLst/>
@@ -19501,8 +19359,8 @@
         </p:nvSpPr>
         <p:spPr>
           <a:xfrm>
-            <a:off x="457200" y="3931920"/>
-            <a:ext cx="11247120" cy="502920"/>
+            <a:off x="457200" y="2834640"/>
+            <a:ext cx="11247120" cy="548640"/>
           </a:xfrm>
           <a:prstGeom prst="rect">
             <a:avLst/>
@@ -19517,13 +19375,13 @@
           <a:p>
             <a:pPr algn="ctr"/>
             <a:r>
-              <a:rPr sz="2000" b="1" i="0">
+              <a:rPr sz="2200" b="1" i="0">
                 <a:solidFill>
                   <a:srgbClr val="FFFFFF"/>
                 </a:solidFill>
                 <a:latin typeface="游ゴシック"/>
               </a:rPr>
-              <a:t>市販品の最安モデル（¥30,000〜）と比べて → 約 ¥21,000 以上のコスト削減</a:t>
+              <a:t>標準製品の 1/3.1 の価格で同等機能を実現</a:t>
             </a:r>
           </a:p>
         </p:txBody>
@@ -19536,8 +19394,8 @@
         </p:nvSpPr>
         <p:spPr>
           <a:xfrm>
-            <a:off x="457200" y="4480560"/>
-            <a:ext cx="11247120" cy="411480"/>
+            <a:off x="457200" y="3474720"/>
+            <a:ext cx="11247120" cy="457200"/>
           </a:xfrm>
           <a:prstGeom prst="rect">
             <a:avLst/>
@@ -19552,27 +19410,62 @@
           <a:p>
             <a:pPr algn="ctr"/>
             <a:r>
-              <a:rPr sz="1400" b="0" i="0">
+              <a:rPr sz="1500" b="0" i="0">
                 <a:solidFill>
                   <a:srgbClr val="FF6D00"/>
                 </a:solidFill>
                 <a:latin typeface="游ゴシック"/>
               </a:rPr>
-              <a:t>市販品の 1/4 〜 1/28 のコストで、同等の計測・記録・アラーム機能を自作実現</a:t>
-            </a:r>
-          </a:p>
-        </p:txBody>
-      </p:sp>
-      <p:sp>
-        <p:nvSpPr>
-          <p:cNvPr id="15" name="Rectangle 14"/>
+              <a:t>本ツール ¥9,570 vs 標準ロガー ¥30,000〜 → 最大 ¥20,000 以上削減</a:t>
+            </a:r>
+          </a:p>
+        </p:txBody>
+      </p:sp>
+      <p:sp>
+        <p:nvSpPr>
+          <p:cNvPr id="15" name="TextBox 14"/>
+          <p:cNvSpPr txBox="1"/>
+          <p:nvPr/>
+        </p:nvSpPr>
+        <p:spPr>
+          <a:xfrm>
+            <a:off x="457200" y="3977639"/>
+            <a:ext cx="11247120" cy="320040"/>
+          </a:xfrm>
+          <a:prstGeom prst="rect">
+            <a:avLst/>
+          </a:prstGeom>
+          <a:noFill/>
+        </p:spPr>
+        <p:txBody>
+          <a:bodyPr wrap="square">
+            <a:spAutoFit/>
+          </a:bodyPr>
+          <a:lstStyle/>
+          <a:p>
+            <a:pPr algn="ctr"/>
+            <a:r>
+              <a:rPr sz="1200" b="0" i="0">
+                <a:solidFill>
+                  <a:srgbClr val="FFFFFF"/>
+                </a:solidFill>
+                <a:latin typeface="游ゴシック"/>
+              </a:rPr>
+              <a:t>（SD 自動記録 ・ LCD リアルタイム表示 ・ 上下限アラーム機能 完全実装）</a:t>
+            </a:r>
+          </a:p>
+        </p:txBody>
+      </p:sp>
+      <p:sp>
+        <p:nvSpPr>
+          <p:cNvPr id="16" name="Rectangle 15"/>
           <p:cNvSpPr/>
           <p:nvPr/>
         </p:nvSpPr>
         <p:spPr>
           <a:xfrm>
-            <a:off x="320040" y="5166360"/>
-            <a:ext cx="11521440" cy="640080"/>
+            <a:off x="320040" y="4160520"/>
+            <a:ext cx="11521440" cy="914400"/>
           </a:xfrm>
           <a:prstGeom prst="rect">
             <a:avLst/>
@@ -19608,14 +19501,14 @@
       </p:sp>
       <p:sp>
         <p:nvSpPr>
-          <p:cNvPr id="16" name="TextBox 15"/>
+          <p:cNvPr id="17" name="TextBox 16"/>
           <p:cNvSpPr txBox="1"/>
           <p:nvPr/>
         </p:nvSpPr>
         <p:spPr>
           <a:xfrm>
-            <a:off x="502920" y="5230368"/>
-            <a:ext cx="11155680" cy="530352"/>
+            <a:off x="502920" y="4224528"/>
+            <a:ext cx="11155680" cy="749808"/>
           </a:xfrm>
           <a:prstGeom prst="rect">
             <a:avLst/>
@@ -19636,7 +19529,19 @@
                 </a:solidFill>
                 <a:latin typeface="游ゴシック"/>
               </a:rPr>
-              <a:t>実装済み機能:  ✓ SD 自動記録  ✓ LCD リアルタイム表示  ✓ 上下限アラーム（ビープ音）  ✓ スタンドアロン動作  ✓ EEPROM 設定保存  ✓ 統計解析（平均・σ・Max/Min）</a:t>
+              <a:t>✓ SD 自動記録  ✓ LCD リアルタイム表示  ✓ 上下限アラーム（ビープ音）</a:t>
+            </a:r>
+          </a:p>
+          <a:p>
+            <a:pPr algn="ctr"/>
+            <a:r>
+              <a:rPr sz="1200" b="0" i="0">
+                <a:solidFill>
+                  <a:srgbClr val="1A1A2E"/>
+                </a:solidFill>
+                <a:latin typeface="游ゴシック"/>
+              </a:rPr>
+              <a:t>✓ スタンドアロン動作  ✓ EEPROM 設定保存  ✓ 統計解析（平均・σ・Max/Min）</a:t>
             </a:r>
           </a:p>
         </p:txBody>
@@ -20202,7 +20107,7 @@
                 </a:solidFill>
                 <a:latin typeface="Segoe UI"/>
               </a:rPr>
-              <a:t>M5Stack Core2</a:t>
+              <a:t>M5Stack Basic V2.7</a:t>
             </a:r>
           </a:p>
         </p:txBody>
@@ -21697,7 +21602,7 @@
         </p:nvGraphicFramePr>
         <p:xfrm>
           <a:off x="320040" y="1417320"/>
-          <a:ext cx="11521439" cy="2633472"/>
+          <a:ext cx="11521439" cy="2468880"/>
         </p:xfrm>
         <a:graphic>
           <a:graphicData uri="http://schemas.openxmlformats.org/drawingml/2006/table">
@@ -21711,7 +21616,7 @@
                 <a:gridCol w="3657600"/>
                 <a:gridCol w="3749039"/>
               </a:tblGrid>
-              <a:tr h="438912">
+              <a:tr h="411480">
                 <a:tc>
                   <a:txBody>
                     <a:bodyPr/>
@@ -21805,7 +21710,7 @@
                   </a:tcPr>
                 </a:tc>
               </a:tr>
-              <a:tr h="438912">
+              <a:tr h="411480">
                 <a:tc>
                   <a:txBody>
                     <a:bodyPr/>
@@ -21899,7 +21804,7 @@
                   </a:tcPr>
                 </a:tc>
               </a:tr>
-              <a:tr h="438912">
+              <a:tr h="411480">
                 <a:tc>
                   <a:txBody>
                     <a:bodyPr/>
@@ -21993,7 +21898,7 @@
                   </a:tcPr>
                 </a:tc>
               </a:tr>
-              <a:tr h="438912">
+              <a:tr h="411480">
                 <a:tc>
                   <a:txBody>
                     <a:bodyPr/>
@@ -22087,7 +21992,7 @@
                   </a:tcPr>
                 </a:tc>
               </a:tr>
-              <a:tr h="438912">
+              <a:tr h="411480">
                 <a:tc>
                   <a:txBody>
                     <a:bodyPr/>
@@ -22181,7 +22086,7 @@
                   </a:tcPr>
                 </a:tc>
               </a:tr>
-              <a:tr h="438912">
+              <a:tr h="411480">
                 <a:tc>
                   <a:txBody>
                     <a:bodyPr/>
@@ -22287,8 +22192,8 @@
         </p:nvSpPr>
         <p:spPr>
           <a:xfrm>
-            <a:off x="320040" y="3886200"/>
-            <a:ext cx="11521440" cy="1005840"/>
+            <a:off x="320040" y="3657600"/>
+            <a:ext cx="11521440" cy="960120"/>
           </a:xfrm>
           <a:prstGeom prst="rect">
             <a:avLst/>
@@ -22332,7 +22237,7 @@
         </p:nvSpPr>
         <p:spPr>
           <a:xfrm>
-            <a:off x="502920" y="3950208"/>
+            <a:off x="502920" y="3703320"/>
             <a:ext cx="11155680" cy="365760"/>
           </a:xfrm>
           <a:prstGeom prst="rect">
@@ -22367,7 +22272,7 @@
         </p:nvSpPr>
         <p:spPr>
           <a:xfrm>
-            <a:off x="502920" y="4343400"/>
+            <a:off x="502920" y="4096512"/>
             <a:ext cx="11155680" cy="411480"/>
           </a:xfrm>
           <a:prstGeom prst="rect">
@@ -22402,8 +22307,8 @@
         </p:nvSpPr>
         <p:spPr>
           <a:xfrm>
-            <a:off x="320040" y="5029200"/>
-            <a:ext cx="11521440" cy="731520"/>
+            <a:off x="320040" y="4709160"/>
+            <a:ext cx="11521440" cy="640080"/>
           </a:xfrm>
           <a:prstGeom prst="rect">
             <a:avLst/>
@@ -22445,7 +22350,7 @@
         </p:nvSpPr>
         <p:spPr>
           <a:xfrm>
-            <a:off x="502920" y="5102352"/>
+            <a:off x="502920" y="4773168"/>
             <a:ext cx="11155680" cy="502920"/>
           </a:xfrm>
           <a:prstGeom prst="rect">
@@ -22461,7 +22366,7 @@
           <a:p>
             <a:pPr algn="l"/>
             <a:r>
-              <a:rPr sz="1300" b="0" i="0">
+              <a:rPr sz="1200" b="0" i="0">
                 <a:solidFill>
                   <a:srgbClr val="1A1A2E"/>
                 </a:solidFill>

</xml_diff>

<commit_message>
fix: update presentation content and layout for clarity
</commit_message>
<xml_diff>
--- a/docs/career/Simple_Temp_Tool_Overview_v2.pptx
+++ b/docs/career/Simple_Temp_Tool_Overview_v2.pptx
@@ -5,31 +5,31 @@
     <p:sldMasterId id="2147483648" r:id="rId1"/>
   </p:sldMasterIdLst>
   <p:sldIdLst>
-    <p:sldId id="256" r:id="rId7"/>
-    <p:sldId id="257" r:id="rId8"/>
-    <p:sldId id="258" r:id="rId9"/>
-    <p:sldId id="259" r:id="rId10"/>
-    <p:sldId id="260" r:id="rId11"/>
-    <p:sldId id="261" r:id="rId12"/>
-    <p:sldId id="262" r:id="rId13"/>
-    <p:sldId id="263" r:id="rId14"/>
-    <p:sldId id="264" r:id="rId15"/>
-    <p:sldId id="265" r:id="rId16"/>
-    <p:sldId id="266" r:id="rId17"/>
-    <p:sldId id="267" r:id="rId18"/>
-    <p:sldId id="268" r:id="rId19"/>
-    <p:sldId id="269" r:id="rId20"/>
-    <p:sldId id="270" r:id="rId21"/>
-    <p:sldId id="271" r:id="rId22"/>
-    <p:sldId id="272" r:id="rId23"/>
-    <p:sldId id="273" r:id="rId24"/>
-    <p:sldId id="274" r:id="rId25"/>
-    <p:sldId id="275" r:id="rId26"/>
-    <p:sldId id="276" r:id="rId27"/>
-    <p:sldId id="277" r:id="rId28"/>
-    <p:sldId id="278" r:id="rId29"/>
+    <p:sldId id="256" r:id="rId2"/>
+    <p:sldId id="257" r:id="rId3"/>
+    <p:sldId id="258" r:id="rId4"/>
+    <p:sldId id="259" r:id="rId5"/>
+    <p:sldId id="260" r:id="rId6"/>
+    <p:sldId id="261" r:id="rId7"/>
+    <p:sldId id="262" r:id="rId8"/>
+    <p:sldId id="263" r:id="rId9"/>
+    <p:sldId id="264" r:id="rId10"/>
+    <p:sldId id="265" r:id="rId11"/>
+    <p:sldId id="266" r:id="rId12"/>
+    <p:sldId id="267" r:id="rId13"/>
+    <p:sldId id="268" r:id="rId14"/>
+    <p:sldId id="269" r:id="rId15"/>
+    <p:sldId id="270" r:id="rId16"/>
+    <p:sldId id="271" r:id="rId17"/>
+    <p:sldId id="272" r:id="rId18"/>
+    <p:sldId id="273" r:id="rId19"/>
+    <p:sldId id="274" r:id="rId20"/>
+    <p:sldId id="275" r:id="rId21"/>
+    <p:sldId id="276" r:id="rId22"/>
+    <p:sldId id="277" r:id="rId23"/>
+    <p:sldId id="278" r:id="rId24"/>
   </p:sldIdLst>
-  <p:sldSz cx="12188952" cy="6858000" type="screen4x3"/>
+  <p:sldSz cx="12188825" cy="6858000"/>
   <p:notesSz cx="6858000" cy="9144000"/>
   <p:defaultTextStyle>
     <a:defPPr>
@@ -126,6 +126,22 @@
       </a:defRPr>
     </a:lvl9pPr>
   </p:defaultTextStyle>
+  <p:extLst>
+    <p:ext uri="{EFAFB233-063F-42B5-8137-9DF3F51BA10A}">
+      <p15:sldGuideLst xmlns:p15="http://schemas.microsoft.com/office/powerpoint/2012/main">
+        <p15:guide id="1" orient="horz" pos="2160">
+          <p15:clr>
+            <a:srgbClr val="A4A3A4"/>
+          </p15:clr>
+        </p15:guide>
+        <p15:guide id="2" pos="2880">
+          <p15:clr>
+            <a:srgbClr val="A4A3A4"/>
+          </p15:clr>
+        </p15:guide>
+      </p15:sldGuideLst>
+    </p:ext>
+  </p:extLst>
 </p:presentation>
 </file>
 
@@ -167,10 +183,9 @@
           <a:lstStyle/>
           <a:p>
             <a:r>
-              <a:rPr lang="en-US" smtClean="0"/>
+              <a:rPr lang="en-US"/>
               <a:t>Click to edit Master title style</a:t>
             </a:r>
-            <a:endParaRPr lang="en-US"/>
           </a:p>
         </p:txBody>
       </p:sp>
@@ -286,10 +301,9 @@
           </a:lstStyle>
           <a:p>
             <a:r>
-              <a:rPr lang="en-US" smtClean="0"/>
+              <a:rPr lang="en-US"/>
               <a:t>Click to edit Master subtitle style</a:t>
             </a:r>
-            <a:endParaRPr lang="en-US"/>
           </a:p>
         </p:txBody>
       </p:sp>
@@ -310,7 +324,7 @@
           <a:p>
             <a:fld id="{5BCAD085-E8A6-8845-BD4E-CB4CCA059FC4}" type="datetimeFigureOut">
               <a:rPr lang="en-US" smtClean="0"/>
-              <a:t>1/27/13</a:t>
+              <a:t>3/2/2026</a:t>
             </a:fld>
             <a:endParaRPr lang="en-US"/>
           </a:p>
@@ -404,10 +418,9 @@
           <a:lstStyle/>
           <a:p>
             <a:r>
-              <a:rPr lang="en-US" smtClean="0"/>
+              <a:rPr lang="en-US"/>
               <a:t>Click to edit Master title style</a:t>
             </a:r>
-            <a:endParaRPr lang="en-US"/>
           </a:p>
         </p:txBody>
       </p:sp>
@@ -428,38 +441,37 @@
           <a:p>
             <a:pPr lvl="0"/>
             <a:r>
-              <a:rPr lang="en-US" smtClean="0"/>
+              <a:rPr lang="en-US"/>
               <a:t>Click to edit Master text styles</a:t>
             </a:r>
           </a:p>
           <a:p>
             <a:pPr lvl="1"/>
             <a:r>
-              <a:rPr lang="en-US" smtClean="0"/>
+              <a:rPr lang="en-US"/>
               <a:t>Second level</a:t>
             </a:r>
           </a:p>
           <a:p>
             <a:pPr lvl="2"/>
             <a:r>
-              <a:rPr lang="en-US" smtClean="0"/>
+              <a:rPr lang="en-US"/>
               <a:t>Third level</a:t>
             </a:r>
           </a:p>
           <a:p>
             <a:pPr lvl="3"/>
             <a:r>
-              <a:rPr lang="en-US" smtClean="0"/>
+              <a:rPr lang="en-US"/>
               <a:t>Fourth level</a:t>
             </a:r>
           </a:p>
           <a:p>
             <a:pPr lvl="4"/>
             <a:r>
-              <a:rPr lang="en-US" smtClean="0"/>
+              <a:rPr lang="en-US"/>
               <a:t>Fifth level</a:t>
             </a:r>
-            <a:endParaRPr lang="en-US"/>
           </a:p>
         </p:txBody>
       </p:sp>
@@ -480,7 +492,7 @@
           <a:p>
             <a:fld id="{5BCAD085-E8A6-8845-BD4E-CB4CCA059FC4}" type="datetimeFigureOut">
               <a:rPr lang="en-US" smtClean="0"/>
-              <a:t>1/27/13</a:t>
+              <a:t>3/2/2026</a:t>
             </a:fld>
             <a:endParaRPr lang="en-US"/>
           </a:p>
@@ -579,10 +591,9 @@
           <a:lstStyle/>
           <a:p>
             <a:r>
-              <a:rPr lang="en-US" smtClean="0"/>
+              <a:rPr lang="en-US"/>
               <a:t>Click to edit Master title style</a:t>
             </a:r>
-            <a:endParaRPr lang="en-US"/>
           </a:p>
         </p:txBody>
       </p:sp>
@@ -608,38 +619,37 @@
           <a:p>
             <a:pPr lvl="0"/>
             <a:r>
-              <a:rPr lang="en-US" smtClean="0"/>
+              <a:rPr lang="en-US"/>
               <a:t>Click to edit Master text styles</a:t>
             </a:r>
           </a:p>
           <a:p>
             <a:pPr lvl="1"/>
             <a:r>
-              <a:rPr lang="en-US" smtClean="0"/>
+              <a:rPr lang="en-US"/>
               <a:t>Second level</a:t>
             </a:r>
           </a:p>
           <a:p>
             <a:pPr lvl="2"/>
             <a:r>
-              <a:rPr lang="en-US" smtClean="0"/>
+              <a:rPr lang="en-US"/>
               <a:t>Third level</a:t>
             </a:r>
           </a:p>
           <a:p>
             <a:pPr lvl="3"/>
             <a:r>
-              <a:rPr lang="en-US" smtClean="0"/>
+              <a:rPr lang="en-US"/>
               <a:t>Fourth level</a:t>
             </a:r>
           </a:p>
           <a:p>
             <a:pPr lvl="4"/>
             <a:r>
-              <a:rPr lang="en-US" smtClean="0"/>
+              <a:rPr lang="en-US"/>
               <a:t>Fifth level</a:t>
             </a:r>
-            <a:endParaRPr lang="en-US"/>
           </a:p>
         </p:txBody>
       </p:sp>
@@ -660,7 +670,7 @@
           <a:p>
             <a:fld id="{5BCAD085-E8A6-8845-BD4E-CB4CCA059FC4}" type="datetimeFigureOut">
               <a:rPr lang="en-US" smtClean="0"/>
-              <a:t>1/27/13</a:t>
+              <a:t>3/2/2026</a:t>
             </a:fld>
             <a:endParaRPr lang="en-US"/>
           </a:p>
@@ -754,10 +764,9 @@
           <a:lstStyle/>
           <a:p>
             <a:r>
-              <a:rPr lang="en-US" smtClean="0"/>
+              <a:rPr lang="en-US"/>
               <a:t>Click to edit Master title style</a:t>
             </a:r>
-            <a:endParaRPr lang="en-US"/>
           </a:p>
         </p:txBody>
       </p:sp>
@@ -778,38 +787,37 @@
           <a:p>
             <a:pPr lvl="0"/>
             <a:r>
-              <a:rPr lang="en-US" smtClean="0"/>
+              <a:rPr lang="en-US"/>
               <a:t>Click to edit Master text styles</a:t>
             </a:r>
           </a:p>
           <a:p>
             <a:pPr lvl="1"/>
             <a:r>
-              <a:rPr lang="en-US" smtClean="0"/>
+              <a:rPr lang="en-US"/>
               <a:t>Second level</a:t>
             </a:r>
           </a:p>
           <a:p>
             <a:pPr lvl="2"/>
             <a:r>
-              <a:rPr lang="en-US" smtClean="0"/>
+              <a:rPr lang="en-US"/>
               <a:t>Third level</a:t>
             </a:r>
           </a:p>
           <a:p>
             <a:pPr lvl="3"/>
             <a:r>
-              <a:rPr lang="en-US" smtClean="0"/>
+              <a:rPr lang="en-US"/>
               <a:t>Fourth level</a:t>
             </a:r>
           </a:p>
           <a:p>
             <a:pPr lvl="4"/>
             <a:r>
-              <a:rPr lang="en-US" smtClean="0"/>
+              <a:rPr lang="en-US"/>
               <a:t>Fifth level</a:t>
             </a:r>
-            <a:endParaRPr lang="en-US"/>
           </a:p>
         </p:txBody>
       </p:sp>
@@ -830,7 +838,7 @@
           <a:p>
             <a:fld id="{5BCAD085-E8A6-8845-BD4E-CB4CCA059FC4}" type="datetimeFigureOut">
               <a:rPr lang="en-US" smtClean="0"/>
-              <a:t>1/27/13</a:t>
+              <a:t>3/2/2026</a:t>
             </a:fld>
             <a:endParaRPr lang="en-US"/>
           </a:p>
@@ -933,10 +941,9 @@
           </a:lstStyle>
           <a:p>
             <a:r>
-              <a:rPr lang="en-US" smtClean="0"/>
+              <a:rPr lang="en-US"/>
               <a:t>Click to edit Master title style</a:t>
             </a:r>
-            <a:endParaRPr lang="en-US"/>
           </a:p>
         </p:txBody>
       </p:sp>
@@ -1053,7 +1060,7 @@
           <a:p>
             <a:pPr lvl="0"/>
             <a:r>
-              <a:rPr lang="en-US" smtClean="0"/>
+              <a:rPr lang="en-US"/>
               <a:t>Click to edit Master text styles</a:t>
             </a:r>
           </a:p>
@@ -1076,7 +1083,7 @@
           <a:p>
             <a:fld id="{5BCAD085-E8A6-8845-BD4E-CB4CCA059FC4}" type="datetimeFigureOut">
               <a:rPr lang="en-US" smtClean="0"/>
-              <a:t>1/27/13</a:t>
+              <a:t>3/2/2026</a:t>
             </a:fld>
             <a:endParaRPr lang="en-US"/>
           </a:p>
@@ -1170,10 +1177,9 @@
           <a:lstStyle/>
           <a:p>
             <a:r>
-              <a:rPr lang="en-US" smtClean="0"/>
+              <a:rPr lang="en-US"/>
               <a:t>Click to edit Master title style</a:t>
             </a:r>
-            <a:endParaRPr lang="en-US"/>
           </a:p>
         </p:txBody>
       </p:sp>
@@ -1227,38 +1233,37 @@
           <a:p>
             <a:pPr lvl="0"/>
             <a:r>
-              <a:rPr lang="en-US" smtClean="0"/>
+              <a:rPr lang="en-US"/>
               <a:t>Click to edit Master text styles</a:t>
             </a:r>
           </a:p>
           <a:p>
             <a:pPr lvl="1"/>
             <a:r>
-              <a:rPr lang="en-US" smtClean="0"/>
+              <a:rPr lang="en-US"/>
               <a:t>Second level</a:t>
             </a:r>
           </a:p>
           <a:p>
             <a:pPr lvl="2"/>
             <a:r>
-              <a:rPr lang="en-US" smtClean="0"/>
+              <a:rPr lang="en-US"/>
               <a:t>Third level</a:t>
             </a:r>
           </a:p>
           <a:p>
             <a:pPr lvl="3"/>
             <a:r>
-              <a:rPr lang="en-US" smtClean="0"/>
+              <a:rPr lang="en-US"/>
               <a:t>Fourth level</a:t>
             </a:r>
           </a:p>
           <a:p>
             <a:pPr lvl="4"/>
             <a:r>
-              <a:rPr lang="en-US" smtClean="0"/>
+              <a:rPr lang="en-US"/>
               <a:t>Fifth level</a:t>
             </a:r>
-            <a:endParaRPr lang="en-US"/>
           </a:p>
         </p:txBody>
       </p:sp>
@@ -1312,38 +1317,37 @@
           <a:p>
             <a:pPr lvl="0"/>
             <a:r>
-              <a:rPr lang="en-US" smtClean="0"/>
+              <a:rPr lang="en-US"/>
               <a:t>Click to edit Master text styles</a:t>
             </a:r>
           </a:p>
           <a:p>
             <a:pPr lvl="1"/>
             <a:r>
-              <a:rPr lang="en-US" smtClean="0"/>
+              <a:rPr lang="en-US"/>
               <a:t>Second level</a:t>
             </a:r>
           </a:p>
           <a:p>
             <a:pPr lvl="2"/>
             <a:r>
-              <a:rPr lang="en-US" smtClean="0"/>
+              <a:rPr lang="en-US"/>
               <a:t>Third level</a:t>
             </a:r>
           </a:p>
           <a:p>
             <a:pPr lvl="3"/>
             <a:r>
-              <a:rPr lang="en-US" smtClean="0"/>
+              <a:rPr lang="en-US"/>
               <a:t>Fourth level</a:t>
             </a:r>
           </a:p>
           <a:p>
             <a:pPr lvl="4"/>
             <a:r>
-              <a:rPr lang="en-US" smtClean="0"/>
+              <a:rPr lang="en-US"/>
               <a:t>Fifth level</a:t>
             </a:r>
-            <a:endParaRPr lang="en-US"/>
           </a:p>
         </p:txBody>
       </p:sp>
@@ -1364,7 +1368,7 @@
           <a:p>
             <a:fld id="{5BCAD085-E8A6-8845-BD4E-CB4CCA059FC4}" type="datetimeFigureOut">
               <a:rPr lang="en-US" smtClean="0"/>
-              <a:t>1/27/13</a:t>
+              <a:t>3/2/2026</a:t>
             </a:fld>
             <a:endParaRPr lang="en-US"/>
           </a:p>
@@ -1462,10 +1466,9 @@
           </a:lstStyle>
           <a:p>
             <a:r>
-              <a:rPr lang="en-US" smtClean="0"/>
+              <a:rPr lang="en-US"/>
               <a:t>Click to edit Master title style</a:t>
             </a:r>
-            <a:endParaRPr lang="en-US"/>
           </a:p>
         </p:txBody>
       </p:sp>
@@ -1528,7 +1531,7 @@
           <a:p>
             <a:pPr lvl="0"/>
             <a:r>
-              <a:rPr lang="en-US" smtClean="0"/>
+              <a:rPr lang="en-US"/>
               <a:t>Click to edit Master text styles</a:t>
             </a:r>
           </a:p>
@@ -1584,38 +1587,37 @@
           <a:p>
             <a:pPr lvl="0"/>
             <a:r>
-              <a:rPr lang="en-US" smtClean="0"/>
+              <a:rPr lang="en-US"/>
               <a:t>Click to edit Master text styles</a:t>
             </a:r>
           </a:p>
           <a:p>
             <a:pPr lvl="1"/>
             <a:r>
-              <a:rPr lang="en-US" smtClean="0"/>
+              <a:rPr lang="en-US"/>
               <a:t>Second level</a:t>
             </a:r>
           </a:p>
           <a:p>
             <a:pPr lvl="2"/>
             <a:r>
-              <a:rPr lang="en-US" smtClean="0"/>
+              <a:rPr lang="en-US"/>
               <a:t>Third level</a:t>
             </a:r>
           </a:p>
           <a:p>
             <a:pPr lvl="3"/>
             <a:r>
-              <a:rPr lang="en-US" smtClean="0"/>
+              <a:rPr lang="en-US"/>
               <a:t>Fourth level</a:t>
             </a:r>
           </a:p>
           <a:p>
             <a:pPr lvl="4"/>
             <a:r>
-              <a:rPr lang="en-US" smtClean="0"/>
+              <a:rPr lang="en-US"/>
               <a:t>Fifth level</a:t>
             </a:r>
-            <a:endParaRPr lang="en-US"/>
           </a:p>
         </p:txBody>
       </p:sp>
@@ -1678,7 +1680,7 @@
           <a:p>
             <a:pPr lvl="0"/>
             <a:r>
-              <a:rPr lang="en-US" smtClean="0"/>
+              <a:rPr lang="en-US"/>
               <a:t>Click to edit Master text styles</a:t>
             </a:r>
           </a:p>
@@ -1734,38 +1736,37 @@
           <a:p>
             <a:pPr lvl="0"/>
             <a:r>
-              <a:rPr lang="en-US" smtClean="0"/>
+              <a:rPr lang="en-US"/>
               <a:t>Click to edit Master text styles</a:t>
             </a:r>
           </a:p>
           <a:p>
             <a:pPr lvl="1"/>
             <a:r>
-              <a:rPr lang="en-US" smtClean="0"/>
+              <a:rPr lang="en-US"/>
               <a:t>Second level</a:t>
             </a:r>
           </a:p>
           <a:p>
             <a:pPr lvl="2"/>
             <a:r>
-              <a:rPr lang="en-US" smtClean="0"/>
+              <a:rPr lang="en-US"/>
               <a:t>Third level</a:t>
             </a:r>
           </a:p>
           <a:p>
             <a:pPr lvl="3"/>
             <a:r>
-              <a:rPr lang="en-US" smtClean="0"/>
+              <a:rPr lang="en-US"/>
               <a:t>Fourth level</a:t>
             </a:r>
           </a:p>
           <a:p>
             <a:pPr lvl="4"/>
             <a:r>
-              <a:rPr lang="en-US" smtClean="0"/>
+              <a:rPr lang="en-US"/>
               <a:t>Fifth level</a:t>
             </a:r>
-            <a:endParaRPr lang="en-US"/>
           </a:p>
         </p:txBody>
       </p:sp>
@@ -1786,7 +1787,7 @@
           <a:p>
             <a:fld id="{5BCAD085-E8A6-8845-BD4E-CB4CCA059FC4}" type="datetimeFigureOut">
               <a:rPr lang="en-US" smtClean="0"/>
-              <a:t>1/27/13</a:t>
+              <a:t>3/2/2026</a:t>
             </a:fld>
             <a:endParaRPr lang="en-US"/>
           </a:p>
@@ -1880,10 +1881,9 @@
           <a:lstStyle/>
           <a:p>
             <a:r>
-              <a:rPr lang="en-US" smtClean="0"/>
+              <a:rPr lang="en-US"/>
               <a:t>Click to edit Master title style</a:t>
             </a:r>
-            <a:endParaRPr lang="en-US"/>
           </a:p>
         </p:txBody>
       </p:sp>
@@ -1904,7 +1904,7 @@
           <a:p>
             <a:fld id="{5BCAD085-E8A6-8845-BD4E-CB4CCA059FC4}" type="datetimeFigureOut">
               <a:rPr lang="en-US" smtClean="0"/>
-              <a:t>1/27/13</a:t>
+              <a:t>3/2/2026</a:t>
             </a:fld>
             <a:endParaRPr lang="en-US"/>
           </a:p>
@@ -1999,7 +1999,7 @@
           <a:p>
             <a:fld id="{5BCAD085-E8A6-8845-BD4E-CB4CCA059FC4}" type="datetimeFigureOut">
               <a:rPr lang="en-US" smtClean="0"/>
-              <a:t>1/27/13</a:t>
+              <a:t>3/2/2026</a:t>
             </a:fld>
             <a:endParaRPr lang="en-US"/>
           </a:p>
@@ -2102,10 +2102,9 @@
           </a:lstStyle>
           <a:p>
             <a:r>
-              <a:rPr lang="en-US" smtClean="0"/>
+              <a:rPr lang="en-US"/>
               <a:t>Click to edit Master title style</a:t>
             </a:r>
-            <a:endParaRPr lang="en-US"/>
           </a:p>
         </p:txBody>
       </p:sp>
@@ -2159,38 +2158,37 @@
           <a:p>
             <a:pPr lvl="0"/>
             <a:r>
-              <a:rPr lang="en-US" smtClean="0"/>
+              <a:rPr lang="en-US"/>
               <a:t>Click to edit Master text styles</a:t>
             </a:r>
           </a:p>
           <a:p>
             <a:pPr lvl="1"/>
             <a:r>
-              <a:rPr lang="en-US" smtClean="0"/>
+              <a:rPr lang="en-US"/>
               <a:t>Second level</a:t>
             </a:r>
           </a:p>
           <a:p>
             <a:pPr lvl="2"/>
             <a:r>
-              <a:rPr lang="en-US" smtClean="0"/>
+              <a:rPr lang="en-US"/>
               <a:t>Third level</a:t>
             </a:r>
           </a:p>
           <a:p>
             <a:pPr lvl="3"/>
             <a:r>
-              <a:rPr lang="en-US" smtClean="0"/>
+              <a:rPr lang="en-US"/>
               <a:t>Fourth level</a:t>
             </a:r>
           </a:p>
           <a:p>
             <a:pPr lvl="4"/>
             <a:r>
-              <a:rPr lang="en-US" smtClean="0"/>
+              <a:rPr lang="en-US"/>
               <a:t>Fifth level</a:t>
             </a:r>
-            <a:endParaRPr lang="en-US"/>
           </a:p>
         </p:txBody>
       </p:sp>
@@ -2253,7 +2251,7 @@
           <a:p>
             <a:pPr lvl="0"/>
             <a:r>
-              <a:rPr lang="en-US" smtClean="0"/>
+              <a:rPr lang="en-US"/>
               <a:t>Click to edit Master text styles</a:t>
             </a:r>
           </a:p>
@@ -2276,7 +2274,7 @@
           <a:p>
             <a:fld id="{5BCAD085-E8A6-8845-BD4E-CB4CCA059FC4}" type="datetimeFigureOut">
               <a:rPr lang="en-US" smtClean="0"/>
-              <a:t>1/27/13</a:t>
+              <a:t>3/2/2026</a:t>
             </a:fld>
             <a:endParaRPr lang="en-US"/>
           </a:p>
@@ -2379,10 +2377,9 @@
           </a:lstStyle>
           <a:p>
             <a:r>
-              <a:rPr lang="en-US" smtClean="0"/>
+              <a:rPr lang="en-US"/>
               <a:t>Click to edit Master title style</a:t>
             </a:r>
-            <a:endParaRPr lang="en-US"/>
           </a:p>
         </p:txBody>
       </p:sp>
@@ -2506,7 +2503,7 @@
           <a:p>
             <a:pPr lvl="0"/>
             <a:r>
-              <a:rPr lang="en-US" smtClean="0"/>
+              <a:rPr lang="en-US"/>
               <a:t>Click to edit Master text styles</a:t>
             </a:r>
           </a:p>
@@ -2529,7 +2526,7 @@
           <a:p>
             <a:fld id="{5BCAD085-E8A6-8845-BD4E-CB4CCA059FC4}" type="datetimeFigureOut">
               <a:rPr lang="en-US" smtClean="0"/>
-              <a:t>1/27/13</a:t>
+              <a:t>3/2/2026</a:t>
             </a:fld>
             <a:endParaRPr lang="en-US"/>
           </a:p>
@@ -2638,10 +2635,9 @@
           <a:lstStyle/>
           <a:p>
             <a:r>
-              <a:rPr lang="en-US" smtClean="0"/>
+              <a:rPr lang="en-US"/>
               <a:t>Click to edit Master title style</a:t>
             </a:r>
-            <a:endParaRPr lang="en-US"/>
           </a:p>
         </p:txBody>
       </p:sp>
@@ -2672,38 +2668,37 @@
           <a:p>
             <a:pPr lvl="0"/>
             <a:r>
-              <a:rPr lang="en-US" smtClean="0"/>
+              <a:rPr lang="en-US"/>
               <a:t>Click to edit Master text styles</a:t>
             </a:r>
           </a:p>
           <a:p>
             <a:pPr lvl="1"/>
             <a:r>
-              <a:rPr lang="en-US" smtClean="0"/>
+              <a:rPr lang="en-US"/>
               <a:t>Second level</a:t>
             </a:r>
           </a:p>
           <a:p>
             <a:pPr lvl="2"/>
             <a:r>
-              <a:rPr lang="en-US" smtClean="0"/>
+              <a:rPr lang="en-US"/>
               <a:t>Third level</a:t>
             </a:r>
           </a:p>
           <a:p>
             <a:pPr lvl="3"/>
             <a:r>
-              <a:rPr lang="en-US" smtClean="0"/>
+              <a:rPr lang="en-US"/>
               <a:t>Fourth level</a:t>
             </a:r>
           </a:p>
           <a:p>
             <a:pPr lvl="4"/>
             <a:r>
-              <a:rPr lang="en-US" smtClean="0"/>
+              <a:rPr lang="en-US"/>
               <a:t>Fifth level</a:t>
             </a:r>
-            <a:endParaRPr lang="en-US"/>
           </a:p>
         </p:txBody>
       </p:sp>
@@ -2742,7 +2737,7 @@
           <a:p>
             <a:fld id="{5BCAD085-E8A6-8845-BD4E-CB4CCA059FC4}" type="datetimeFigureOut">
               <a:rPr lang="en-US" smtClean="0"/>
-              <a:t>1/27/13</a:t>
+              <a:t>3/2/2026</a:t>
             </a:fld>
             <a:endParaRPr lang="en-US"/>
           </a:p>
@@ -3101,7 +3096,7 @@
 </file>
 
 <file path=ppt/slides/slide1.xml><?xml version="1.0" encoding="utf-8"?>
-<p:sld xmlns:a="http://schemas.openxmlformats.org/drawingml/2006/main" xmlns:p="http://schemas.openxmlformats.org/presentationml/2006/main" xmlns:r="http://schemas.openxmlformats.org/officeDocument/2006/relationships">
+<p:sld xmlns:a="http://schemas.openxmlformats.org/drawingml/2006/main" xmlns:r="http://schemas.openxmlformats.org/officeDocument/2006/relationships" xmlns:p="http://schemas.openxmlformats.org/presentationml/2006/main">
   <p:cSld>
     <p:bg>
       <p:bgPr>
@@ -3117,7 +3112,14 @@
         <p:cNvGrpSpPr/>
         <p:nvPr/>
       </p:nvGrpSpPr>
-      <p:grpSpPr/>
+      <p:grpSpPr>
+        <a:xfrm>
+          <a:off x="0" y="0"/>
+          <a:ext cx="0" cy="0"/>
+          <a:chOff x="0" y="0"/>
+          <a:chExt cx="0" cy="0"/>
+        </a:xfrm>
+      </p:grpSpPr>
       <p:sp>
         <p:nvSpPr>
           <p:cNvPr id="2" name="TextBox 1"/>
@@ -3183,7 +3185,7 @@
                 </a:solidFill>
                 <a:latin typeface="游ゴシック"/>
               </a:rPr>
-              <a:t>M5Stack Core2 × MAX31855  熱電対温度計測システム</a:t>
+              <a:t>M5Stack Basic V2.7 × MAX31855  熱電対温度計測システム</a:t>
             </a:r>
           </a:p>
         </p:txBody>
@@ -3228,6 +3230,7 @@
           <a:lstStyle/>
           <a:p>
             <a:pPr algn="ctr"/>
+            <a:endParaRPr/>
           </a:p>
         </p:txBody>
       </p:sp>
@@ -3345,7 +3348,7 @@
 </file>
 
 <file path=ppt/slides/slide10.xml><?xml version="1.0" encoding="utf-8"?>
-<p:sld xmlns:a="http://schemas.openxmlformats.org/drawingml/2006/main" xmlns:p="http://schemas.openxmlformats.org/presentationml/2006/main" xmlns:r="http://schemas.openxmlformats.org/officeDocument/2006/relationships">
+<p:sld xmlns:a="http://schemas.openxmlformats.org/drawingml/2006/main" xmlns:r="http://schemas.openxmlformats.org/officeDocument/2006/relationships" xmlns:p="http://schemas.openxmlformats.org/presentationml/2006/main">
   <p:cSld>
     <p:spTree>
       <p:nvGrpSpPr>
@@ -3353,7 +3356,14 @@
         <p:cNvGrpSpPr/>
         <p:nvPr/>
       </p:nvGrpSpPr>
-      <p:grpSpPr/>
+      <p:grpSpPr>
+        <a:xfrm>
+          <a:off x="0" y="0"/>
+          <a:ext cx="0" cy="0"/>
+          <a:chOff x="0" y="0"/>
+          <a:chExt cx="0" cy="0"/>
+        </a:xfrm>
+      </p:grpSpPr>
       <p:sp>
         <p:nvSpPr>
           <p:cNvPr id="2" name="Rectangle 1"/>
@@ -3394,6 +3404,7 @@
           <a:lstStyle/>
           <a:p>
             <a:pPr algn="ctr"/>
+            <a:endParaRPr/>
           </a:p>
         </p:txBody>
       </p:sp>
@@ -3507,6 +3518,7 @@
           <a:lstStyle/>
           <a:p>
             <a:pPr algn="ctr"/>
+            <a:endParaRPr/>
           </a:p>
         </p:txBody>
       </p:sp>
@@ -3634,10 +3646,34 @@
                 <a:tableStyleId>{5C22544A-7EE6-4342-B048-85BDC9FD1C3A}</a:tableStyleId>
               </a:tblPr>
               <a:tblGrid>
-                <a:gridCol w="1828800"/>
-                <a:gridCol w="3108960"/>
-                <a:gridCol w="3108960"/>
-                <a:gridCol w="3474720"/>
+                <a:gridCol w="1828800">
+                  <a:extLst>
+                    <a:ext uri="{9D8B030D-6E8A-4147-A177-3AD203B41FA5}">
+                      <a16:colId xmlns:a16="http://schemas.microsoft.com/office/drawing/2014/main" val="20000"/>
+                    </a:ext>
+                  </a:extLst>
+                </a:gridCol>
+                <a:gridCol w="3108960">
+                  <a:extLst>
+                    <a:ext uri="{9D8B030D-6E8A-4147-A177-3AD203B41FA5}">
+                      <a16:colId xmlns:a16="http://schemas.microsoft.com/office/drawing/2014/main" val="20001"/>
+                    </a:ext>
+                  </a:extLst>
+                </a:gridCol>
+                <a:gridCol w="3108960">
+                  <a:extLst>
+                    <a:ext uri="{9D8B030D-6E8A-4147-A177-3AD203B41FA5}">
+                      <a16:colId xmlns:a16="http://schemas.microsoft.com/office/drawing/2014/main" val="20002"/>
+                    </a:ext>
+                  </a:extLst>
+                </a:gridCol>
+                <a:gridCol w="3474720">
+                  <a:extLst>
+                    <a:ext uri="{9D8B030D-6E8A-4147-A177-3AD203B41FA5}">
+                      <a16:colId xmlns:a16="http://schemas.microsoft.com/office/drawing/2014/main" val="20003"/>
+                    </a:ext>
+                  </a:extLst>
+                </a:gridCol>
               </a:tblGrid>
               <a:tr h="420624">
                 <a:tc>
@@ -3732,6 +3768,11 @@
                     </a:solidFill>
                   </a:tcPr>
                 </a:tc>
+                <a:extLst>
+                  <a:ext uri="{0D108BD9-81ED-4DB2-BD59-A6C34878D82A}">
+                    <a16:rowId xmlns:a16="http://schemas.microsoft.com/office/drawing/2014/main" val="10000"/>
+                  </a:ext>
+                </a:extLst>
               </a:tr>
               <a:tr h="420624">
                 <a:tc>
@@ -3826,6 +3867,11 @@
                     </a:solidFill>
                   </a:tcPr>
                 </a:tc>
+                <a:extLst>
+                  <a:ext uri="{0D108BD9-81ED-4DB2-BD59-A6C34878D82A}">
+                    <a16:rowId xmlns:a16="http://schemas.microsoft.com/office/drawing/2014/main" val="10001"/>
+                  </a:ext>
+                </a:extLst>
               </a:tr>
               <a:tr h="420624">
                 <a:tc>
@@ -3920,6 +3966,11 @@
                     </a:solidFill>
                   </a:tcPr>
                 </a:tc>
+                <a:extLst>
+                  <a:ext uri="{0D108BD9-81ED-4DB2-BD59-A6C34878D82A}">
+                    <a16:rowId xmlns:a16="http://schemas.microsoft.com/office/drawing/2014/main" val="10002"/>
+                  </a:ext>
+                </a:extLst>
               </a:tr>
               <a:tr h="420624">
                 <a:tc>
@@ -4014,6 +4065,11 @@
                     </a:solidFill>
                   </a:tcPr>
                 </a:tc>
+                <a:extLst>
+                  <a:ext uri="{0D108BD9-81ED-4DB2-BD59-A6C34878D82A}">
+                    <a16:rowId xmlns:a16="http://schemas.microsoft.com/office/drawing/2014/main" val="10003"/>
+                  </a:ext>
+                </a:extLst>
               </a:tr>
               <a:tr h="420624">
                 <a:tc>
@@ -4108,6 +4164,11 @@
                     </a:solidFill>
                   </a:tcPr>
                 </a:tc>
+                <a:extLst>
+                  <a:ext uri="{0D108BD9-81ED-4DB2-BD59-A6C34878D82A}">
+                    <a16:rowId xmlns:a16="http://schemas.microsoft.com/office/drawing/2014/main" val="10004"/>
+                  </a:ext>
+                </a:extLst>
               </a:tr>
               <a:tr h="420624">
                 <a:tc>
@@ -4202,6 +4263,11 @@
                     </a:solidFill>
                   </a:tcPr>
                 </a:tc>
+                <a:extLst>
+                  <a:ext uri="{0D108BD9-81ED-4DB2-BD59-A6C34878D82A}">
+                    <a16:rowId xmlns:a16="http://schemas.microsoft.com/office/drawing/2014/main" val="10005"/>
+                  </a:ext>
+                </a:extLst>
               </a:tr>
             </a:tbl>
           </a:graphicData>
@@ -4251,7 +4317,7 @@
 </file>
 
 <file path=ppt/slides/slide11.xml><?xml version="1.0" encoding="utf-8"?>
-<p:sld xmlns:a="http://schemas.openxmlformats.org/drawingml/2006/main" xmlns:p="http://schemas.openxmlformats.org/presentationml/2006/main" xmlns:r="http://schemas.openxmlformats.org/officeDocument/2006/relationships">
+<p:sld xmlns:a="http://schemas.openxmlformats.org/drawingml/2006/main" xmlns:r="http://schemas.openxmlformats.org/officeDocument/2006/relationships" xmlns:p="http://schemas.openxmlformats.org/presentationml/2006/main">
   <p:cSld>
     <p:spTree>
       <p:nvGrpSpPr>
@@ -4259,7 +4325,14 @@
         <p:cNvGrpSpPr/>
         <p:nvPr/>
       </p:nvGrpSpPr>
-      <p:grpSpPr/>
+      <p:grpSpPr>
+        <a:xfrm>
+          <a:off x="0" y="0"/>
+          <a:ext cx="0" cy="0"/>
+          <a:chOff x="0" y="0"/>
+          <a:chExt cx="0" cy="0"/>
+        </a:xfrm>
+      </p:grpSpPr>
       <p:sp>
         <p:nvSpPr>
           <p:cNvPr id="2" name="Rectangle 1"/>
@@ -4300,6 +4373,7 @@
           <a:lstStyle/>
           <a:p>
             <a:pPr algn="ctr"/>
+            <a:endParaRPr/>
           </a:p>
         </p:txBody>
       </p:sp>
@@ -4413,6 +4487,7 @@
           <a:lstStyle/>
           <a:p>
             <a:pPr algn="ctr"/>
+            <a:endParaRPr/>
           </a:p>
         </p:txBody>
       </p:sp>
@@ -4528,6 +4603,7 @@
           <a:lstStyle/>
           <a:p>
             <a:pPr algn="ctr"/>
+            <a:endParaRPr/>
           </a:p>
         </p:txBody>
       </p:sp>
@@ -4564,6 +4640,14 @@
             </a:r>
           </a:p>
           <a:p>
+            <a:endParaRPr sz="1300">
+              <a:solidFill>
+                <a:srgbClr val="FFFFFF"/>
+              </a:solidFill>
+              <a:latin typeface="Consolas"/>
+            </a:endParaRPr>
+          </a:p>
+          <a:p>
             <a:r>
               <a:rPr sz="1300">
                 <a:solidFill>
@@ -4571,7 +4655,7 @@
                 </a:solidFill>
                 <a:latin typeface="Consolas"/>
               </a:rPr>
-              <a:t/>
+              <a:t>Temp:</a:t>
             </a:r>
           </a:p>
           <a:p>
@@ -4582,8 +4666,16 @@
                 </a:solidFill>
                 <a:latin typeface="Consolas"/>
               </a:rPr>
-              <a:t>Temp:</a:t>
-            </a:r>
+              <a:t>  25.3  C</a:t>
+            </a:r>
+          </a:p>
+          <a:p>
+            <a:endParaRPr sz="1300">
+              <a:solidFill>
+                <a:srgbClr val="FFFFFF"/>
+              </a:solidFill>
+              <a:latin typeface="Consolas"/>
+            </a:endParaRPr>
           </a:p>
           <a:p>
             <a:r>
@@ -4593,41 +4685,16 @@
                 </a:solidFill>
                 <a:latin typeface="Consolas"/>
               </a:rPr>
-              <a:t>  25.3  C</a:t>
-            </a:r>
-          </a:p>
-          <a:p>
-            <a:r>
-              <a:rPr sz="1300">
-                <a:solidFill>
-                  <a:srgbClr val="FFFFFF"/>
-                </a:solidFill>
-                <a:latin typeface="Consolas"/>
-              </a:rPr>
-              <a:t/>
-            </a:r>
-          </a:p>
-          <a:p>
-            <a:r>
-              <a:rPr sz="1300">
-                <a:solidFill>
-                  <a:srgbClr val="FFFFFF"/>
-                </a:solidFill>
-                <a:latin typeface="Consolas"/>
-              </a:rPr>
               <a:t>SD Ready</a:t>
             </a:r>
           </a:p>
           <a:p>
-            <a:r>
-              <a:rPr sz="1300">
-                <a:solidFill>
-                  <a:srgbClr val="FFFFFF"/>
-                </a:solidFill>
-                <a:latin typeface="Consolas"/>
-              </a:rPr>
-              <a:t/>
-            </a:r>
+            <a:endParaRPr sz="1300">
+              <a:solidFill>
+                <a:srgbClr val="FFFFFF"/>
+              </a:solidFill>
+              <a:latin typeface="Consolas"/>
+            </a:endParaRPr>
           </a:p>
           <a:p>
             <a:r>
@@ -4687,7 +4754,7 @@
         </p:nvGraphicFramePr>
         <p:xfrm>
           <a:off x="6217920" y="1600200"/>
-          <a:ext cx="5577840" cy="3008376"/>
+          <a:ext cx="5577840" cy="3035808"/>
         </p:xfrm>
         <a:graphic>
           <a:graphicData uri="http://schemas.openxmlformats.org/drawingml/2006/table">
@@ -4696,8 +4763,20 @@
                 <a:tableStyleId>{5C22544A-7EE6-4342-B048-85BDC9FD1C3A}</a:tableStyleId>
               </a:tblPr>
               <a:tblGrid>
-                <a:gridCol w="2011680"/>
-                <a:gridCol w="3566160"/>
+                <a:gridCol w="2011680">
+                  <a:extLst>
+                    <a:ext uri="{9D8B030D-6E8A-4147-A177-3AD203B41FA5}">
+                      <a16:colId xmlns:a16="http://schemas.microsoft.com/office/drawing/2014/main" val="20000"/>
+                    </a:ext>
+                  </a:extLst>
+                </a:gridCol>
+                <a:gridCol w="3566160">
+                  <a:extLst>
+                    <a:ext uri="{9D8B030D-6E8A-4147-A177-3AD203B41FA5}">
+                      <a16:colId xmlns:a16="http://schemas.microsoft.com/office/drawing/2014/main" val="20001"/>
+                    </a:ext>
+                  </a:extLst>
+                </a:gridCol>
               </a:tblGrid>
               <a:tr h="429768">
                 <a:tc>
@@ -4746,6 +4825,11 @@
                     </a:solidFill>
                   </a:tcPr>
                 </a:tc>
+                <a:extLst>
+                  <a:ext uri="{0D108BD9-81ED-4DB2-BD59-A6C34878D82A}">
+                    <a16:rowId xmlns:a16="http://schemas.microsoft.com/office/drawing/2014/main" val="10000"/>
+                  </a:ext>
+                </a:extLst>
               </a:tr>
               <a:tr h="429768">
                 <a:tc>
@@ -4794,6 +4878,11 @@
                     </a:solidFill>
                   </a:tcPr>
                 </a:tc>
+                <a:extLst>
+                  <a:ext uri="{0D108BD9-81ED-4DB2-BD59-A6C34878D82A}">
+                    <a16:rowId xmlns:a16="http://schemas.microsoft.com/office/drawing/2014/main" val="10001"/>
+                  </a:ext>
+                </a:extLst>
               </a:tr>
               <a:tr h="429768">
                 <a:tc>
@@ -4842,6 +4931,11 @@
                     </a:solidFill>
                   </a:tcPr>
                 </a:tc>
+                <a:extLst>
+                  <a:ext uri="{0D108BD9-81ED-4DB2-BD59-A6C34878D82A}">
+                    <a16:rowId xmlns:a16="http://schemas.microsoft.com/office/drawing/2014/main" val="10002"/>
+                  </a:ext>
+                </a:extLst>
               </a:tr>
               <a:tr h="429768">
                 <a:tc>
@@ -4890,6 +4984,11 @@
                     </a:solidFill>
                   </a:tcPr>
                 </a:tc>
+                <a:extLst>
+                  <a:ext uri="{0D108BD9-81ED-4DB2-BD59-A6C34878D82A}">
+                    <a16:rowId xmlns:a16="http://schemas.microsoft.com/office/drawing/2014/main" val="10003"/>
+                  </a:ext>
+                </a:extLst>
               </a:tr>
               <a:tr h="429768">
                 <a:tc>
@@ -4938,6 +5037,11 @@
                     </a:solidFill>
                   </a:tcPr>
                 </a:tc>
+                <a:extLst>
+                  <a:ext uri="{0D108BD9-81ED-4DB2-BD59-A6C34878D82A}">
+                    <a16:rowId xmlns:a16="http://schemas.microsoft.com/office/drawing/2014/main" val="10004"/>
+                  </a:ext>
+                </a:extLst>
               </a:tr>
               <a:tr h="429768">
                 <a:tc>
@@ -4986,6 +5090,11 @@
                     </a:solidFill>
                   </a:tcPr>
                 </a:tc>
+                <a:extLst>
+                  <a:ext uri="{0D108BD9-81ED-4DB2-BD59-A6C34878D82A}">
+                    <a16:rowId xmlns:a16="http://schemas.microsoft.com/office/drawing/2014/main" val="10005"/>
+                  </a:ext>
+                </a:extLst>
               </a:tr>
               <a:tr h="429768">
                 <a:tc>
@@ -5034,6 +5143,11 @@
                     </a:solidFill>
                   </a:tcPr>
                 </a:tc>
+                <a:extLst>
+                  <a:ext uri="{0D108BD9-81ED-4DB2-BD59-A6C34878D82A}">
+                    <a16:rowId xmlns:a16="http://schemas.microsoft.com/office/drawing/2014/main" val="10006"/>
+                  </a:ext>
+                </a:extLst>
               </a:tr>
             </a:tbl>
           </a:graphicData>
@@ -5048,7 +5162,7 @@
 </file>
 
 <file path=ppt/slides/slide12.xml><?xml version="1.0" encoding="utf-8"?>
-<p:sld xmlns:a="http://schemas.openxmlformats.org/drawingml/2006/main" xmlns:p="http://schemas.openxmlformats.org/presentationml/2006/main" xmlns:r="http://schemas.openxmlformats.org/officeDocument/2006/relationships">
+<p:sld xmlns:a="http://schemas.openxmlformats.org/drawingml/2006/main" xmlns:r="http://schemas.openxmlformats.org/officeDocument/2006/relationships" xmlns:p="http://schemas.openxmlformats.org/presentationml/2006/main">
   <p:cSld>
     <p:spTree>
       <p:nvGrpSpPr>
@@ -5056,7 +5170,14 @@
         <p:cNvGrpSpPr/>
         <p:nvPr/>
       </p:nvGrpSpPr>
-      <p:grpSpPr/>
+      <p:grpSpPr>
+        <a:xfrm>
+          <a:off x="0" y="0"/>
+          <a:ext cx="0" cy="0"/>
+          <a:chOff x="0" y="0"/>
+          <a:chExt cx="0" cy="0"/>
+        </a:xfrm>
+      </p:grpSpPr>
       <p:sp>
         <p:nvSpPr>
           <p:cNvPr id="2" name="Rectangle 1"/>
@@ -5097,6 +5218,7 @@
           <a:lstStyle/>
           <a:p>
             <a:pPr algn="ctr"/>
+            <a:endParaRPr/>
           </a:p>
         </p:txBody>
       </p:sp>
@@ -5210,6 +5332,7 @@
           <a:lstStyle/>
           <a:p>
             <a:pPr algn="ctr"/>
+            <a:endParaRPr/>
           </a:p>
         </p:txBody>
       </p:sp>
@@ -5325,6 +5448,7 @@
           <a:lstStyle/>
           <a:p>
             <a:pPr algn="ctr"/>
+            <a:endParaRPr/>
           </a:p>
         </p:txBody>
       </p:sp>
@@ -5361,6 +5485,14 @@
             </a:r>
           </a:p>
           <a:p>
+            <a:endParaRPr sz="1300">
+              <a:solidFill>
+                <a:srgbClr val="FFFFFF"/>
+              </a:solidFill>
+              <a:latin typeface="Consolas"/>
+            </a:endParaRPr>
+          </a:p>
+          <a:p>
             <a:r>
               <a:rPr sz="1300">
                 <a:solidFill>
@@ -5368,7 +5500,7 @@
                 </a:solidFill>
                 <a:latin typeface="Consolas"/>
               </a:rPr>
-              <a:t/>
+              <a:t>Temp:</a:t>
             </a:r>
           </a:p>
           <a:p>
@@ -5379,8 +5511,16 @@
                 </a:solidFill>
                 <a:latin typeface="Consolas"/>
               </a:rPr>
-              <a:t>Temp:</a:t>
-            </a:r>
+              <a:t>  540.2  C</a:t>
+            </a:r>
+          </a:p>
+          <a:p>
+            <a:endParaRPr sz="1300">
+              <a:solidFill>
+                <a:srgbClr val="FFFFFF"/>
+              </a:solidFill>
+              <a:latin typeface="Consolas"/>
+            </a:endParaRPr>
           </a:p>
           <a:p>
             <a:r>
@@ -5390,7 +5530,7 @@
                 </a:solidFill>
                 <a:latin typeface="Consolas"/>
               </a:rPr>
-              <a:t>  540.2  C</a:t>
+              <a:t>Samples:   142</a:t>
             </a:r>
           </a:p>
           <a:p>
@@ -5401,41 +5541,16 @@
                 </a:solidFill>
                 <a:latin typeface="Consolas"/>
               </a:rPr>
-              <a:t/>
-            </a:r>
-          </a:p>
-          <a:p>
-            <a:r>
-              <a:rPr sz="1300">
-                <a:solidFill>
-                  <a:srgbClr val="FFFFFF"/>
-                </a:solidFill>
-                <a:latin typeface="Consolas"/>
-              </a:rPr>
-              <a:t>Samples:   142</a:t>
-            </a:r>
-          </a:p>
-          <a:p>
-            <a:r>
-              <a:rPr sz="1300">
-                <a:solidFill>
-                  <a:srgbClr val="FFFFFF"/>
-                </a:solidFill>
-                <a:latin typeface="Consolas"/>
-              </a:rPr>
               <a:t>SD: /DATA_0000.csv</a:t>
             </a:r>
           </a:p>
           <a:p>
-            <a:r>
-              <a:rPr sz="1300">
-                <a:solidFill>
-                  <a:srgbClr val="FFFFFF"/>
-                </a:solidFill>
-                <a:latin typeface="Consolas"/>
-              </a:rPr>
-              <a:t/>
-            </a:r>
+            <a:endParaRPr sz="1300">
+              <a:solidFill>
+                <a:srgbClr val="FFFFFF"/>
+              </a:solidFill>
+              <a:latin typeface="Consolas"/>
+            </a:endParaRPr>
           </a:p>
           <a:p>
             <a:r>
@@ -5495,7 +5610,7 @@
         </p:nvGraphicFramePr>
         <p:xfrm>
           <a:off x="6217920" y="1600200"/>
-          <a:ext cx="5577840" cy="3008376"/>
+          <a:ext cx="5577840" cy="3090672"/>
         </p:xfrm>
         <a:graphic>
           <a:graphicData uri="http://schemas.openxmlformats.org/drawingml/2006/table">
@@ -5504,8 +5619,20 @@
                 <a:tableStyleId>{5C22544A-7EE6-4342-B048-85BDC9FD1C3A}</a:tableStyleId>
               </a:tblPr>
               <a:tblGrid>
-                <a:gridCol w="2286000"/>
-                <a:gridCol w="3291840"/>
+                <a:gridCol w="2286000">
+                  <a:extLst>
+                    <a:ext uri="{9D8B030D-6E8A-4147-A177-3AD203B41FA5}">
+                      <a16:colId xmlns:a16="http://schemas.microsoft.com/office/drawing/2014/main" val="20000"/>
+                    </a:ext>
+                  </a:extLst>
+                </a:gridCol>
+                <a:gridCol w="3291840">
+                  <a:extLst>
+                    <a:ext uri="{9D8B030D-6E8A-4147-A177-3AD203B41FA5}">
+                      <a16:colId xmlns:a16="http://schemas.microsoft.com/office/drawing/2014/main" val="20001"/>
+                    </a:ext>
+                  </a:extLst>
+                </a:gridCol>
               </a:tblGrid>
               <a:tr h="429768">
                 <a:tc>
@@ -5554,6 +5681,11 @@
                     </a:solidFill>
                   </a:tcPr>
                 </a:tc>
+                <a:extLst>
+                  <a:ext uri="{0D108BD9-81ED-4DB2-BD59-A6C34878D82A}">
+                    <a16:rowId xmlns:a16="http://schemas.microsoft.com/office/drawing/2014/main" val="10000"/>
+                  </a:ext>
+                </a:extLst>
               </a:tr>
               <a:tr h="429768">
                 <a:tc>
@@ -5602,6 +5734,11 @@
                     </a:solidFill>
                   </a:tcPr>
                 </a:tc>
+                <a:extLst>
+                  <a:ext uri="{0D108BD9-81ED-4DB2-BD59-A6C34878D82A}">
+                    <a16:rowId xmlns:a16="http://schemas.microsoft.com/office/drawing/2014/main" val="10001"/>
+                  </a:ext>
+                </a:extLst>
               </a:tr>
               <a:tr h="429768">
                 <a:tc>
@@ -5650,6 +5787,11 @@
                     </a:solidFill>
                   </a:tcPr>
                 </a:tc>
+                <a:extLst>
+                  <a:ext uri="{0D108BD9-81ED-4DB2-BD59-A6C34878D82A}">
+                    <a16:rowId xmlns:a16="http://schemas.microsoft.com/office/drawing/2014/main" val="10002"/>
+                  </a:ext>
+                </a:extLst>
               </a:tr>
               <a:tr h="429768">
                 <a:tc>
@@ -5698,6 +5840,11 @@
                     </a:solidFill>
                   </a:tcPr>
                 </a:tc>
+                <a:extLst>
+                  <a:ext uri="{0D108BD9-81ED-4DB2-BD59-A6C34878D82A}">
+                    <a16:rowId xmlns:a16="http://schemas.microsoft.com/office/drawing/2014/main" val="10003"/>
+                  </a:ext>
+                </a:extLst>
               </a:tr>
               <a:tr h="429768">
                 <a:tc>
@@ -5746,6 +5893,11 @@
                     </a:solidFill>
                   </a:tcPr>
                 </a:tc>
+                <a:extLst>
+                  <a:ext uri="{0D108BD9-81ED-4DB2-BD59-A6C34878D82A}">
+                    <a16:rowId xmlns:a16="http://schemas.microsoft.com/office/drawing/2014/main" val="10004"/>
+                  </a:ext>
+                </a:extLst>
               </a:tr>
               <a:tr h="429768">
                 <a:tc>
@@ -5794,6 +5946,11 @@
                     </a:solidFill>
                   </a:tcPr>
                 </a:tc>
+                <a:extLst>
+                  <a:ext uri="{0D108BD9-81ED-4DB2-BD59-A6C34878D82A}">
+                    <a16:rowId xmlns:a16="http://schemas.microsoft.com/office/drawing/2014/main" val="10005"/>
+                  </a:ext>
+                </a:extLst>
               </a:tr>
               <a:tr h="429768">
                 <a:tc>
@@ -5842,6 +5999,11 @@
                     </a:solidFill>
                   </a:tcPr>
                 </a:tc>
+                <a:extLst>
+                  <a:ext uri="{0D108BD9-81ED-4DB2-BD59-A6C34878D82A}">
+                    <a16:rowId xmlns:a16="http://schemas.microsoft.com/office/drawing/2014/main" val="10006"/>
+                  </a:ext>
+                </a:extLst>
               </a:tr>
             </a:tbl>
           </a:graphicData>
@@ -5856,7 +6018,7 @@
 </file>
 
 <file path=ppt/slides/slide13.xml><?xml version="1.0" encoding="utf-8"?>
-<p:sld xmlns:a="http://schemas.openxmlformats.org/drawingml/2006/main" xmlns:p="http://schemas.openxmlformats.org/presentationml/2006/main" xmlns:r="http://schemas.openxmlformats.org/officeDocument/2006/relationships">
+<p:sld xmlns:a="http://schemas.openxmlformats.org/drawingml/2006/main" xmlns:r="http://schemas.openxmlformats.org/officeDocument/2006/relationships" xmlns:p="http://schemas.openxmlformats.org/presentationml/2006/main">
   <p:cSld>
     <p:spTree>
       <p:nvGrpSpPr>
@@ -5864,7 +6026,14 @@
         <p:cNvGrpSpPr/>
         <p:nvPr/>
       </p:nvGrpSpPr>
-      <p:grpSpPr/>
+      <p:grpSpPr>
+        <a:xfrm>
+          <a:off x="0" y="0"/>
+          <a:ext cx="0" cy="0"/>
+          <a:chOff x="0" y="0"/>
+          <a:chExt cx="0" cy="0"/>
+        </a:xfrm>
+      </p:grpSpPr>
       <p:sp>
         <p:nvSpPr>
           <p:cNvPr id="2" name="Rectangle 1"/>
@@ -5905,6 +6074,7 @@
           <a:lstStyle/>
           <a:p>
             <a:pPr algn="ctr"/>
+            <a:endParaRPr/>
           </a:p>
         </p:txBody>
       </p:sp>
@@ -6018,6 +6188,7 @@
           <a:lstStyle/>
           <a:p>
             <a:pPr algn="ctr"/>
+            <a:endParaRPr/>
           </a:p>
         </p:txBody>
       </p:sp>
@@ -6133,6 +6304,7 @@
           <a:lstStyle/>
           <a:p>
             <a:pPr algn="ctr"/>
+            <a:endParaRPr/>
           </a:p>
         </p:txBody>
       </p:sp>
@@ -6169,6 +6341,14 @@
             </a:r>
           </a:p>
           <a:p>
+            <a:endParaRPr sz="1300">
+              <a:solidFill>
+                <a:srgbClr val="FFFFFF"/>
+              </a:solidFill>
+              <a:latin typeface="Consolas"/>
+            </a:endParaRPr>
+          </a:p>
+          <a:p>
             <a:r>
               <a:rPr sz="1300">
                 <a:solidFill>
@@ -6176,7 +6356,7 @@
                 </a:solidFill>
                 <a:latin typeface="Consolas"/>
               </a:rPr>
-              <a:t/>
+              <a:t>Temp:</a:t>
             </a:r>
           </a:p>
           <a:p>
@@ -6187,8 +6367,16 @@
                 </a:solidFill>
                 <a:latin typeface="Consolas"/>
               </a:rPr>
-              <a:t>Temp:</a:t>
-            </a:r>
+              <a:t>  540.2  C</a:t>
+            </a:r>
+          </a:p>
+          <a:p>
+            <a:endParaRPr sz="1300">
+              <a:solidFill>
+                <a:srgbClr val="FFFFFF"/>
+              </a:solidFill>
+              <a:latin typeface="Consolas"/>
+            </a:endParaRPr>
           </a:p>
           <a:p>
             <a:r>
@@ -6198,7 +6386,7 @@
                 </a:solidFill>
                 <a:latin typeface="Consolas"/>
               </a:rPr>
-              <a:t>  540.2  C</a:t>
+              <a:t>Avg:</a:t>
             </a:r>
           </a:p>
           <a:p>
@@ -6209,41 +6397,16 @@
                 </a:solidFill>
                 <a:latin typeface="Consolas"/>
               </a:rPr>
-              <a:t/>
-            </a:r>
-          </a:p>
-          <a:p>
-            <a:r>
-              <a:rPr sz="1300">
-                <a:solidFill>
-                  <a:srgbClr val="FFFFFF"/>
-                </a:solidFill>
-                <a:latin typeface="Consolas"/>
-              </a:rPr>
-              <a:t>Avg:</a:t>
-            </a:r>
-          </a:p>
-          <a:p>
-            <a:r>
-              <a:rPr sz="1300">
-                <a:solidFill>
-                  <a:srgbClr val="FFFFFF"/>
-                </a:solidFill>
-                <a:latin typeface="Consolas"/>
-              </a:rPr>
               <a:t>  539.8  C</a:t>
             </a:r>
           </a:p>
           <a:p>
-            <a:r>
-              <a:rPr sz="1300">
-                <a:solidFill>
-                  <a:srgbClr val="FFFFFF"/>
-                </a:solidFill>
-                <a:latin typeface="Consolas"/>
-              </a:rPr>
-              <a:t/>
-            </a:r>
+            <a:endParaRPr sz="1300">
+              <a:solidFill>
+                <a:srgbClr val="FFFFFF"/>
+              </a:solidFill>
+              <a:latin typeface="Consolas"/>
+            </a:endParaRPr>
           </a:p>
           <a:p>
             <a:r>
@@ -6335,6 +6498,7 @@
           <a:lstStyle/>
           <a:p>
             <a:pPr algn="ctr"/>
+            <a:endParaRPr/>
           </a:p>
         </p:txBody>
       </p:sp>
@@ -6371,6 +6535,14 @@
             </a:r>
           </a:p>
           <a:p>
+            <a:endParaRPr sz="1300">
+              <a:solidFill>
+                <a:srgbClr val="FFFFFF"/>
+              </a:solidFill>
+              <a:latin typeface="Consolas"/>
+            </a:endParaRPr>
+          </a:p>
+          <a:p>
             <a:r>
               <a:rPr sz="1300">
                 <a:solidFill>
@@ -6378,7 +6550,7 @@
                 </a:solidFill>
                 <a:latin typeface="Consolas"/>
               </a:rPr>
-              <a:t/>
+              <a:t>StdDev:</a:t>
             </a:r>
           </a:p>
           <a:p>
@@ -6389,7 +6561,7 @@
                 </a:solidFill>
                 <a:latin typeface="Consolas"/>
               </a:rPr>
-              <a:t>StdDev:</a:t>
+              <a:t>   0.8  C</a:t>
             </a:r>
           </a:p>
           <a:p>
@@ -6400,7 +6572,7 @@
                 </a:solidFill>
                 <a:latin typeface="Consolas"/>
               </a:rPr>
-              <a:t>   0.8  C</a:t>
+              <a:t>Range:   10.0  C</a:t>
             </a:r>
           </a:p>
           <a:p>
@@ -6411,7 +6583,7 @@
                 </a:solidFill>
                 <a:latin typeface="Consolas"/>
               </a:rPr>
-              <a:t>Range:   10.0  C</a:t>
+              <a:t>Max:    550.0  C</a:t>
             </a:r>
           </a:p>
           <a:p>
@@ -6422,30 +6594,16 @@
                 </a:solidFill>
                 <a:latin typeface="Consolas"/>
               </a:rPr>
-              <a:t>Max:    550.0  C</a:t>
-            </a:r>
-          </a:p>
-          <a:p>
-            <a:r>
-              <a:rPr sz="1300">
-                <a:solidFill>
-                  <a:srgbClr val="FFFFFF"/>
-                </a:solidFill>
-                <a:latin typeface="Consolas"/>
-              </a:rPr>
               <a:t>Min:    530.0  C</a:t>
             </a:r>
           </a:p>
           <a:p>
-            <a:r>
-              <a:rPr sz="1300">
-                <a:solidFill>
-                  <a:srgbClr val="FFFFFF"/>
-                </a:solidFill>
-                <a:latin typeface="Consolas"/>
-              </a:rPr>
-              <a:t/>
-            </a:r>
+            <a:endParaRPr sz="1300">
+              <a:solidFill>
+                <a:srgbClr val="FFFFFF"/>
+              </a:solidFill>
+              <a:latin typeface="Consolas"/>
+            </a:endParaRPr>
           </a:p>
           <a:p>
             <a:r>
@@ -6504,7 +6662,7 @@
 </file>
 
 <file path=ppt/slides/slide14.xml><?xml version="1.0" encoding="utf-8"?>
-<p:sld xmlns:a="http://schemas.openxmlformats.org/drawingml/2006/main" xmlns:p="http://schemas.openxmlformats.org/presentationml/2006/main" xmlns:r="http://schemas.openxmlformats.org/officeDocument/2006/relationships">
+<p:sld xmlns:a="http://schemas.openxmlformats.org/drawingml/2006/main" xmlns:r="http://schemas.openxmlformats.org/officeDocument/2006/relationships" xmlns:p="http://schemas.openxmlformats.org/presentationml/2006/main">
   <p:cSld>
     <p:spTree>
       <p:nvGrpSpPr>
@@ -6512,7 +6670,14 @@
         <p:cNvGrpSpPr/>
         <p:nvPr/>
       </p:nvGrpSpPr>
-      <p:grpSpPr/>
+      <p:grpSpPr>
+        <a:xfrm>
+          <a:off x="0" y="0"/>
+          <a:ext cx="0" cy="0"/>
+          <a:chOff x="0" y="0"/>
+          <a:chExt cx="0" cy="0"/>
+        </a:xfrm>
+      </p:grpSpPr>
       <p:sp>
         <p:nvSpPr>
           <p:cNvPr id="2" name="Rectangle 1"/>
@@ -6553,6 +6718,7 @@
           <a:lstStyle/>
           <a:p>
             <a:pPr algn="ctr"/>
+            <a:endParaRPr/>
           </a:p>
         </p:txBody>
       </p:sp>
@@ -6666,6 +6832,7 @@
           <a:lstStyle/>
           <a:p>
             <a:pPr algn="ctr"/>
+            <a:endParaRPr/>
           </a:p>
         </p:txBody>
       </p:sp>
@@ -6781,6 +6948,7 @@
           <a:lstStyle/>
           <a:p>
             <a:pPr algn="ctr"/>
+            <a:endParaRPr/>
           </a:p>
         </p:txBody>
       </p:sp>
@@ -6817,6 +6985,14 @@
             </a:r>
           </a:p>
           <a:p>
+            <a:endParaRPr sz="1300">
+              <a:solidFill>
+                <a:srgbClr val="FFFFFF"/>
+              </a:solidFill>
+              <a:latin typeface="Consolas"/>
+            </a:endParaRPr>
+          </a:p>
+          <a:p>
             <a:r>
               <a:rPr sz="1300">
                 <a:solidFill>
@@ -6824,7 +7000,7 @@
                 </a:solidFill>
                 <a:latin typeface="Consolas"/>
               </a:rPr>
-              <a:t/>
+              <a:t>Current:</a:t>
             </a:r>
           </a:p>
           <a:p>
@@ -6835,30 +7011,16 @@
                 </a:solidFill>
                 <a:latin typeface="Consolas"/>
               </a:rPr>
-              <a:t>Current:</a:t>
-            </a:r>
-          </a:p>
-          <a:p>
-            <a:r>
-              <a:rPr sz="1300">
-                <a:solidFill>
-                  <a:srgbClr val="FFFFFF"/>
-                </a:solidFill>
-                <a:latin typeface="Consolas"/>
-              </a:rPr>
               <a:t>  600.0  C</a:t>
             </a:r>
           </a:p>
           <a:p>
-            <a:r>
-              <a:rPr sz="1300">
-                <a:solidFill>
-                  <a:srgbClr val="FFFFFF"/>
-                </a:solidFill>
-                <a:latin typeface="Consolas"/>
-              </a:rPr>
-              <a:t/>
-            </a:r>
+            <a:endParaRPr sz="1300">
+              <a:solidFill>
+                <a:srgbClr val="FFFFFF"/>
+              </a:solidFill>
+              <a:latin typeface="Consolas"/>
+            </a:endParaRPr>
           </a:p>
           <a:p>
             <a:r>
@@ -6961,6 +7123,7 @@
           <a:lstStyle/>
           <a:p>
             <a:pPr algn="ctr"/>
+            <a:endParaRPr/>
           </a:p>
         </p:txBody>
       </p:sp>
@@ -6997,6 +7160,14 @@
             </a:r>
           </a:p>
           <a:p>
+            <a:endParaRPr sz="1300">
+              <a:solidFill>
+                <a:srgbClr val="FFFFFF"/>
+              </a:solidFill>
+              <a:latin typeface="Consolas"/>
+            </a:endParaRPr>
+          </a:p>
+          <a:p>
             <a:r>
               <a:rPr sz="1300">
                 <a:solidFill>
@@ -7004,7 +7175,7 @@
                 </a:solidFill>
                 <a:latin typeface="Consolas"/>
               </a:rPr>
-              <a:t/>
+              <a:t>Current:</a:t>
             </a:r>
           </a:p>
           <a:p>
@@ -7015,30 +7186,16 @@
                 </a:solidFill>
                 <a:latin typeface="Consolas"/>
               </a:rPr>
-              <a:t>Current:</a:t>
-            </a:r>
-          </a:p>
-          <a:p>
-            <a:r>
-              <a:rPr sz="1300">
-                <a:solidFill>
-                  <a:srgbClr val="FFFFFF"/>
-                </a:solidFill>
-                <a:latin typeface="Consolas"/>
-              </a:rPr>
               <a:t>  400.0  C</a:t>
             </a:r>
           </a:p>
           <a:p>
-            <a:r>
-              <a:rPr sz="1300">
-                <a:solidFill>
-                  <a:srgbClr val="FFFFFF"/>
-                </a:solidFill>
-                <a:latin typeface="Consolas"/>
-              </a:rPr>
-              <a:t/>
-            </a:r>
+            <a:endParaRPr sz="1300">
+              <a:solidFill>
+                <a:srgbClr val="FFFFFF"/>
+              </a:solidFill>
+              <a:latin typeface="Consolas"/>
+            </a:endParaRPr>
           </a:p>
           <a:p>
             <a:r>
@@ -7108,7 +7265,7 @@
 </file>
 
 <file path=ppt/slides/slide15.xml><?xml version="1.0" encoding="utf-8"?>
-<p:sld xmlns:a="http://schemas.openxmlformats.org/drawingml/2006/main" xmlns:p="http://schemas.openxmlformats.org/presentationml/2006/main" xmlns:r="http://schemas.openxmlformats.org/officeDocument/2006/relationships">
+<p:sld xmlns:a="http://schemas.openxmlformats.org/drawingml/2006/main" xmlns:r="http://schemas.openxmlformats.org/officeDocument/2006/relationships" xmlns:p="http://schemas.openxmlformats.org/presentationml/2006/main">
   <p:cSld>
     <p:spTree>
       <p:nvGrpSpPr>
@@ -7116,7 +7273,14 @@
         <p:cNvGrpSpPr/>
         <p:nvPr/>
       </p:nvGrpSpPr>
-      <p:grpSpPr/>
+      <p:grpSpPr>
+        <a:xfrm>
+          <a:off x="0" y="0"/>
+          <a:ext cx="0" cy="0"/>
+          <a:chOff x="0" y="0"/>
+          <a:chExt cx="0" cy="0"/>
+        </a:xfrm>
+      </p:grpSpPr>
       <p:sp>
         <p:nvSpPr>
           <p:cNvPr id="2" name="Rectangle 1"/>
@@ -7157,6 +7321,7 @@
           <a:lstStyle/>
           <a:p>
             <a:pPr algn="ctr"/>
+            <a:endParaRPr/>
           </a:p>
         </p:txBody>
       </p:sp>
@@ -7270,6 +7435,7 @@
           <a:lstStyle/>
           <a:p>
             <a:pPr algn="ctr"/>
+            <a:endParaRPr/>
           </a:p>
         </p:txBody>
       </p:sp>
@@ -7397,10 +7563,34 @@
                 <a:tableStyleId>{5C22544A-7EE6-4342-B048-85BDC9FD1C3A}</a:tableStyleId>
               </a:tblPr>
               <a:tblGrid>
-                <a:gridCol w="731520"/>
-                <a:gridCol w="2103120"/>
-                <a:gridCol w="1828800"/>
-                <a:gridCol w="6858000"/>
+                <a:gridCol w="731520">
+                  <a:extLst>
+                    <a:ext uri="{9D8B030D-6E8A-4147-A177-3AD203B41FA5}">
+                      <a16:colId xmlns:a16="http://schemas.microsoft.com/office/drawing/2014/main" val="20000"/>
+                    </a:ext>
+                  </a:extLst>
+                </a:gridCol>
+                <a:gridCol w="2103120">
+                  <a:extLst>
+                    <a:ext uri="{9D8B030D-6E8A-4147-A177-3AD203B41FA5}">
+                      <a16:colId xmlns:a16="http://schemas.microsoft.com/office/drawing/2014/main" val="20001"/>
+                    </a:ext>
+                  </a:extLst>
+                </a:gridCol>
+                <a:gridCol w="1828800">
+                  <a:extLst>
+                    <a:ext uri="{9D8B030D-6E8A-4147-A177-3AD203B41FA5}">
+                      <a16:colId xmlns:a16="http://schemas.microsoft.com/office/drawing/2014/main" val="20002"/>
+                    </a:ext>
+                  </a:extLst>
+                </a:gridCol>
+                <a:gridCol w="6858000">
+                  <a:extLst>
+                    <a:ext uri="{9D8B030D-6E8A-4147-A177-3AD203B41FA5}">
+                      <a16:colId xmlns:a16="http://schemas.microsoft.com/office/drawing/2014/main" val="20003"/>
+                    </a:ext>
+                  </a:extLst>
+                </a:gridCol>
               </a:tblGrid>
               <a:tr h="402336">
                 <a:tc>
@@ -7495,6 +7685,11 @@
                     </a:solidFill>
                   </a:tcPr>
                 </a:tc>
+                <a:extLst>
+                  <a:ext uri="{0D108BD9-81ED-4DB2-BD59-A6C34878D82A}">
+                    <a16:rowId xmlns:a16="http://schemas.microsoft.com/office/drawing/2014/main" val="10000"/>
+                  </a:ext>
+                </a:extLst>
               </a:tr>
               <a:tr h="402336">
                 <a:tc>
@@ -7589,6 +7784,11 @@
                     </a:solidFill>
                   </a:tcPr>
                 </a:tc>
+                <a:extLst>
+                  <a:ext uri="{0D108BD9-81ED-4DB2-BD59-A6C34878D82A}">
+                    <a16:rowId xmlns:a16="http://schemas.microsoft.com/office/drawing/2014/main" val="10001"/>
+                  </a:ext>
+                </a:extLst>
               </a:tr>
               <a:tr h="402336">
                 <a:tc>
@@ -7683,6 +7883,11 @@
                     </a:solidFill>
                   </a:tcPr>
                 </a:tc>
+                <a:extLst>
+                  <a:ext uri="{0D108BD9-81ED-4DB2-BD59-A6C34878D82A}">
+                    <a16:rowId xmlns:a16="http://schemas.microsoft.com/office/drawing/2014/main" val="10002"/>
+                  </a:ext>
+                </a:extLst>
               </a:tr>
               <a:tr h="402336">
                 <a:tc>
@@ -7777,6 +7982,11 @@
                     </a:solidFill>
                   </a:tcPr>
                 </a:tc>
+                <a:extLst>
+                  <a:ext uri="{0D108BD9-81ED-4DB2-BD59-A6C34878D82A}">
+                    <a16:rowId xmlns:a16="http://schemas.microsoft.com/office/drawing/2014/main" val="10003"/>
+                  </a:ext>
+                </a:extLst>
               </a:tr>
               <a:tr h="402336">
                 <a:tc>
@@ -7871,6 +8081,11 @@
                     </a:solidFill>
                   </a:tcPr>
                 </a:tc>
+                <a:extLst>
+                  <a:ext uri="{0D108BD9-81ED-4DB2-BD59-A6C34878D82A}">
+                    <a16:rowId xmlns:a16="http://schemas.microsoft.com/office/drawing/2014/main" val="10004"/>
+                  </a:ext>
+                </a:extLst>
               </a:tr>
               <a:tr h="402336">
                 <a:tc>
@@ -7965,6 +8180,11 @@
                     </a:solidFill>
                   </a:tcPr>
                 </a:tc>
+                <a:extLst>
+                  <a:ext uri="{0D108BD9-81ED-4DB2-BD59-A6C34878D82A}">
+                    <a16:rowId xmlns:a16="http://schemas.microsoft.com/office/drawing/2014/main" val="10005"/>
+                  </a:ext>
+                </a:extLst>
               </a:tr>
               <a:tr h="402336">
                 <a:tc>
@@ -8059,6 +8279,11 @@
                     </a:solidFill>
                   </a:tcPr>
                 </a:tc>
+                <a:extLst>
+                  <a:ext uri="{0D108BD9-81ED-4DB2-BD59-A6C34878D82A}">
+                    <a16:rowId xmlns:a16="http://schemas.microsoft.com/office/drawing/2014/main" val="10006"/>
+                  </a:ext>
+                </a:extLst>
               </a:tr>
               <a:tr h="402336">
                 <a:tc>
@@ -8153,6 +8378,11 @@
                     </a:solidFill>
                   </a:tcPr>
                 </a:tc>
+                <a:extLst>
+                  <a:ext uri="{0D108BD9-81ED-4DB2-BD59-A6C34878D82A}">
+                    <a16:rowId xmlns:a16="http://schemas.microsoft.com/office/drawing/2014/main" val="10007"/>
+                  </a:ext>
+                </a:extLst>
               </a:tr>
               <a:tr h="402336">
                 <a:tc>
@@ -8247,6 +8477,11 @@
                     </a:solidFill>
                   </a:tcPr>
                 </a:tc>
+                <a:extLst>
+                  <a:ext uri="{0D108BD9-81ED-4DB2-BD59-A6C34878D82A}">
+                    <a16:rowId xmlns:a16="http://schemas.microsoft.com/office/drawing/2014/main" val="10008"/>
+                  </a:ext>
+                </a:extLst>
               </a:tr>
               <a:tr h="402336">
                 <a:tc>
@@ -8341,6 +8576,11 @@
                     </a:solidFill>
                   </a:tcPr>
                 </a:tc>
+                <a:extLst>
+                  <a:ext uri="{0D108BD9-81ED-4DB2-BD59-A6C34878D82A}">
+                    <a16:rowId xmlns:a16="http://schemas.microsoft.com/office/drawing/2014/main" val="10009"/>
+                  </a:ext>
+                </a:extLst>
               </a:tr>
               <a:tr h="402336">
                 <a:tc>
@@ -8435,6 +8675,11 @@
                     </a:solidFill>
                   </a:tcPr>
                 </a:tc>
+                <a:extLst>
+                  <a:ext uri="{0D108BD9-81ED-4DB2-BD59-A6C34878D82A}">
+                    <a16:rowId xmlns:a16="http://schemas.microsoft.com/office/drawing/2014/main" val="10010"/>
+                  </a:ext>
+                </a:extLst>
               </a:tr>
             </a:tbl>
           </a:graphicData>
@@ -8484,7 +8729,7 @@
 </file>
 
 <file path=ppt/slides/slide16.xml><?xml version="1.0" encoding="utf-8"?>
-<p:sld xmlns:a="http://schemas.openxmlformats.org/drawingml/2006/main" xmlns:p="http://schemas.openxmlformats.org/presentationml/2006/main" xmlns:r="http://schemas.openxmlformats.org/officeDocument/2006/relationships">
+<p:sld xmlns:a="http://schemas.openxmlformats.org/drawingml/2006/main" xmlns:r="http://schemas.openxmlformats.org/officeDocument/2006/relationships" xmlns:p="http://schemas.openxmlformats.org/presentationml/2006/main">
   <p:cSld>
     <p:spTree>
       <p:nvGrpSpPr>
@@ -8492,7 +8737,14 @@
         <p:cNvGrpSpPr/>
         <p:nvPr/>
       </p:nvGrpSpPr>
-      <p:grpSpPr/>
+      <p:grpSpPr>
+        <a:xfrm>
+          <a:off x="0" y="0"/>
+          <a:ext cx="0" cy="0"/>
+          <a:chOff x="0" y="0"/>
+          <a:chExt cx="0" cy="0"/>
+        </a:xfrm>
+      </p:grpSpPr>
       <p:sp>
         <p:nvSpPr>
           <p:cNvPr id="2" name="Rectangle 1"/>
@@ -8533,6 +8785,7 @@
           <a:lstStyle/>
           <a:p>
             <a:pPr algn="ctr"/>
+            <a:endParaRPr/>
           </a:p>
         </p:txBody>
       </p:sp>
@@ -8646,6 +8899,7 @@
           <a:lstStyle/>
           <a:p>
             <a:pPr algn="ctr"/>
+            <a:endParaRPr/>
           </a:p>
         </p:txBody>
       </p:sp>
@@ -8738,9 +8992,27 @@
                 <a:tableStyleId>{5C22544A-7EE6-4342-B048-85BDC9FD1C3A}</a:tableStyleId>
               </a:tblPr>
               <a:tblGrid>
-                <a:gridCol w="731520"/>
-                <a:gridCol w="4114800"/>
-                <a:gridCol w="6675120"/>
+                <a:gridCol w="731520">
+                  <a:extLst>
+                    <a:ext uri="{9D8B030D-6E8A-4147-A177-3AD203B41FA5}">
+                      <a16:colId xmlns:a16="http://schemas.microsoft.com/office/drawing/2014/main" val="20000"/>
+                    </a:ext>
+                  </a:extLst>
+                </a:gridCol>
+                <a:gridCol w="4114800">
+                  <a:extLst>
+                    <a:ext uri="{9D8B030D-6E8A-4147-A177-3AD203B41FA5}">
+                      <a16:colId xmlns:a16="http://schemas.microsoft.com/office/drawing/2014/main" val="20001"/>
+                    </a:ext>
+                  </a:extLst>
+                </a:gridCol>
+                <a:gridCol w="6675120">
+                  <a:extLst>
+                    <a:ext uri="{9D8B030D-6E8A-4147-A177-3AD203B41FA5}">
+                      <a16:colId xmlns:a16="http://schemas.microsoft.com/office/drawing/2014/main" val="20002"/>
+                    </a:ext>
+                  </a:extLst>
+                </a:gridCol>
               </a:tblGrid>
               <a:tr h="457200">
                 <a:tc>
@@ -8812,6 +9084,11 @@
                     </a:solidFill>
                   </a:tcPr>
                 </a:tc>
+                <a:extLst>
+                  <a:ext uri="{0D108BD9-81ED-4DB2-BD59-A6C34878D82A}">
+                    <a16:rowId xmlns:a16="http://schemas.microsoft.com/office/drawing/2014/main" val="10000"/>
+                  </a:ext>
+                </a:extLst>
               </a:tr>
               <a:tr h="457200">
                 <a:tc>
@@ -8883,6 +9160,11 @@
                     </a:solidFill>
                   </a:tcPr>
                 </a:tc>
+                <a:extLst>
+                  <a:ext uri="{0D108BD9-81ED-4DB2-BD59-A6C34878D82A}">
+                    <a16:rowId xmlns:a16="http://schemas.microsoft.com/office/drawing/2014/main" val="10001"/>
+                  </a:ext>
+                </a:extLst>
               </a:tr>
               <a:tr h="457200">
                 <a:tc>
@@ -8954,6 +9236,11 @@
                     </a:solidFill>
                   </a:tcPr>
                 </a:tc>
+                <a:extLst>
+                  <a:ext uri="{0D108BD9-81ED-4DB2-BD59-A6C34878D82A}">
+                    <a16:rowId xmlns:a16="http://schemas.microsoft.com/office/drawing/2014/main" val="10002"/>
+                  </a:ext>
+                </a:extLst>
               </a:tr>
               <a:tr h="457200">
                 <a:tc>
@@ -9025,6 +9312,11 @@
                     </a:solidFill>
                   </a:tcPr>
                 </a:tc>
+                <a:extLst>
+                  <a:ext uri="{0D108BD9-81ED-4DB2-BD59-A6C34878D82A}">
+                    <a16:rowId xmlns:a16="http://schemas.microsoft.com/office/drawing/2014/main" val="10003"/>
+                  </a:ext>
+                </a:extLst>
               </a:tr>
               <a:tr h="457200">
                 <a:tc>
@@ -9096,6 +9388,11 @@
                     </a:solidFill>
                   </a:tcPr>
                 </a:tc>
+                <a:extLst>
+                  <a:ext uri="{0D108BD9-81ED-4DB2-BD59-A6C34878D82A}">
+                    <a16:rowId xmlns:a16="http://schemas.microsoft.com/office/drawing/2014/main" val="10004"/>
+                  </a:ext>
+                </a:extLst>
               </a:tr>
               <a:tr h="457200">
                 <a:tc>
@@ -9167,6 +9464,11 @@
                     </a:solidFill>
                   </a:tcPr>
                 </a:tc>
+                <a:extLst>
+                  <a:ext uri="{0D108BD9-81ED-4DB2-BD59-A6C34878D82A}">
+                    <a16:rowId xmlns:a16="http://schemas.microsoft.com/office/drawing/2014/main" val="10005"/>
+                  </a:ext>
+                </a:extLst>
               </a:tr>
             </a:tbl>
           </a:graphicData>
@@ -9212,6 +9514,7 @@
           <a:lstStyle/>
           <a:p>
             <a:pPr algn="ctr"/>
+            <a:endParaRPr/>
           </a:p>
         </p:txBody>
       </p:sp>
@@ -9283,7 +9586,7 @@
 </file>
 
 <file path=ppt/slides/slide17.xml><?xml version="1.0" encoding="utf-8"?>
-<p:sld xmlns:a="http://schemas.openxmlformats.org/drawingml/2006/main" xmlns:p="http://schemas.openxmlformats.org/presentationml/2006/main" xmlns:r="http://schemas.openxmlformats.org/officeDocument/2006/relationships">
+<p:sld xmlns:a="http://schemas.openxmlformats.org/drawingml/2006/main" xmlns:r="http://schemas.openxmlformats.org/officeDocument/2006/relationships" xmlns:p="http://schemas.openxmlformats.org/presentationml/2006/main">
   <p:cSld>
     <p:spTree>
       <p:nvGrpSpPr>
@@ -9291,7 +9594,14 @@
         <p:cNvGrpSpPr/>
         <p:nvPr/>
       </p:nvGrpSpPr>
-      <p:grpSpPr/>
+      <p:grpSpPr>
+        <a:xfrm>
+          <a:off x="0" y="0"/>
+          <a:ext cx="0" cy="0"/>
+          <a:chOff x="0" y="0"/>
+          <a:chExt cx="0" cy="0"/>
+        </a:xfrm>
+      </p:grpSpPr>
       <p:sp>
         <p:nvSpPr>
           <p:cNvPr id="2" name="Rectangle 1"/>
@@ -9332,6 +9642,7 @@
           <a:lstStyle/>
           <a:p>
             <a:pPr algn="ctr"/>
+            <a:endParaRPr/>
           </a:p>
         </p:txBody>
       </p:sp>
@@ -9445,6 +9756,7 @@
           <a:lstStyle/>
           <a:p>
             <a:pPr algn="ctr"/>
+            <a:endParaRPr/>
           </a:p>
         </p:txBody>
       </p:sp>
@@ -9595,6 +9907,7 @@
           <a:lstStyle/>
           <a:p>
             <a:pPr algn="ctr"/>
+            <a:endParaRPr/>
           </a:p>
         </p:txBody>
       </p:sp>
@@ -9638,6 +9951,7 @@
           <a:lstStyle/>
           <a:p>
             <a:pPr algn="ctr"/>
+            <a:endParaRPr/>
           </a:p>
         </p:txBody>
       </p:sp>
@@ -9883,6 +10197,7 @@
           <a:lstStyle/>
           <a:p>
             <a:pPr algn="ctr"/>
+            <a:endParaRPr/>
           </a:p>
         </p:txBody>
       </p:sp>
@@ -9926,6 +10241,7 @@
           <a:lstStyle/>
           <a:p>
             <a:pPr algn="ctr"/>
+            <a:endParaRPr/>
           </a:p>
         </p:txBody>
       </p:sp>
@@ -10147,6 +10463,7 @@
           <a:lstStyle/>
           <a:p>
             <a:pPr algn="ctr"/>
+            <a:endParaRPr/>
           </a:p>
         </p:txBody>
       </p:sp>
@@ -10190,6 +10507,7 @@
           <a:lstStyle/>
           <a:p>
             <a:pPr algn="ctr"/>
+            <a:endParaRPr/>
           </a:p>
         </p:txBody>
       </p:sp>
@@ -10413,7 +10731,7 @@
 </file>
 
 <file path=ppt/slides/slide18.xml><?xml version="1.0" encoding="utf-8"?>
-<p:sld xmlns:a="http://schemas.openxmlformats.org/drawingml/2006/main" xmlns:p="http://schemas.openxmlformats.org/presentationml/2006/main" xmlns:r="http://schemas.openxmlformats.org/officeDocument/2006/relationships">
+<p:sld xmlns:a="http://schemas.openxmlformats.org/drawingml/2006/main" xmlns:r="http://schemas.openxmlformats.org/officeDocument/2006/relationships" xmlns:p="http://schemas.openxmlformats.org/presentationml/2006/main">
   <p:cSld>
     <p:spTree>
       <p:nvGrpSpPr>
@@ -10421,7 +10739,14 @@
         <p:cNvGrpSpPr/>
         <p:nvPr/>
       </p:nvGrpSpPr>
-      <p:grpSpPr/>
+      <p:grpSpPr>
+        <a:xfrm>
+          <a:off x="0" y="0"/>
+          <a:ext cx="0" cy="0"/>
+          <a:chOff x="0" y="0"/>
+          <a:chExt cx="0" cy="0"/>
+        </a:xfrm>
+      </p:grpSpPr>
       <p:sp>
         <p:nvSpPr>
           <p:cNvPr id="2" name="Rectangle 1"/>
@@ -10462,6 +10787,7 @@
           <a:lstStyle/>
           <a:p>
             <a:pPr algn="ctr"/>
+            <a:endParaRPr/>
           </a:p>
         </p:txBody>
       </p:sp>
@@ -10575,6 +10901,7 @@
           <a:lstStyle/>
           <a:p>
             <a:pPr algn="ctr"/>
+            <a:endParaRPr/>
           </a:p>
         </p:txBody>
       </p:sp>
@@ -10702,8 +11029,20 @@
                 <a:tableStyleId>{5C22544A-7EE6-4342-B048-85BDC9FD1C3A}</a:tableStyleId>
               </a:tblPr>
               <a:tblGrid>
-                <a:gridCol w="2011680"/>
-                <a:gridCol w="3383280"/>
+                <a:gridCol w="2011680">
+                  <a:extLst>
+                    <a:ext uri="{9D8B030D-6E8A-4147-A177-3AD203B41FA5}">
+                      <a16:colId xmlns:a16="http://schemas.microsoft.com/office/drawing/2014/main" val="20000"/>
+                    </a:ext>
+                  </a:extLst>
+                </a:gridCol>
+                <a:gridCol w="3383280">
+                  <a:extLst>
+                    <a:ext uri="{9D8B030D-6E8A-4147-A177-3AD203B41FA5}">
+                      <a16:colId xmlns:a16="http://schemas.microsoft.com/office/drawing/2014/main" val="20001"/>
+                    </a:ext>
+                  </a:extLst>
+                </a:gridCol>
               </a:tblGrid>
               <a:tr h="429768">
                 <a:tc>
@@ -10752,6 +11091,11 @@
                     </a:solidFill>
                   </a:tcPr>
                 </a:tc>
+                <a:extLst>
+                  <a:ext uri="{0D108BD9-81ED-4DB2-BD59-A6C34878D82A}">
+                    <a16:rowId xmlns:a16="http://schemas.microsoft.com/office/drawing/2014/main" val="10000"/>
+                  </a:ext>
+                </a:extLst>
               </a:tr>
               <a:tr h="429768">
                 <a:tc>
@@ -10800,6 +11144,11 @@
                     </a:solidFill>
                   </a:tcPr>
                 </a:tc>
+                <a:extLst>
+                  <a:ext uri="{0D108BD9-81ED-4DB2-BD59-A6C34878D82A}">
+                    <a16:rowId xmlns:a16="http://schemas.microsoft.com/office/drawing/2014/main" val="10001"/>
+                  </a:ext>
+                </a:extLst>
               </a:tr>
               <a:tr h="429768">
                 <a:tc>
@@ -10848,6 +11197,11 @@
                     </a:solidFill>
                   </a:tcPr>
                 </a:tc>
+                <a:extLst>
+                  <a:ext uri="{0D108BD9-81ED-4DB2-BD59-A6C34878D82A}">
+                    <a16:rowId xmlns:a16="http://schemas.microsoft.com/office/drawing/2014/main" val="10002"/>
+                  </a:ext>
+                </a:extLst>
               </a:tr>
               <a:tr h="429768">
                 <a:tc>
@@ -10896,6 +11250,11 @@
                     </a:solidFill>
                   </a:tcPr>
                 </a:tc>
+                <a:extLst>
+                  <a:ext uri="{0D108BD9-81ED-4DB2-BD59-A6C34878D82A}">
+                    <a16:rowId xmlns:a16="http://schemas.microsoft.com/office/drawing/2014/main" val="10003"/>
+                  </a:ext>
+                </a:extLst>
               </a:tr>
               <a:tr h="429768">
                 <a:tc>
@@ -10944,6 +11303,11 @@
                     </a:solidFill>
                   </a:tcPr>
                 </a:tc>
+                <a:extLst>
+                  <a:ext uri="{0D108BD9-81ED-4DB2-BD59-A6C34878D82A}">
+                    <a16:rowId xmlns:a16="http://schemas.microsoft.com/office/drawing/2014/main" val="10004"/>
+                  </a:ext>
+                </a:extLst>
               </a:tr>
               <a:tr h="429768">
                 <a:tc>
@@ -10992,6 +11356,11 @@
                     </a:solidFill>
                   </a:tcPr>
                 </a:tc>
+                <a:extLst>
+                  <a:ext uri="{0D108BD9-81ED-4DB2-BD59-A6C34878D82A}">
+                    <a16:rowId xmlns:a16="http://schemas.microsoft.com/office/drawing/2014/main" val="10005"/>
+                  </a:ext>
+                </a:extLst>
               </a:tr>
             </a:tbl>
           </a:graphicData>
@@ -11072,6 +11441,7 @@
           <a:lstStyle/>
           <a:p>
             <a:pPr algn="ctr"/>
+            <a:endParaRPr/>
           </a:p>
         </p:txBody>
       </p:sp>
@@ -11132,7 +11502,7 @@
         </p:nvGraphicFramePr>
         <p:xfrm>
           <a:off x="5989320" y="2697480"/>
-          <a:ext cx="5577840" cy="1719072"/>
+          <a:ext cx="5577840" cy="1773936"/>
         </p:xfrm>
         <a:graphic>
           <a:graphicData uri="http://schemas.openxmlformats.org/drawingml/2006/table">
@@ -11141,8 +11511,20 @@
                 <a:tableStyleId>{5C22544A-7EE6-4342-B048-85BDC9FD1C3A}</a:tableStyleId>
               </a:tblPr>
               <a:tblGrid>
-                <a:gridCol w="2286000"/>
-                <a:gridCol w="3291840"/>
+                <a:gridCol w="2286000">
+                  <a:extLst>
+                    <a:ext uri="{9D8B030D-6E8A-4147-A177-3AD203B41FA5}">
+                      <a16:colId xmlns:a16="http://schemas.microsoft.com/office/drawing/2014/main" val="20000"/>
+                    </a:ext>
+                  </a:extLst>
+                </a:gridCol>
+                <a:gridCol w="3291840">
+                  <a:extLst>
+                    <a:ext uri="{9D8B030D-6E8A-4147-A177-3AD203B41FA5}">
+                      <a16:colId xmlns:a16="http://schemas.microsoft.com/office/drawing/2014/main" val="20001"/>
+                    </a:ext>
+                  </a:extLst>
+                </a:gridCol>
               </a:tblGrid>
               <a:tr h="429768">
                 <a:tc>
@@ -11191,6 +11573,11 @@
                     </a:solidFill>
                   </a:tcPr>
                 </a:tc>
+                <a:extLst>
+                  <a:ext uri="{0D108BD9-81ED-4DB2-BD59-A6C34878D82A}">
+                    <a16:rowId xmlns:a16="http://schemas.microsoft.com/office/drawing/2014/main" val="10000"/>
+                  </a:ext>
+                </a:extLst>
               </a:tr>
               <a:tr h="429768">
                 <a:tc>
@@ -11239,6 +11626,11 @@
                     </a:solidFill>
                   </a:tcPr>
                 </a:tc>
+                <a:extLst>
+                  <a:ext uri="{0D108BD9-81ED-4DB2-BD59-A6C34878D82A}">
+                    <a16:rowId xmlns:a16="http://schemas.microsoft.com/office/drawing/2014/main" val="10001"/>
+                  </a:ext>
+                </a:extLst>
               </a:tr>
               <a:tr h="429768">
                 <a:tc>
@@ -11287,6 +11679,11 @@
                     </a:solidFill>
                   </a:tcPr>
                 </a:tc>
+                <a:extLst>
+                  <a:ext uri="{0D108BD9-81ED-4DB2-BD59-A6C34878D82A}">
+                    <a16:rowId xmlns:a16="http://schemas.microsoft.com/office/drawing/2014/main" val="10002"/>
+                  </a:ext>
+                </a:extLst>
               </a:tr>
               <a:tr h="429768">
                 <a:tc>
@@ -11335,6 +11732,11 @@
                     </a:solidFill>
                   </a:tcPr>
                 </a:tc>
+                <a:extLst>
+                  <a:ext uri="{0D108BD9-81ED-4DB2-BD59-A6C34878D82A}">
+                    <a16:rowId xmlns:a16="http://schemas.microsoft.com/office/drawing/2014/main" val="10003"/>
+                  </a:ext>
+                </a:extLst>
               </a:tr>
             </a:tbl>
           </a:graphicData>
@@ -11384,7 +11786,7 @@
 </file>
 
 <file path=ppt/slides/slide19.xml><?xml version="1.0" encoding="utf-8"?>
-<p:sld xmlns:a="http://schemas.openxmlformats.org/drawingml/2006/main" xmlns:p="http://schemas.openxmlformats.org/presentationml/2006/main" xmlns:r="http://schemas.openxmlformats.org/officeDocument/2006/relationships">
+<p:sld xmlns:a="http://schemas.openxmlformats.org/drawingml/2006/main" xmlns:r="http://schemas.openxmlformats.org/officeDocument/2006/relationships" xmlns:p="http://schemas.openxmlformats.org/presentationml/2006/main">
   <p:cSld>
     <p:spTree>
       <p:nvGrpSpPr>
@@ -11392,7 +11794,14 @@
         <p:cNvGrpSpPr/>
         <p:nvPr/>
       </p:nvGrpSpPr>
-      <p:grpSpPr/>
+      <p:grpSpPr>
+        <a:xfrm>
+          <a:off x="0" y="0"/>
+          <a:ext cx="0" cy="0"/>
+          <a:chOff x="0" y="0"/>
+          <a:chExt cx="0" cy="0"/>
+        </a:xfrm>
+      </p:grpSpPr>
       <p:sp>
         <p:nvSpPr>
           <p:cNvPr id="2" name="Rectangle 1"/>
@@ -11433,6 +11842,7 @@
           <a:lstStyle/>
           <a:p>
             <a:pPr algn="ctr"/>
+            <a:endParaRPr/>
           </a:p>
         </p:txBody>
       </p:sp>
@@ -11546,6 +11956,7 @@
           <a:lstStyle/>
           <a:p>
             <a:pPr algn="ctr"/>
+            <a:endParaRPr/>
           </a:p>
         </p:txBody>
       </p:sp>
@@ -11694,6 +12105,7 @@
           <a:lstStyle/>
           <a:p>
             <a:pPr algn="ctr"/>
+            <a:endParaRPr/>
           </a:p>
         </p:txBody>
       </p:sp>
@@ -11774,6 +12186,7 @@
           <a:lstStyle/>
           <a:p>
             <a:pPr algn="ctr"/>
+            <a:endParaRPr/>
           </a:p>
         </p:txBody>
       </p:sp>
@@ -11949,6 +12362,7 @@
           <a:lstStyle/>
           <a:p>
             <a:pPr algn="ctr"/>
+            <a:endParaRPr/>
           </a:p>
         </p:txBody>
       </p:sp>
@@ -12098,6 +12512,7 @@
           <a:lstStyle/>
           <a:p>
             <a:pPr algn="ctr"/>
+            <a:endParaRPr/>
           </a:p>
         </p:txBody>
       </p:sp>
@@ -12204,7 +12619,7 @@
 </file>
 
 <file path=ppt/slides/slide2.xml><?xml version="1.0" encoding="utf-8"?>
-<p:sld xmlns:a="http://schemas.openxmlformats.org/drawingml/2006/main" xmlns:p="http://schemas.openxmlformats.org/presentationml/2006/main" xmlns:r="http://schemas.openxmlformats.org/officeDocument/2006/relationships">
+<p:sld xmlns:a="http://schemas.openxmlformats.org/drawingml/2006/main" xmlns:r="http://schemas.openxmlformats.org/officeDocument/2006/relationships" xmlns:p="http://schemas.openxmlformats.org/presentationml/2006/main">
   <p:cSld>
     <p:spTree>
       <p:nvGrpSpPr>
@@ -12212,7 +12627,14 @@
         <p:cNvGrpSpPr/>
         <p:nvPr/>
       </p:nvGrpSpPr>
-      <p:grpSpPr/>
+      <p:grpSpPr>
+        <a:xfrm>
+          <a:off x="0" y="0"/>
+          <a:ext cx="0" cy="0"/>
+          <a:chOff x="0" y="0"/>
+          <a:chExt cx="0" cy="0"/>
+        </a:xfrm>
+      </p:grpSpPr>
       <p:sp>
         <p:nvSpPr>
           <p:cNvPr id="2" name="Rectangle 1"/>
@@ -12253,6 +12675,7 @@
           <a:lstStyle/>
           <a:p>
             <a:pPr algn="ctr"/>
+            <a:endParaRPr/>
           </a:p>
         </p:txBody>
       </p:sp>
@@ -12366,6 +12789,7 @@
           <a:lstStyle/>
           <a:p>
             <a:pPr algn="ctr"/>
+            <a:endParaRPr/>
           </a:p>
         </p:txBody>
       </p:sp>
@@ -12479,6 +12903,7 @@
           <a:lstStyle/>
           <a:p>
             <a:pPr algn="ctr"/>
+            <a:endParaRPr/>
           </a:p>
         </p:txBody>
       </p:sp>
@@ -12627,6 +13052,7 @@
           <a:lstStyle/>
           <a:p>
             <a:pPr algn="ctr"/>
+            <a:endParaRPr/>
           </a:p>
         </p:txBody>
       </p:sp>
@@ -12775,6 +13201,7 @@
           <a:lstStyle/>
           <a:p>
             <a:pPr algn="ctr"/>
+            <a:endParaRPr/>
           </a:p>
         </p:txBody>
       </p:sp>
@@ -12923,6 +13350,7 @@
           <a:lstStyle/>
           <a:p>
             <a:pPr algn="ctr"/>
+            <a:endParaRPr/>
           </a:p>
         </p:txBody>
       </p:sp>
@@ -13071,6 +13499,7 @@
           <a:lstStyle/>
           <a:p>
             <a:pPr algn="ctr"/>
+            <a:endParaRPr/>
           </a:p>
         </p:txBody>
       </p:sp>
@@ -13219,6 +13648,7 @@
           <a:lstStyle/>
           <a:p>
             <a:pPr algn="ctr"/>
+            <a:endParaRPr/>
           </a:p>
         </p:txBody>
       </p:sp>
@@ -13367,6 +13797,7 @@
           <a:lstStyle/>
           <a:p>
             <a:pPr algn="ctr"/>
+            <a:endParaRPr/>
           </a:p>
         </p:txBody>
       </p:sp>
@@ -13515,6 +13946,7 @@
           <a:lstStyle/>
           <a:p>
             <a:pPr algn="ctr"/>
+            <a:endParaRPr/>
           </a:p>
         </p:txBody>
       </p:sp>
@@ -13632,7 +14064,7 @@
 </file>
 
 <file path=ppt/slides/slide20.xml><?xml version="1.0" encoding="utf-8"?>
-<p:sld xmlns:a="http://schemas.openxmlformats.org/drawingml/2006/main" xmlns:p="http://schemas.openxmlformats.org/presentationml/2006/main" xmlns:r="http://schemas.openxmlformats.org/officeDocument/2006/relationships">
+<p:sld xmlns:a="http://schemas.openxmlformats.org/drawingml/2006/main" xmlns:r="http://schemas.openxmlformats.org/officeDocument/2006/relationships" xmlns:p="http://schemas.openxmlformats.org/presentationml/2006/main">
   <p:cSld>
     <p:spTree>
       <p:nvGrpSpPr>
@@ -13640,7 +14072,14 @@
         <p:cNvGrpSpPr/>
         <p:nvPr/>
       </p:nvGrpSpPr>
-      <p:grpSpPr/>
+      <p:grpSpPr>
+        <a:xfrm>
+          <a:off x="0" y="0"/>
+          <a:ext cx="0" cy="0"/>
+          <a:chOff x="0" y="0"/>
+          <a:chExt cx="0" cy="0"/>
+        </a:xfrm>
+      </p:grpSpPr>
       <p:sp>
         <p:nvSpPr>
           <p:cNvPr id="2" name="Rectangle 1"/>
@@ -13681,6 +14120,7 @@
           <a:lstStyle/>
           <a:p>
             <a:pPr algn="ctr"/>
+            <a:endParaRPr/>
           </a:p>
         </p:txBody>
       </p:sp>
@@ -13794,6 +14234,7 @@
           <a:lstStyle/>
           <a:p>
             <a:pPr algn="ctr"/>
+            <a:endParaRPr/>
           </a:p>
         </p:txBody>
       </p:sp>
@@ -13907,6 +14348,7 @@
           <a:lstStyle/>
           <a:p>
             <a:pPr algn="ctr"/>
+            <a:endParaRPr/>
           </a:p>
         </p:txBody>
       </p:sp>
@@ -13964,11 +14406,41 @@
                 <a:tableStyleId>{5C22544A-7EE6-4342-B048-85BDC9FD1C3A}</a:tableStyleId>
               </a:tblPr>
               <a:tblGrid>
-                <a:gridCol w="1371600"/>
-                <a:gridCol w="3200400"/>
-                <a:gridCol w="3200400"/>
-                <a:gridCol w="1554480"/>
-                <a:gridCol w="2194560"/>
+                <a:gridCol w="1371600">
+                  <a:extLst>
+                    <a:ext uri="{9D8B030D-6E8A-4147-A177-3AD203B41FA5}">
+                      <a16:colId xmlns:a16="http://schemas.microsoft.com/office/drawing/2014/main" val="20000"/>
+                    </a:ext>
+                  </a:extLst>
+                </a:gridCol>
+                <a:gridCol w="3200400">
+                  <a:extLst>
+                    <a:ext uri="{9D8B030D-6E8A-4147-A177-3AD203B41FA5}">
+                      <a16:colId xmlns:a16="http://schemas.microsoft.com/office/drawing/2014/main" val="20001"/>
+                    </a:ext>
+                  </a:extLst>
+                </a:gridCol>
+                <a:gridCol w="3200400">
+                  <a:extLst>
+                    <a:ext uri="{9D8B030D-6E8A-4147-A177-3AD203B41FA5}">
+                      <a16:colId xmlns:a16="http://schemas.microsoft.com/office/drawing/2014/main" val="20002"/>
+                    </a:ext>
+                  </a:extLst>
+                </a:gridCol>
+                <a:gridCol w="1554480">
+                  <a:extLst>
+                    <a:ext uri="{9D8B030D-6E8A-4147-A177-3AD203B41FA5}">
+                      <a16:colId xmlns:a16="http://schemas.microsoft.com/office/drawing/2014/main" val="20003"/>
+                    </a:ext>
+                  </a:extLst>
+                </a:gridCol>
+                <a:gridCol w="2194560">
+                  <a:extLst>
+                    <a:ext uri="{9D8B030D-6E8A-4147-A177-3AD203B41FA5}">
+                      <a16:colId xmlns:a16="http://schemas.microsoft.com/office/drawing/2014/main" val="20004"/>
+                    </a:ext>
+                  </a:extLst>
+                </a:gridCol>
               </a:tblGrid>
               <a:tr h="457200">
                 <a:tc>
@@ -14086,6 +14558,11 @@
                     </a:solidFill>
                   </a:tcPr>
                 </a:tc>
+                <a:extLst>
+                  <a:ext uri="{0D108BD9-81ED-4DB2-BD59-A6C34878D82A}">
+                    <a16:rowId xmlns:a16="http://schemas.microsoft.com/office/drawing/2014/main" val="10000"/>
+                  </a:ext>
+                </a:extLst>
               </a:tr>
               <a:tr h="457200">
                 <a:tc>
@@ -14203,6 +14680,11 @@
                     </a:solidFill>
                   </a:tcPr>
                 </a:tc>
+                <a:extLst>
+                  <a:ext uri="{0D108BD9-81ED-4DB2-BD59-A6C34878D82A}">
+                    <a16:rowId xmlns:a16="http://schemas.microsoft.com/office/drawing/2014/main" val="10001"/>
+                  </a:ext>
+                </a:extLst>
               </a:tr>
               <a:tr h="457200">
                 <a:tc>
@@ -14320,6 +14802,11 @@
                     </a:solidFill>
                   </a:tcPr>
                 </a:tc>
+                <a:extLst>
+                  <a:ext uri="{0D108BD9-81ED-4DB2-BD59-A6C34878D82A}">
+                    <a16:rowId xmlns:a16="http://schemas.microsoft.com/office/drawing/2014/main" val="10002"/>
+                  </a:ext>
+                </a:extLst>
               </a:tr>
               <a:tr h="457200">
                 <a:tc>
@@ -14437,6 +14924,11 @@
                     </a:solidFill>
                   </a:tcPr>
                 </a:tc>
+                <a:extLst>
+                  <a:ext uri="{0D108BD9-81ED-4DB2-BD59-A6C34878D82A}">
+                    <a16:rowId xmlns:a16="http://schemas.microsoft.com/office/drawing/2014/main" val="10003"/>
+                  </a:ext>
+                </a:extLst>
               </a:tr>
             </a:tbl>
           </a:graphicData>
@@ -14482,6 +14974,7 @@
           <a:lstStyle/>
           <a:p>
             <a:pPr algn="ctr"/>
+            <a:endParaRPr/>
           </a:p>
         </p:txBody>
       </p:sp>
@@ -14633,6 +15126,7 @@
           <a:lstStyle/>
           <a:p>
             <a:pPr algn="ctr"/>
+            <a:endParaRPr/>
           </a:p>
         </p:txBody>
       </p:sp>
@@ -14751,7 +15245,7 @@
 </file>
 
 <file path=ppt/slides/slide21.xml><?xml version="1.0" encoding="utf-8"?>
-<p:sld xmlns:a="http://schemas.openxmlformats.org/drawingml/2006/main" xmlns:p="http://schemas.openxmlformats.org/presentationml/2006/main" xmlns:r="http://schemas.openxmlformats.org/officeDocument/2006/relationships">
+<p:sld xmlns:a="http://schemas.openxmlformats.org/drawingml/2006/main" xmlns:r="http://schemas.openxmlformats.org/officeDocument/2006/relationships" xmlns:p="http://schemas.openxmlformats.org/presentationml/2006/main">
   <p:cSld>
     <p:spTree>
       <p:nvGrpSpPr>
@@ -14759,7 +15253,14 @@
         <p:cNvGrpSpPr/>
         <p:nvPr/>
       </p:nvGrpSpPr>
-      <p:grpSpPr/>
+      <p:grpSpPr>
+        <a:xfrm>
+          <a:off x="0" y="0"/>
+          <a:ext cx="0" cy="0"/>
+          <a:chOff x="0" y="0"/>
+          <a:chExt cx="0" cy="0"/>
+        </a:xfrm>
+      </p:grpSpPr>
       <p:sp>
         <p:nvSpPr>
           <p:cNvPr id="2" name="Rectangle 1"/>
@@ -14800,6 +15301,7 @@
           <a:lstStyle/>
           <a:p>
             <a:pPr algn="ctr"/>
+            <a:endParaRPr/>
           </a:p>
         </p:txBody>
       </p:sp>
@@ -14913,6 +15415,7 @@
           <a:lstStyle/>
           <a:p>
             <a:pPr algn="ctr"/>
+            <a:endParaRPr/>
           </a:p>
         </p:txBody>
       </p:sp>
@@ -15005,10 +15508,34 @@
                 <a:tableStyleId>{5C22544A-7EE6-4342-B048-85BDC9FD1C3A}</a:tableStyleId>
               </a:tblPr>
               <a:tblGrid>
-                <a:gridCol w="457200"/>
-                <a:gridCol w="3200400"/>
-                <a:gridCol w="3200400"/>
-                <a:gridCol w="4663440"/>
+                <a:gridCol w="457200">
+                  <a:extLst>
+                    <a:ext uri="{9D8B030D-6E8A-4147-A177-3AD203B41FA5}">
+                      <a16:colId xmlns:a16="http://schemas.microsoft.com/office/drawing/2014/main" val="20000"/>
+                    </a:ext>
+                  </a:extLst>
+                </a:gridCol>
+                <a:gridCol w="3200400">
+                  <a:extLst>
+                    <a:ext uri="{9D8B030D-6E8A-4147-A177-3AD203B41FA5}">
+                      <a16:colId xmlns:a16="http://schemas.microsoft.com/office/drawing/2014/main" val="20001"/>
+                    </a:ext>
+                  </a:extLst>
+                </a:gridCol>
+                <a:gridCol w="3200400">
+                  <a:extLst>
+                    <a:ext uri="{9D8B030D-6E8A-4147-A177-3AD203B41FA5}">
+                      <a16:colId xmlns:a16="http://schemas.microsoft.com/office/drawing/2014/main" val="20002"/>
+                    </a:ext>
+                  </a:extLst>
+                </a:gridCol>
+                <a:gridCol w="4663440">
+                  <a:extLst>
+                    <a:ext uri="{9D8B030D-6E8A-4147-A177-3AD203B41FA5}">
+                      <a16:colId xmlns:a16="http://schemas.microsoft.com/office/drawing/2014/main" val="20003"/>
+                    </a:ext>
+                  </a:extLst>
+                </a:gridCol>
               </a:tblGrid>
               <a:tr h="457200">
                 <a:tc>
@@ -15103,6 +15630,11 @@
                     </a:solidFill>
                   </a:tcPr>
                 </a:tc>
+                <a:extLst>
+                  <a:ext uri="{0D108BD9-81ED-4DB2-BD59-A6C34878D82A}">
+                    <a16:rowId xmlns:a16="http://schemas.microsoft.com/office/drawing/2014/main" val="10000"/>
+                  </a:ext>
+                </a:extLst>
               </a:tr>
               <a:tr h="457200">
                 <a:tc>
@@ -15197,6 +15729,11 @@
                     </a:solidFill>
                   </a:tcPr>
                 </a:tc>
+                <a:extLst>
+                  <a:ext uri="{0D108BD9-81ED-4DB2-BD59-A6C34878D82A}">
+                    <a16:rowId xmlns:a16="http://schemas.microsoft.com/office/drawing/2014/main" val="10001"/>
+                  </a:ext>
+                </a:extLst>
               </a:tr>
               <a:tr h="457200">
                 <a:tc>
@@ -15291,6 +15828,11 @@
                     </a:solidFill>
                   </a:tcPr>
                 </a:tc>
+                <a:extLst>
+                  <a:ext uri="{0D108BD9-81ED-4DB2-BD59-A6C34878D82A}">
+                    <a16:rowId xmlns:a16="http://schemas.microsoft.com/office/drawing/2014/main" val="10002"/>
+                  </a:ext>
+                </a:extLst>
               </a:tr>
               <a:tr h="457200">
                 <a:tc>
@@ -15385,6 +15927,11 @@
                     </a:solidFill>
                   </a:tcPr>
                 </a:tc>
+                <a:extLst>
+                  <a:ext uri="{0D108BD9-81ED-4DB2-BD59-A6C34878D82A}">
+                    <a16:rowId xmlns:a16="http://schemas.microsoft.com/office/drawing/2014/main" val="10003"/>
+                  </a:ext>
+                </a:extLst>
               </a:tr>
               <a:tr h="457200">
                 <a:tc>
@@ -15479,6 +16026,11 @@
                     </a:solidFill>
                   </a:tcPr>
                 </a:tc>
+                <a:extLst>
+                  <a:ext uri="{0D108BD9-81ED-4DB2-BD59-A6C34878D82A}">
+                    <a16:rowId xmlns:a16="http://schemas.microsoft.com/office/drawing/2014/main" val="10004"/>
+                  </a:ext>
+                </a:extLst>
               </a:tr>
               <a:tr h="457200">
                 <a:tc>
@@ -15573,6 +16125,11 @@
                     </a:solidFill>
                   </a:tcPr>
                 </a:tc>
+                <a:extLst>
+                  <a:ext uri="{0D108BD9-81ED-4DB2-BD59-A6C34878D82A}">
+                    <a16:rowId xmlns:a16="http://schemas.microsoft.com/office/drawing/2014/main" val="10005"/>
+                  </a:ext>
+                </a:extLst>
               </a:tr>
             </a:tbl>
           </a:graphicData>
@@ -15618,6 +16175,7 @@
           <a:lstStyle/>
           <a:p>
             <a:pPr algn="ctr"/>
+            <a:endParaRPr/>
           </a:p>
         </p:txBody>
       </p:sp>
@@ -15665,7 +16223,7 @@
 </file>
 
 <file path=ppt/slides/slide22.xml><?xml version="1.0" encoding="utf-8"?>
-<p:sld xmlns:a="http://schemas.openxmlformats.org/drawingml/2006/main" xmlns:p="http://schemas.openxmlformats.org/presentationml/2006/main" xmlns:r="http://schemas.openxmlformats.org/officeDocument/2006/relationships">
+<p:sld xmlns:a="http://schemas.openxmlformats.org/drawingml/2006/main" xmlns:r="http://schemas.openxmlformats.org/officeDocument/2006/relationships" xmlns:p="http://schemas.openxmlformats.org/presentationml/2006/main">
   <p:cSld>
     <p:spTree>
       <p:nvGrpSpPr>
@@ -15673,7 +16231,14 @@
         <p:cNvGrpSpPr/>
         <p:nvPr/>
       </p:nvGrpSpPr>
-      <p:grpSpPr/>
+      <p:grpSpPr>
+        <a:xfrm>
+          <a:off x="0" y="0"/>
+          <a:ext cx="0" cy="0"/>
+          <a:chOff x="0" y="0"/>
+          <a:chExt cx="0" cy="0"/>
+        </a:xfrm>
+      </p:grpSpPr>
       <p:sp>
         <p:nvSpPr>
           <p:cNvPr id="2" name="Rectangle 1"/>
@@ -15714,6 +16279,7 @@
           <a:lstStyle/>
           <a:p>
             <a:pPr algn="ctr"/>
+            <a:endParaRPr/>
           </a:p>
         </p:txBody>
       </p:sp>
@@ -15827,6 +16393,7 @@
           <a:lstStyle/>
           <a:p>
             <a:pPr algn="ctr"/>
+            <a:endParaRPr/>
           </a:p>
         </p:txBody>
       </p:sp>
@@ -15945,7 +16512,7 @@
         </p:nvGraphicFramePr>
         <p:xfrm>
           <a:off x="320040" y="1645920"/>
-          <a:ext cx="8229600" cy="3364992"/>
+          <a:ext cx="8229600" cy="3401568"/>
         </p:xfrm>
         <a:graphic>
           <a:graphicData uri="http://schemas.openxmlformats.org/drawingml/2006/table">
@@ -15954,10 +16521,34 @@
                 <a:tableStyleId>{5C22544A-7EE6-4342-B048-85BDC9FD1C3A}</a:tableStyleId>
               </a:tblPr>
               <a:tblGrid>
-                <a:gridCol w="1645920"/>
-                <a:gridCol w="4114800"/>
-                <a:gridCol w="685800"/>
-                <a:gridCol w="1783080"/>
+                <a:gridCol w="1645920">
+                  <a:extLst>
+                    <a:ext uri="{9D8B030D-6E8A-4147-A177-3AD203B41FA5}">
+                      <a16:colId xmlns:a16="http://schemas.microsoft.com/office/drawing/2014/main" val="20000"/>
+                    </a:ext>
+                  </a:extLst>
+                </a:gridCol>
+                <a:gridCol w="4114800">
+                  <a:extLst>
+                    <a:ext uri="{9D8B030D-6E8A-4147-A177-3AD203B41FA5}">
+                      <a16:colId xmlns:a16="http://schemas.microsoft.com/office/drawing/2014/main" val="20001"/>
+                    </a:ext>
+                  </a:extLst>
+                </a:gridCol>
+                <a:gridCol w="685800">
+                  <a:extLst>
+                    <a:ext uri="{9D8B030D-6E8A-4147-A177-3AD203B41FA5}">
+                      <a16:colId xmlns:a16="http://schemas.microsoft.com/office/drawing/2014/main" val="20002"/>
+                    </a:ext>
+                  </a:extLst>
+                </a:gridCol>
+                <a:gridCol w="1783080">
+                  <a:extLst>
+                    <a:ext uri="{9D8B030D-6E8A-4147-A177-3AD203B41FA5}">
+                      <a16:colId xmlns:a16="http://schemas.microsoft.com/office/drawing/2014/main" val="20003"/>
+                    </a:ext>
+                  </a:extLst>
+                </a:gridCol>
               </a:tblGrid>
               <a:tr h="420624">
                 <a:tc>
@@ -16052,6 +16643,11 @@
                     </a:solidFill>
                   </a:tcPr>
                 </a:tc>
+                <a:extLst>
+                  <a:ext uri="{0D108BD9-81ED-4DB2-BD59-A6C34878D82A}">
+                    <a16:rowId xmlns:a16="http://schemas.microsoft.com/office/drawing/2014/main" val="10000"/>
+                  </a:ext>
+                </a:extLst>
               </a:tr>
               <a:tr h="420624">
                 <a:tc>
@@ -16146,6 +16742,11 @@
                     </a:solidFill>
                   </a:tcPr>
                 </a:tc>
+                <a:extLst>
+                  <a:ext uri="{0D108BD9-81ED-4DB2-BD59-A6C34878D82A}">
+                    <a16:rowId xmlns:a16="http://schemas.microsoft.com/office/drawing/2014/main" val="10001"/>
+                  </a:ext>
+                </a:extLst>
               </a:tr>
               <a:tr h="420624">
                 <a:tc>
@@ -16240,6 +16841,11 @@
                     </a:solidFill>
                   </a:tcPr>
                 </a:tc>
+                <a:extLst>
+                  <a:ext uri="{0D108BD9-81ED-4DB2-BD59-A6C34878D82A}">
+                    <a16:rowId xmlns:a16="http://schemas.microsoft.com/office/drawing/2014/main" val="10002"/>
+                  </a:ext>
+                </a:extLst>
               </a:tr>
               <a:tr h="420624">
                 <a:tc>
@@ -16334,6 +16940,11 @@
                     </a:solidFill>
                   </a:tcPr>
                 </a:tc>
+                <a:extLst>
+                  <a:ext uri="{0D108BD9-81ED-4DB2-BD59-A6C34878D82A}">
+                    <a16:rowId xmlns:a16="http://schemas.microsoft.com/office/drawing/2014/main" val="10003"/>
+                  </a:ext>
+                </a:extLst>
               </a:tr>
               <a:tr h="420624">
                 <a:tc>
@@ -16428,6 +17039,11 @@
                     </a:solidFill>
                   </a:tcPr>
                 </a:tc>
+                <a:extLst>
+                  <a:ext uri="{0D108BD9-81ED-4DB2-BD59-A6C34878D82A}">
+                    <a16:rowId xmlns:a16="http://schemas.microsoft.com/office/drawing/2014/main" val="10004"/>
+                  </a:ext>
+                </a:extLst>
               </a:tr>
               <a:tr h="420624">
                 <a:tc>
@@ -16522,6 +17138,11 @@
                     </a:solidFill>
                   </a:tcPr>
                 </a:tc>
+                <a:extLst>
+                  <a:ext uri="{0D108BD9-81ED-4DB2-BD59-A6C34878D82A}">
+                    <a16:rowId xmlns:a16="http://schemas.microsoft.com/office/drawing/2014/main" val="10005"/>
+                  </a:ext>
+                </a:extLst>
               </a:tr>
               <a:tr h="420624">
                 <a:tc>
@@ -16616,6 +17237,11 @@
                     </a:solidFill>
                   </a:tcPr>
                 </a:tc>
+                <a:extLst>
+                  <a:ext uri="{0D108BD9-81ED-4DB2-BD59-A6C34878D82A}">
+                    <a16:rowId xmlns:a16="http://schemas.microsoft.com/office/drawing/2014/main" val="10006"/>
+                  </a:ext>
+                </a:extLst>
               </a:tr>
               <a:tr h="420624">
                 <a:tc>
@@ -16710,6 +17336,11 @@
                     </a:solidFill>
                   </a:tcPr>
                 </a:tc>
+                <a:extLst>
+                  <a:ext uri="{0D108BD9-81ED-4DB2-BD59-A6C34878D82A}">
+                    <a16:rowId xmlns:a16="http://schemas.microsoft.com/office/drawing/2014/main" val="10007"/>
+                  </a:ext>
+                </a:extLst>
               </a:tr>
             </a:tbl>
           </a:graphicData>
@@ -16755,6 +17386,7 @@
           <a:lstStyle/>
           <a:p>
             <a:pPr algn="ctr"/>
+            <a:endParaRPr/>
           </a:p>
         </p:txBody>
       </p:sp>
@@ -16837,7 +17469,7 @@
 </file>
 
 <file path=ppt/slides/slide23.xml><?xml version="1.0" encoding="utf-8"?>
-<p:sld xmlns:a="http://schemas.openxmlformats.org/drawingml/2006/main" xmlns:p="http://schemas.openxmlformats.org/presentationml/2006/main" xmlns:r="http://schemas.openxmlformats.org/officeDocument/2006/relationships">
+<p:sld xmlns:a="http://schemas.openxmlformats.org/drawingml/2006/main" xmlns:r="http://schemas.openxmlformats.org/officeDocument/2006/relationships" xmlns:p="http://schemas.openxmlformats.org/presentationml/2006/main">
   <p:cSld>
     <p:spTree>
       <p:nvGrpSpPr>
@@ -16845,7 +17477,14 @@
         <p:cNvGrpSpPr/>
         <p:nvPr/>
       </p:nvGrpSpPr>
-      <p:grpSpPr/>
+      <p:grpSpPr>
+        <a:xfrm>
+          <a:off x="0" y="0"/>
+          <a:ext cx="0" cy="0"/>
+          <a:chOff x="0" y="0"/>
+          <a:chExt cx="0" cy="0"/>
+        </a:xfrm>
+      </p:grpSpPr>
       <p:sp>
         <p:nvSpPr>
           <p:cNvPr id="2" name="Rectangle 1"/>
@@ -16886,6 +17525,7 @@
           <a:lstStyle/>
           <a:p>
             <a:pPr algn="ctr"/>
+            <a:endParaRPr/>
           </a:p>
         </p:txBody>
       </p:sp>
@@ -16999,6 +17639,7 @@
           <a:lstStyle/>
           <a:p>
             <a:pPr algn="ctr"/>
+            <a:endParaRPr/>
           </a:p>
         </p:txBody>
       </p:sp>
@@ -17112,6 +17753,7 @@
           <a:lstStyle/>
           <a:p>
             <a:pPr algn="ctr"/>
+            <a:endParaRPr/>
           </a:p>
         </p:txBody>
       </p:sp>
@@ -17275,6 +17917,7 @@
           <a:lstStyle/>
           <a:p>
             <a:pPr algn="ctr"/>
+            <a:endParaRPr/>
           </a:p>
         </p:txBody>
       </p:sp>
@@ -17426,6 +18069,7 @@
           <a:lstStyle/>
           <a:p>
             <a:pPr algn="ctr"/>
+            <a:endParaRPr/>
           </a:p>
         </p:txBody>
       </p:sp>
@@ -17544,7 +18188,7 @@
 </file>
 
 <file path=ppt/slides/slide3.xml><?xml version="1.0" encoding="utf-8"?>
-<p:sld xmlns:a="http://schemas.openxmlformats.org/drawingml/2006/main" xmlns:p="http://schemas.openxmlformats.org/presentationml/2006/main" xmlns:r="http://schemas.openxmlformats.org/officeDocument/2006/relationships">
+<p:sld xmlns:a="http://schemas.openxmlformats.org/drawingml/2006/main" xmlns:r="http://schemas.openxmlformats.org/officeDocument/2006/relationships" xmlns:p="http://schemas.openxmlformats.org/presentationml/2006/main">
   <p:cSld>
     <p:spTree>
       <p:nvGrpSpPr>
@@ -17552,7 +18196,14 @@
         <p:cNvGrpSpPr/>
         <p:nvPr/>
       </p:nvGrpSpPr>
-      <p:grpSpPr/>
+      <p:grpSpPr>
+        <a:xfrm>
+          <a:off x="0" y="0"/>
+          <a:ext cx="0" cy="0"/>
+          <a:chOff x="0" y="0"/>
+          <a:chExt cx="0" cy="0"/>
+        </a:xfrm>
+      </p:grpSpPr>
       <p:sp>
         <p:nvSpPr>
           <p:cNvPr id="2" name="Rectangle 1"/>
@@ -17593,6 +18244,7 @@
           <a:lstStyle/>
           <a:p>
             <a:pPr algn="ctr"/>
+            <a:endParaRPr/>
           </a:p>
         </p:txBody>
       </p:sp>
@@ -17706,6 +18358,7 @@
           <a:lstStyle/>
           <a:p>
             <a:pPr algn="ctr"/>
+            <a:endParaRPr/>
           </a:p>
         </p:txBody>
       </p:sp>
@@ -17819,6 +18472,7 @@
           <a:lstStyle/>
           <a:p>
             <a:pPr algn="ctr"/>
+            <a:endParaRPr/>
           </a:p>
         </p:txBody>
       </p:sp>
@@ -17923,6 +18577,7 @@
           <a:lstStyle/>
           <a:p>
             <a:pPr algn="ctr"/>
+            <a:endParaRPr/>
           </a:p>
         </p:txBody>
       </p:sp>
@@ -18062,6 +18717,7 @@
           <a:lstStyle/>
           <a:p>
             <a:pPr algn="ctr"/>
+            <a:endParaRPr/>
           </a:p>
         </p:txBody>
       </p:sp>
@@ -18168,7 +18824,7 @@
 </file>
 
 <file path=ppt/slides/slide4.xml><?xml version="1.0" encoding="utf-8"?>
-<p:sld xmlns:a="http://schemas.openxmlformats.org/drawingml/2006/main" xmlns:p="http://schemas.openxmlformats.org/presentationml/2006/main" xmlns:r="http://schemas.openxmlformats.org/officeDocument/2006/relationships">
+<p:sld xmlns:a="http://schemas.openxmlformats.org/drawingml/2006/main" xmlns:r="http://schemas.openxmlformats.org/officeDocument/2006/relationships" xmlns:p="http://schemas.openxmlformats.org/presentationml/2006/main">
   <p:cSld>
     <p:spTree>
       <p:nvGrpSpPr>
@@ -18176,7 +18832,14 @@
         <p:cNvGrpSpPr/>
         <p:nvPr/>
       </p:nvGrpSpPr>
-      <p:grpSpPr/>
+      <p:grpSpPr>
+        <a:xfrm>
+          <a:off x="0" y="0"/>
+          <a:ext cx="0" cy="0"/>
+          <a:chOff x="0" y="0"/>
+          <a:chExt cx="0" cy="0"/>
+        </a:xfrm>
+      </p:grpSpPr>
       <p:sp>
         <p:nvSpPr>
           <p:cNvPr id="2" name="Rectangle 1"/>
@@ -18217,6 +18880,7 @@
           <a:lstStyle/>
           <a:p>
             <a:pPr algn="ctr"/>
+            <a:endParaRPr/>
           </a:p>
         </p:txBody>
       </p:sp>
@@ -18330,6 +18994,7 @@
           <a:lstStyle/>
           <a:p>
             <a:pPr algn="ctr"/>
+            <a:endParaRPr/>
           </a:p>
         </p:txBody>
       </p:sp>
@@ -18457,9 +19122,27 @@
                 <a:tableStyleId>{5C22544A-7EE6-4342-B048-85BDC9FD1C3A}</a:tableStyleId>
               </a:tblPr>
               <a:tblGrid>
-                <a:gridCol w="2651760"/>
-                <a:gridCol w="1371600"/>
-                <a:gridCol w="1280160"/>
+                <a:gridCol w="2651760">
+                  <a:extLst>
+                    <a:ext uri="{9D8B030D-6E8A-4147-A177-3AD203B41FA5}">
+                      <a16:colId xmlns:a16="http://schemas.microsoft.com/office/drawing/2014/main" val="20000"/>
+                    </a:ext>
+                  </a:extLst>
+                </a:gridCol>
+                <a:gridCol w="1371600">
+                  <a:extLst>
+                    <a:ext uri="{9D8B030D-6E8A-4147-A177-3AD203B41FA5}">
+                      <a16:colId xmlns:a16="http://schemas.microsoft.com/office/drawing/2014/main" val="20001"/>
+                    </a:ext>
+                  </a:extLst>
+                </a:gridCol>
+                <a:gridCol w="1280160">
+                  <a:extLst>
+                    <a:ext uri="{9D8B030D-6E8A-4147-A177-3AD203B41FA5}">
+                      <a16:colId xmlns:a16="http://schemas.microsoft.com/office/drawing/2014/main" val="20002"/>
+                    </a:ext>
+                  </a:extLst>
+                </a:gridCol>
               </a:tblGrid>
               <a:tr h="365760">
                 <a:tc>
@@ -18531,6 +19214,11 @@
                     </a:solidFill>
                   </a:tcPr>
                 </a:tc>
+                <a:extLst>
+                  <a:ext uri="{0D108BD9-81ED-4DB2-BD59-A6C34878D82A}">
+                    <a16:rowId xmlns:a16="http://schemas.microsoft.com/office/drawing/2014/main" val="10000"/>
+                  </a:ext>
+                </a:extLst>
               </a:tr>
               <a:tr h="365760">
                 <a:tc>
@@ -18602,6 +19290,11 @@
                     </a:solidFill>
                   </a:tcPr>
                 </a:tc>
+                <a:extLst>
+                  <a:ext uri="{0D108BD9-81ED-4DB2-BD59-A6C34878D82A}">
+                    <a16:rowId xmlns:a16="http://schemas.microsoft.com/office/drawing/2014/main" val="10001"/>
+                  </a:ext>
+                </a:extLst>
               </a:tr>
               <a:tr h="365760">
                 <a:tc>
@@ -18673,6 +19366,11 @@
                     </a:solidFill>
                   </a:tcPr>
                 </a:tc>
+                <a:extLst>
+                  <a:ext uri="{0D108BD9-81ED-4DB2-BD59-A6C34878D82A}">
+                    <a16:rowId xmlns:a16="http://schemas.microsoft.com/office/drawing/2014/main" val="10002"/>
+                  </a:ext>
+                </a:extLst>
               </a:tr>
               <a:tr h="365760">
                 <a:tc>
@@ -18744,6 +19442,11 @@
                     </a:solidFill>
                   </a:tcPr>
                 </a:tc>
+                <a:extLst>
+                  <a:ext uri="{0D108BD9-81ED-4DB2-BD59-A6C34878D82A}">
+                    <a16:rowId xmlns:a16="http://schemas.microsoft.com/office/drawing/2014/main" val="10003"/>
+                  </a:ext>
+                </a:extLst>
               </a:tr>
               <a:tr h="365760">
                 <a:tc>
@@ -18815,6 +19518,11 @@
                     </a:solidFill>
                   </a:tcPr>
                 </a:tc>
+                <a:extLst>
+                  <a:ext uri="{0D108BD9-81ED-4DB2-BD59-A6C34878D82A}">
+                    <a16:rowId xmlns:a16="http://schemas.microsoft.com/office/drawing/2014/main" val="10004"/>
+                  </a:ext>
+                </a:extLst>
               </a:tr>
               <a:tr h="365760">
                 <a:tc>
@@ -18886,6 +19594,11 @@
                     </a:solidFill>
                   </a:tcPr>
                 </a:tc>
+                <a:extLst>
+                  <a:ext uri="{0D108BD9-81ED-4DB2-BD59-A6C34878D82A}">
+                    <a16:rowId xmlns:a16="http://schemas.microsoft.com/office/drawing/2014/main" val="10005"/>
+                  </a:ext>
+                </a:extLst>
               </a:tr>
               <a:tr h="365760">
                 <a:tc>
@@ -18957,6 +19670,11 @@
                     </a:solidFill>
                   </a:tcPr>
                 </a:tc>
+                <a:extLst>
+                  <a:ext uri="{0D108BD9-81ED-4DB2-BD59-A6C34878D82A}">
+                    <a16:rowId xmlns:a16="http://schemas.microsoft.com/office/drawing/2014/main" val="10006"/>
+                  </a:ext>
+                </a:extLst>
               </a:tr>
             </a:tbl>
           </a:graphicData>
@@ -19007,7 +19725,7 @@
         </p:nvGraphicFramePr>
         <p:xfrm>
           <a:off x="5943600" y="1371600"/>
-          <a:ext cx="5925312" cy="1463040"/>
+          <a:ext cx="5925312" cy="1645920"/>
         </p:xfrm>
         <a:graphic>
           <a:graphicData uri="http://schemas.openxmlformats.org/drawingml/2006/table">
@@ -19016,9 +19734,27 @@
                 <a:tableStyleId>{5C22544A-7EE6-4342-B048-85BDC9FD1C3A}</a:tableStyleId>
               </a:tblPr>
               <a:tblGrid>
-                <a:gridCol w="2560320"/>
-                <a:gridCol w="1993392"/>
-                <a:gridCol w="1371600"/>
+                <a:gridCol w="2560320">
+                  <a:extLst>
+                    <a:ext uri="{9D8B030D-6E8A-4147-A177-3AD203B41FA5}">
+                      <a16:colId xmlns:a16="http://schemas.microsoft.com/office/drawing/2014/main" val="20000"/>
+                    </a:ext>
+                  </a:extLst>
+                </a:gridCol>
+                <a:gridCol w="1993392">
+                  <a:extLst>
+                    <a:ext uri="{9D8B030D-6E8A-4147-A177-3AD203B41FA5}">
+                      <a16:colId xmlns:a16="http://schemas.microsoft.com/office/drawing/2014/main" val="20001"/>
+                    </a:ext>
+                  </a:extLst>
+                </a:gridCol>
+                <a:gridCol w="1371600">
+                  <a:extLst>
+                    <a:ext uri="{9D8B030D-6E8A-4147-A177-3AD203B41FA5}">
+                      <a16:colId xmlns:a16="http://schemas.microsoft.com/office/drawing/2014/main" val="20002"/>
+                    </a:ext>
+                  </a:extLst>
+                </a:gridCol>
               </a:tblGrid>
               <a:tr h="365760">
                 <a:tc>
@@ -19090,6 +19826,11 @@
                     </a:solidFill>
                   </a:tcPr>
                 </a:tc>
+                <a:extLst>
+                  <a:ext uri="{0D108BD9-81ED-4DB2-BD59-A6C34878D82A}">
+                    <a16:rowId xmlns:a16="http://schemas.microsoft.com/office/drawing/2014/main" val="10000"/>
+                  </a:ext>
+                </a:extLst>
               </a:tr>
               <a:tr h="365760">
                 <a:tc>
@@ -19161,6 +19902,11 @@
                     </a:solidFill>
                   </a:tcPr>
                 </a:tc>
+                <a:extLst>
+                  <a:ext uri="{0D108BD9-81ED-4DB2-BD59-A6C34878D82A}">
+                    <a16:rowId xmlns:a16="http://schemas.microsoft.com/office/drawing/2014/main" val="10001"/>
+                  </a:ext>
+                </a:extLst>
               </a:tr>
               <a:tr h="365760">
                 <a:tc>
@@ -19232,6 +19978,11 @@
                     </a:solidFill>
                   </a:tcPr>
                 </a:tc>
+                <a:extLst>
+                  <a:ext uri="{0D108BD9-81ED-4DB2-BD59-A6C34878D82A}">
+                    <a16:rowId xmlns:a16="http://schemas.microsoft.com/office/drawing/2014/main" val="10002"/>
+                  </a:ext>
+                </a:extLst>
               </a:tr>
               <a:tr h="365760">
                 <a:tc>
@@ -19303,6 +20054,11 @@
                     </a:solidFill>
                   </a:tcPr>
                 </a:tc>
+                <a:extLst>
+                  <a:ext uri="{0D108BD9-81ED-4DB2-BD59-A6C34878D82A}">
+                    <a16:rowId xmlns:a16="http://schemas.microsoft.com/office/drawing/2014/main" val="10003"/>
+                  </a:ext>
+                </a:extLst>
               </a:tr>
             </a:tbl>
           </a:graphicData>
@@ -19316,7 +20072,7 @@
         </p:nvSpPr>
         <p:spPr>
           <a:xfrm>
-            <a:off x="320040" y="2743200"/>
+            <a:off x="320040" y="3977639"/>
             <a:ext cx="11521440" cy="1280160"/>
           </a:xfrm>
           <a:prstGeom prst="rect">
@@ -19348,6 +20104,7 @@
           <a:lstStyle/>
           <a:p>
             <a:pPr algn="ctr"/>
+            <a:endParaRPr/>
           </a:p>
         </p:txBody>
       </p:sp>
@@ -19359,7 +20116,7 @@
         </p:nvSpPr>
         <p:spPr>
           <a:xfrm>
-            <a:off x="457200" y="2834640"/>
+            <a:off x="457200" y="4069080"/>
             <a:ext cx="11247120" cy="548640"/>
           </a:xfrm>
           <a:prstGeom prst="rect">
@@ -19394,7 +20151,7 @@
         </p:nvSpPr>
         <p:spPr>
           <a:xfrm>
-            <a:off x="457200" y="3474720"/>
+            <a:off x="457200" y="4709160"/>
             <a:ext cx="11247120" cy="457200"/>
           </a:xfrm>
           <a:prstGeom prst="rect">
@@ -19429,7 +20186,7 @@
         </p:nvSpPr>
         <p:spPr>
           <a:xfrm>
-            <a:off x="457200" y="3977639"/>
+            <a:off x="457200" y="5212080"/>
             <a:ext cx="11247120" cy="320040"/>
           </a:xfrm>
           <a:prstGeom prst="rect">
@@ -19464,7 +20221,7 @@
         </p:nvSpPr>
         <p:spPr>
           <a:xfrm>
-            <a:off x="320040" y="4160520"/>
+            <a:off x="320040" y="5349240"/>
             <a:ext cx="11521440" cy="914400"/>
           </a:xfrm>
           <a:prstGeom prst="rect">
@@ -19496,6 +20253,7 @@
           <a:lstStyle/>
           <a:p>
             <a:pPr algn="ctr"/>
+            <a:endParaRPr/>
           </a:p>
         </p:txBody>
       </p:sp>
@@ -19507,7 +20265,7 @@
         </p:nvSpPr>
         <p:spPr>
           <a:xfrm>
-            <a:off x="502920" y="4224528"/>
+            <a:off x="502920" y="5413248"/>
             <a:ext cx="11155680" cy="749808"/>
           </a:xfrm>
           <a:prstGeom prst="rect">
@@ -19555,7 +20313,7 @@
 </file>
 
 <file path=ppt/slides/slide5.xml><?xml version="1.0" encoding="utf-8"?>
-<p:sld xmlns:a="http://schemas.openxmlformats.org/drawingml/2006/main" xmlns:p="http://schemas.openxmlformats.org/presentationml/2006/main" xmlns:r="http://schemas.openxmlformats.org/officeDocument/2006/relationships">
+<p:sld xmlns:a="http://schemas.openxmlformats.org/drawingml/2006/main" xmlns:r="http://schemas.openxmlformats.org/officeDocument/2006/relationships" xmlns:p="http://schemas.openxmlformats.org/presentationml/2006/main">
   <p:cSld>
     <p:spTree>
       <p:nvGrpSpPr>
@@ -19563,7 +20321,14 @@
         <p:cNvGrpSpPr/>
         <p:nvPr/>
       </p:nvGrpSpPr>
-      <p:grpSpPr/>
+      <p:grpSpPr>
+        <a:xfrm>
+          <a:off x="0" y="0"/>
+          <a:ext cx="0" cy="0"/>
+          <a:chOff x="0" y="0"/>
+          <a:chExt cx="0" cy="0"/>
+        </a:xfrm>
+      </p:grpSpPr>
       <p:sp>
         <p:nvSpPr>
           <p:cNvPr id="2" name="Rectangle 1"/>
@@ -19604,6 +20369,7 @@
           <a:lstStyle/>
           <a:p>
             <a:pPr algn="ctr"/>
+            <a:endParaRPr/>
           </a:p>
         </p:txBody>
       </p:sp>
@@ -19717,6 +20483,7 @@
           <a:lstStyle/>
           <a:p>
             <a:pPr algn="ctr"/>
+            <a:endParaRPr/>
           </a:p>
         </p:txBody>
       </p:sp>
@@ -19830,6 +20597,7 @@
           <a:lstStyle/>
           <a:p>
             <a:pPr algn="ctr"/>
+            <a:endParaRPr/>
           </a:p>
         </p:txBody>
       </p:sp>
@@ -19951,15 +20719,12 @@
           </a:p>
           <a:p>
             <a:pPr algn="ctr"/>
-            <a:r>
-              <a:rPr sz="1300" b="0" i="0">
-                <a:solidFill>
-                  <a:srgbClr val="1A1A2E"/>
-                </a:solidFill>
-                <a:latin typeface="游ゴシック"/>
-              </a:rPr>
-              <a:t/>
-            </a:r>
+            <a:endParaRPr sz="1300" b="0" i="0">
+              <a:solidFill>
+                <a:srgbClr val="1A1A2E"/>
+              </a:solidFill>
+              <a:latin typeface="游ゴシック"/>
+            </a:endParaRPr>
           </a:p>
           <a:p>
             <a:pPr algn="ctr"/>
@@ -20074,6 +20839,7 @@
           <a:lstStyle/>
           <a:p>
             <a:pPr algn="ctr"/>
+            <a:endParaRPr/>
           </a:p>
         </p:txBody>
       </p:sp>
@@ -20282,6 +21048,7 @@
           <a:lstStyle/>
           <a:p>
             <a:pPr algn="ctr"/>
+            <a:endParaRPr/>
           </a:p>
         </p:txBody>
       </p:sp>
@@ -20367,6 +21134,15 @@
           </a:p>
           <a:p>
             <a:pPr algn="ctr"/>
+            <a:endParaRPr sz="1300" b="0" i="0">
+              <a:solidFill>
+                <a:srgbClr val="1A1A2E"/>
+              </a:solidFill>
+              <a:latin typeface="游ゴシック"/>
+            </a:endParaRPr>
+          </a:p>
+          <a:p>
+            <a:pPr algn="ctr"/>
             <a:r>
               <a:rPr sz="1300" b="0" i="0">
                 <a:solidFill>
@@ -20374,7 +21150,7 @@
                 </a:solidFill>
                 <a:latin typeface="游ゴシック"/>
               </a:rPr>
-              <a:t/>
+              <a:t>LCD</a:t>
             </a:r>
           </a:p>
           <a:p>
@@ -20386,32 +21162,17 @@
                 </a:solidFill>
                 <a:latin typeface="游ゴシック"/>
               </a:rPr>
-              <a:t>LCD</a:t>
+              <a:t>→ リアルタイム表示</a:t>
             </a:r>
           </a:p>
           <a:p>
             <a:pPr algn="ctr"/>
-            <a:r>
-              <a:rPr sz="1300" b="0" i="0">
-                <a:solidFill>
-                  <a:srgbClr val="1A1A2E"/>
-                </a:solidFill>
-                <a:latin typeface="游ゴシック"/>
-              </a:rPr>
-              <a:t>→ リアルタイム表示</a:t>
-            </a:r>
-          </a:p>
-          <a:p>
-            <a:pPr algn="ctr"/>
-            <a:r>
-              <a:rPr sz="1300" b="0" i="0">
-                <a:solidFill>
-                  <a:srgbClr val="1A1A2E"/>
-                </a:solidFill>
-                <a:latin typeface="游ゴシック"/>
-              </a:rPr>
-              <a:t/>
-            </a:r>
+            <a:endParaRPr sz="1300" b="0" i="0">
+              <a:solidFill>
+                <a:srgbClr val="1A1A2E"/>
+              </a:solidFill>
+              <a:latin typeface="游ゴシック"/>
+            </a:endParaRPr>
           </a:p>
           <a:p>
             <a:pPr algn="ctr"/>
@@ -20448,7 +21209,7 @@
 </file>
 
 <file path=ppt/slides/slide6.xml><?xml version="1.0" encoding="utf-8"?>
-<p:sld xmlns:a="http://schemas.openxmlformats.org/drawingml/2006/main" xmlns:p="http://schemas.openxmlformats.org/presentationml/2006/main" xmlns:r="http://schemas.openxmlformats.org/officeDocument/2006/relationships">
+<p:sld xmlns:a="http://schemas.openxmlformats.org/drawingml/2006/main" xmlns:r="http://schemas.openxmlformats.org/officeDocument/2006/relationships" xmlns:p="http://schemas.openxmlformats.org/presentationml/2006/main">
   <p:cSld>
     <p:spTree>
       <p:nvGrpSpPr>
@@ -20456,7 +21217,14 @@
         <p:cNvGrpSpPr/>
         <p:nvPr/>
       </p:nvGrpSpPr>
-      <p:grpSpPr/>
+      <p:grpSpPr>
+        <a:xfrm>
+          <a:off x="0" y="0"/>
+          <a:ext cx="0" cy="0"/>
+          <a:chOff x="0" y="0"/>
+          <a:chExt cx="0" cy="0"/>
+        </a:xfrm>
+      </p:grpSpPr>
       <p:sp>
         <p:nvSpPr>
           <p:cNvPr id="2" name="Rectangle 1"/>
@@ -20497,6 +21265,7 @@
           <a:lstStyle/>
           <a:p>
             <a:pPr algn="ctr"/>
+            <a:endParaRPr/>
           </a:p>
         </p:txBody>
       </p:sp>
@@ -20610,6 +21379,7 @@
           <a:lstStyle/>
           <a:p>
             <a:pPr algn="ctr"/>
+            <a:endParaRPr/>
           </a:p>
         </p:txBody>
       </p:sp>
@@ -20702,9 +21472,27 @@
                 <a:tableStyleId>{5C22544A-7EE6-4342-B048-85BDC9FD1C3A}</a:tableStyleId>
               </a:tblPr>
               <a:tblGrid>
-                <a:gridCol w="2286000"/>
-                <a:gridCol w="4114800"/>
-                <a:gridCol w="5120640"/>
+                <a:gridCol w="2286000">
+                  <a:extLst>
+                    <a:ext uri="{9D8B030D-6E8A-4147-A177-3AD203B41FA5}">
+                      <a16:colId xmlns:a16="http://schemas.microsoft.com/office/drawing/2014/main" val="20000"/>
+                    </a:ext>
+                  </a:extLst>
+                </a:gridCol>
+                <a:gridCol w="4114800">
+                  <a:extLst>
+                    <a:ext uri="{9D8B030D-6E8A-4147-A177-3AD203B41FA5}">
+                      <a16:colId xmlns:a16="http://schemas.microsoft.com/office/drawing/2014/main" val="20001"/>
+                    </a:ext>
+                  </a:extLst>
+                </a:gridCol>
+                <a:gridCol w="5120640">
+                  <a:extLst>
+                    <a:ext uri="{9D8B030D-6E8A-4147-A177-3AD203B41FA5}">
+                      <a16:colId xmlns:a16="http://schemas.microsoft.com/office/drawing/2014/main" val="20002"/>
+                    </a:ext>
+                  </a:extLst>
+                </a:gridCol>
               </a:tblGrid>
               <a:tr h="457200">
                 <a:tc>
@@ -20776,6 +21564,11 @@
                     </a:solidFill>
                   </a:tcPr>
                 </a:tc>
+                <a:extLst>
+                  <a:ext uri="{0D108BD9-81ED-4DB2-BD59-A6C34878D82A}">
+                    <a16:rowId xmlns:a16="http://schemas.microsoft.com/office/drawing/2014/main" val="10000"/>
+                  </a:ext>
+                </a:extLst>
               </a:tr>
               <a:tr h="457200">
                 <a:tc>
@@ -20847,6 +21640,11 @@
                     </a:solidFill>
                   </a:tcPr>
                 </a:tc>
+                <a:extLst>
+                  <a:ext uri="{0D108BD9-81ED-4DB2-BD59-A6C34878D82A}">
+                    <a16:rowId xmlns:a16="http://schemas.microsoft.com/office/drawing/2014/main" val="10001"/>
+                  </a:ext>
+                </a:extLst>
               </a:tr>
               <a:tr h="457200">
                 <a:tc>
@@ -20918,6 +21716,11 @@
                     </a:solidFill>
                   </a:tcPr>
                 </a:tc>
+                <a:extLst>
+                  <a:ext uri="{0D108BD9-81ED-4DB2-BD59-A6C34878D82A}">
+                    <a16:rowId xmlns:a16="http://schemas.microsoft.com/office/drawing/2014/main" val="10002"/>
+                  </a:ext>
+                </a:extLst>
               </a:tr>
               <a:tr h="457200">
                 <a:tc>
@@ -20989,6 +21792,11 @@
                     </a:solidFill>
                   </a:tcPr>
                 </a:tc>
+                <a:extLst>
+                  <a:ext uri="{0D108BD9-81ED-4DB2-BD59-A6C34878D82A}">
+                    <a16:rowId xmlns:a16="http://schemas.microsoft.com/office/drawing/2014/main" val="10003"/>
+                  </a:ext>
+                </a:extLst>
               </a:tr>
               <a:tr h="457200">
                 <a:tc>
@@ -21060,6 +21868,11 @@
                     </a:solidFill>
                   </a:tcPr>
                 </a:tc>
+                <a:extLst>
+                  <a:ext uri="{0D108BD9-81ED-4DB2-BD59-A6C34878D82A}">
+                    <a16:rowId xmlns:a16="http://schemas.microsoft.com/office/drawing/2014/main" val="10004"/>
+                  </a:ext>
+                </a:extLst>
               </a:tr>
               <a:tr h="457200">
                 <a:tc>
@@ -21131,6 +21944,11 @@
                     </a:solidFill>
                   </a:tcPr>
                 </a:tc>
+                <a:extLst>
+                  <a:ext uri="{0D108BD9-81ED-4DB2-BD59-A6C34878D82A}">
+                    <a16:rowId xmlns:a16="http://schemas.microsoft.com/office/drawing/2014/main" val="10005"/>
+                  </a:ext>
+                </a:extLst>
               </a:tr>
               <a:tr h="457200">
                 <a:tc>
@@ -21202,6 +22020,11 @@
                     </a:solidFill>
                   </a:tcPr>
                 </a:tc>
+                <a:extLst>
+                  <a:ext uri="{0D108BD9-81ED-4DB2-BD59-A6C34878D82A}">
+                    <a16:rowId xmlns:a16="http://schemas.microsoft.com/office/drawing/2014/main" val="10006"/>
+                  </a:ext>
+                </a:extLst>
               </a:tr>
               <a:tr h="457200">
                 <a:tc>
@@ -21273,6 +22096,11 @@
                     </a:solidFill>
                   </a:tcPr>
                 </a:tc>
+                <a:extLst>
+                  <a:ext uri="{0D108BD9-81ED-4DB2-BD59-A6C34878D82A}">
+                    <a16:rowId xmlns:a16="http://schemas.microsoft.com/office/drawing/2014/main" val="10007"/>
+                  </a:ext>
+                </a:extLst>
               </a:tr>
             </a:tbl>
           </a:graphicData>
@@ -21322,7 +22150,7 @@
 </file>
 
 <file path=ppt/slides/slide7.xml><?xml version="1.0" encoding="utf-8"?>
-<p:sld xmlns:a="http://schemas.openxmlformats.org/drawingml/2006/main" xmlns:p="http://schemas.openxmlformats.org/presentationml/2006/main" xmlns:r="http://schemas.openxmlformats.org/officeDocument/2006/relationships">
+<p:sld xmlns:a="http://schemas.openxmlformats.org/drawingml/2006/main" xmlns:r="http://schemas.openxmlformats.org/officeDocument/2006/relationships" xmlns:p="http://schemas.openxmlformats.org/presentationml/2006/main">
   <p:cSld>
     <p:spTree>
       <p:nvGrpSpPr>
@@ -21330,7 +22158,14 @@
         <p:cNvGrpSpPr/>
         <p:nvPr/>
       </p:nvGrpSpPr>
-      <p:grpSpPr/>
+      <p:grpSpPr>
+        <a:xfrm>
+          <a:off x="0" y="0"/>
+          <a:ext cx="0" cy="0"/>
+          <a:chOff x="0" y="0"/>
+          <a:chExt cx="0" cy="0"/>
+        </a:xfrm>
+      </p:grpSpPr>
       <p:sp>
         <p:nvSpPr>
           <p:cNvPr id="2" name="Rectangle 1"/>
@@ -21371,6 +22206,7 @@
           <a:lstStyle/>
           <a:p>
             <a:pPr algn="ctr"/>
+            <a:endParaRPr/>
           </a:p>
         </p:txBody>
       </p:sp>
@@ -21484,6 +22320,7 @@
           <a:lstStyle/>
           <a:p>
             <a:pPr algn="ctr"/>
+            <a:endParaRPr/>
           </a:p>
         </p:txBody>
       </p:sp>
@@ -21611,10 +22448,34 @@
                 <a:tableStyleId>{5C22544A-7EE6-4342-B048-85BDC9FD1C3A}</a:tableStyleId>
               </a:tblPr>
               <a:tblGrid>
-                <a:gridCol w="1828800"/>
-                <a:gridCol w="2286000"/>
-                <a:gridCol w="3657600"/>
-                <a:gridCol w="3749039"/>
+                <a:gridCol w="1828800">
+                  <a:extLst>
+                    <a:ext uri="{9D8B030D-6E8A-4147-A177-3AD203B41FA5}">
+                      <a16:colId xmlns:a16="http://schemas.microsoft.com/office/drawing/2014/main" val="20000"/>
+                    </a:ext>
+                  </a:extLst>
+                </a:gridCol>
+                <a:gridCol w="2286000">
+                  <a:extLst>
+                    <a:ext uri="{9D8B030D-6E8A-4147-A177-3AD203B41FA5}">
+                      <a16:colId xmlns:a16="http://schemas.microsoft.com/office/drawing/2014/main" val="20001"/>
+                    </a:ext>
+                  </a:extLst>
+                </a:gridCol>
+                <a:gridCol w="3657600">
+                  <a:extLst>
+                    <a:ext uri="{9D8B030D-6E8A-4147-A177-3AD203B41FA5}">
+                      <a16:colId xmlns:a16="http://schemas.microsoft.com/office/drawing/2014/main" val="20002"/>
+                    </a:ext>
+                  </a:extLst>
+                </a:gridCol>
+                <a:gridCol w="3749039">
+                  <a:extLst>
+                    <a:ext uri="{9D8B030D-6E8A-4147-A177-3AD203B41FA5}">
+                      <a16:colId xmlns:a16="http://schemas.microsoft.com/office/drawing/2014/main" val="20003"/>
+                    </a:ext>
+                  </a:extLst>
+                </a:gridCol>
               </a:tblGrid>
               <a:tr h="411480">
                 <a:tc>
@@ -21709,6 +22570,11 @@
                     </a:solidFill>
                   </a:tcPr>
                 </a:tc>
+                <a:extLst>
+                  <a:ext uri="{0D108BD9-81ED-4DB2-BD59-A6C34878D82A}">
+                    <a16:rowId xmlns:a16="http://schemas.microsoft.com/office/drawing/2014/main" val="10000"/>
+                  </a:ext>
+                </a:extLst>
               </a:tr>
               <a:tr h="411480">
                 <a:tc>
@@ -21803,6 +22669,11 @@
                     </a:solidFill>
                   </a:tcPr>
                 </a:tc>
+                <a:extLst>
+                  <a:ext uri="{0D108BD9-81ED-4DB2-BD59-A6C34878D82A}">
+                    <a16:rowId xmlns:a16="http://schemas.microsoft.com/office/drawing/2014/main" val="10001"/>
+                  </a:ext>
+                </a:extLst>
               </a:tr>
               <a:tr h="411480">
                 <a:tc>
@@ -21897,6 +22768,11 @@
                     </a:solidFill>
                   </a:tcPr>
                 </a:tc>
+                <a:extLst>
+                  <a:ext uri="{0D108BD9-81ED-4DB2-BD59-A6C34878D82A}">
+                    <a16:rowId xmlns:a16="http://schemas.microsoft.com/office/drawing/2014/main" val="10002"/>
+                  </a:ext>
+                </a:extLst>
               </a:tr>
               <a:tr h="411480">
                 <a:tc>
@@ -21991,6 +22867,11 @@
                     </a:solidFill>
                   </a:tcPr>
                 </a:tc>
+                <a:extLst>
+                  <a:ext uri="{0D108BD9-81ED-4DB2-BD59-A6C34878D82A}">
+                    <a16:rowId xmlns:a16="http://schemas.microsoft.com/office/drawing/2014/main" val="10003"/>
+                  </a:ext>
+                </a:extLst>
               </a:tr>
               <a:tr h="411480">
                 <a:tc>
@@ -22085,6 +22966,11 @@
                     </a:solidFill>
                   </a:tcPr>
                 </a:tc>
+                <a:extLst>
+                  <a:ext uri="{0D108BD9-81ED-4DB2-BD59-A6C34878D82A}">
+                    <a16:rowId xmlns:a16="http://schemas.microsoft.com/office/drawing/2014/main" val="10004"/>
+                  </a:ext>
+                </a:extLst>
               </a:tr>
               <a:tr h="411480">
                 <a:tc>
@@ -22179,6 +23065,11 @@
                     </a:solidFill>
                   </a:tcPr>
                 </a:tc>
+                <a:extLst>
+                  <a:ext uri="{0D108BD9-81ED-4DB2-BD59-A6C34878D82A}">
+                    <a16:rowId xmlns:a16="http://schemas.microsoft.com/office/drawing/2014/main" val="10005"/>
+                  </a:ext>
+                </a:extLst>
               </a:tr>
             </a:tbl>
           </a:graphicData>
@@ -22192,7 +23083,7 @@
         </p:nvSpPr>
         <p:spPr>
           <a:xfrm>
-            <a:off x="320040" y="3657600"/>
+            <a:off x="320040" y="3931920"/>
             <a:ext cx="11521440" cy="960120"/>
           </a:xfrm>
           <a:prstGeom prst="rect">
@@ -22226,6 +23117,7 @@
           <a:lstStyle/>
           <a:p>
             <a:pPr algn="ctr"/>
+            <a:endParaRPr/>
           </a:p>
         </p:txBody>
       </p:sp>
@@ -22237,7 +23129,7 @@
         </p:nvSpPr>
         <p:spPr>
           <a:xfrm>
-            <a:off x="502920" y="3703320"/>
+            <a:off x="502920" y="3977639"/>
             <a:ext cx="11155680" cy="365760"/>
           </a:xfrm>
           <a:prstGeom prst="rect">
@@ -22272,7 +23164,7 @@
         </p:nvSpPr>
         <p:spPr>
           <a:xfrm>
-            <a:off x="502920" y="4096512"/>
+            <a:off x="502920" y="4370832"/>
             <a:ext cx="11155680" cy="411480"/>
           </a:xfrm>
           <a:prstGeom prst="rect">
@@ -22307,7 +23199,7 @@
         </p:nvSpPr>
         <p:spPr>
           <a:xfrm>
-            <a:off x="320040" y="4709160"/>
+            <a:off x="320040" y="4983480"/>
             <a:ext cx="11521440" cy="640080"/>
           </a:xfrm>
           <a:prstGeom prst="rect">
@@ -22339,6 +23231,7 @@
           <a:lstStyle/>
           <a:p>
             <a:pPr algn="ctr"/>
+            <a:endParaRPr/>
           </a:p>
         </p:txBody>
       </p:sp>
@@ -22350,7 +23243,7 @@
         </p:nvSpPr>
         <p:spPr>
           <a:xfrm>
-            <a:off x="502920" y="4773168"/>
+            <a:off x="502920" y="5047488"/>
             <a:ext cx="11155680" cy="502920"/>
           </a:xfrm>
           <a:prstGeom prst="rect">
@@ -22386,7 +23279,7 @@
 </file>
 
 <file path=ppt/slides/slide8.xml><?xml version="1.0" encoding="utf-8"?>
-<p:sld xmlns:a="http://schemas.openxmlformats.org/drawingml/2006/main" xmlns:p="http://schemas.openxmlformats.org/presentationml/2006/main" xmlns:r="http://schemas.openxmlformats.org/officeDocument/2006/relationships">
+<p:sld xmlns:a="http://schemas.openxmlformats.org/drawingml/2006/main" xmlns:r="http://schemas.openxmlformats.org/officeDocument/2006/relationships" xmlns:p="http://schemas.openxmlformats.org/presentationml/2006/main">
   <p:cSld>
     <p:spTree>
       <p:nvGrpSpPr>
@@ -22394,7 +23287,14 @@
         <p:cNvGrpSpPr/>
         <p:nvPr/>
       </p:nvGrpSpPr>
-      <p:grpSpPr/>
+      <p:grpSpPr>
+        <a:xfrm>
+          <a:off x="0" y="0"/>
+          <a:ext cx="0" cy="0"/>
+          <a:chOff x="0" y="0"/>
+          <a:chExt cx="0" cy="0"/>
+        </a:xfrm>
+      </p:grpSpPr>
       <p:sp>
         <p:nvSpPr>
           <p:cNvPr id="2" name="Rectangle 1"/>
@@ -22435,6 +23335,7 @@
           <a:lstStyle/>
           <a:p>
             <a:pPr algn="ctr"/>
+            <a:endParaRPr/>
           </a:p>
         </p:txBody>
       </p:sp>
@@ -22548,6 +23449,7 @@
           <a:lstStyle/>
           <a:p>
             <a:pPr algn="ctr"/>
+            <a:endParaRPr/>
           </a:p>
         </p:txBody>
       </p:sp>
@@ -22640,9 +23542,27 @@
                 <a:tableStyleId>{5C22544A-7EE6-4342-B048-85BDC9FD1C3A}</a:tableStyleId>
               </a:tblPr>
               <a:tblGrid>
-                <a:gridCol w="2560320"/>
-                <a:gridCol w="2743200"/>
-                <a:gridCol w="6217920"/>
+                <a:gridCol w="2560320">
+                  <a:extLst>
+                    <a:ext uri="{9D8B030D-6E8A-4147-A177-3AD203B41FA5}">
+                      <a16:colId xmlns:a16="http://schemas.microsoft.com/office/drawing/2014/main" val="20000"/>
+                    </a:ext>
+                  </a:extLst>
+                </a:gridCol>
+                <a:gridCol w="2743200">
+                  <a:extLst>
+                    <a:ext uri="{9D8B030D-6E8A-4147-A177-3AD203B41FA5}">
+                      <a16:colId xmlns:a16="http://schemas.microsoft.com/office/drawing/2014/main" val="20001"/>
+                    </a:ext>
+                  </a:extLst>
+                </a:gridCol>
+                <a:gridCol w="6217920">
+                  <a:extLst>
+                    <a:ext uri="{9D8B030D-6E8A-4147-A177-3AD203B41FA5}">
+                      <a16:colId xmlns:a16="http://schemas.microsoft.com/office/drawing/2014/main" val="20002"/>
+                    </a:ext>
+                  </a:extLst>
+                </a:gridCol>
               </a:tblGrid>
               <a:tr h="438912">
                 <a:tc>
@@ -22714,6 +23634,11 @@
                     </a:solidFill>
                   </a:tcPr>
                 </a:tc>
+                <a:extLst>
+                  <a:ext uri="{0D108BD9-81ED-4DB2-BD59-A6C34878D82A}">
+                    <a16:rowId xmlns:a16="http://schemas.microsoft.com/office/drawing/2014/main" val="10000"/>
+                  </a:ext>
+                </a:extLst>
               </a:tr>
               <a:tr h="438912">
                 <a:tc>
@@ -22785,6 +23710,11 @@
                     </a:solidFill>
                   </a:tcPr>
                 </a:tc>
+                <a:extLst>
+                  <a:ext uri="{0D108BD9-81ED-4DB2-BD59-A6C34878D82A}">
+                    <a16:rowId xmlns:a16="http://schemas.microsoft.com/office/drawing/2014/main" val="10001"/>
+                  </a:ext>
+                </a:extLst>
               </a:tr>
               <a:tr h="438912">
                 <a:tc>
@@ -22856,6 +23786,11 @@
                     </a:solidFill>
                   </a:tcPr>
                 </a:tc>
+                <a:extLst>
+                  <a:ext uri="{0D108BD9-81ED-4DB2-BD59-A6C34878D82A}">
+                    <a16:rowId xmlns:a16="http://schemas.microsoft.com/office/drawing/2014/main" val="10002"/>
+                  </a:ext>
+                </a:extLst>
               </a:tr>
               <a:tr h="438912">
                 <a:tc>
@@ -22927,6 +23862,11 @@
                     </a:solidFill>
                   </a:tcPr>
                 </a:tc>
+                <a:extLst>
+                  <a:ext uri="{0D108BD9-81ED-4DB2-BD59-A6C34878D82A}">
+                    <a16:rowId xmlns:a16="http://schemas.microsoft.com/office/drawing/2014/main" val="10003"/>
+                  </a:ext>
+                </a:extLst>
               </a:tr>
               <a:tr h="438912">
                 <a:tc>
@@ -22998,6 +23938,11 @@
                     </a:solidFill>
                   </a:tcPr>
                 </a:tc>
+                <a:extLst>
+                  <a:ext uri="{0D108BD9-81ED-4DB2-BD59-A6C34878D82A}">
+                    <a16:rowId xmlns:a16="http://schemas.microsoft.com/office/drawing/2014/main" val="10004"/>
+                  </a:ext>
+                </a:extLst>
               </a:tr>
               <a:tr h="438912">
                 <a:tc>
@@ -23069,6 +24014,11 @@
                     </a:solidFill>
                   </a:tcPr>
                 </a:tc>
+                <a:extLst>
+                  <a:ext uri="{0D108BD9-81ED-4DB2-BD59-A6C34878D82A}">
+                    <a16:rowId xmlns:a16="http://schemas.microsoft.com/office/drawing/2014/main" val="10005"/>
+                  </a:ext>
+                </a:extLst>
               </a:tr>
               <a:tr h="438912">
                 <a:tc>
@@ -23140,6 +24090,11 @@
                     </a:solidFill>
                   </a:tcPr>
                 </a:tc>
+                <a:extLst>
+                  <a:ext uri="{0D108BD9-81ED-4DB2-BD59-A6C34878D82A}">
+                    <a16:rowId xmlns:a16="http://schemas.microsoft.com/office/drawing/2014/main" val="10006"/>
+                  </a:ext>
+                </a:extLst>
               </a:tr>
               <a:tr h="438912">
                 <a:tc>
@@ -23211,6 +24166,11 @@
                     </a:solidFill>
                   </a:tcPr>
                 </a:tc>
+                <a:extLst>
+                  <a:ext uri="{0D108BD9-81ED-4DB2-BD59-A6C34878D82A}">
+                    <a16:rowId xmlns:a16="http://schemas.microsoft.com/office/drawing/2014/main" val="10007"/>
+                  </a:ext>
+                </a:extLst>
               </a:tr>
             </a:tbl>
           </a:graphicData>
@@ -23256,6 +24216,7 @@
           <a:lstStyle/>
           <a:p>
             <a:pPr algn="ctr"/>
+            <a:endParaRPr/>
           </a:p>
         </p:txBody>
       </p:sp>
@@ -23315,7 +24276,7 @@
 </file>
 
 <file path=ppt/slides/slide9.xml><?xml version="1.0" encoding="utf-8"?>
-<p:sld xmlns:a="http://schemas.openxmlformats.org/drawingml/2006/main" xmlns:p="http://schemas.openxmlformats.org/presentationml/2006/main" xmlns:r="http://schemas.openxmlformats.org/officeDocument/2006/relationships">
+<p:sld xmlns:a="http://schemas.openxmlformats.org/drawingml/2006/main" xmlns:r="http://schemas.openxmlformats.org/officeDocument/2006/relationships" xmlns:p="http://schemas.openxmlformats.org/presentationml/2006/main">
   <p:cSld>
     <p:spTree>
       <p:nvGrpSpPr>
@@ -23323,7 +24284,14 @@
         <p:cNvGrpSpPr/>
         <p:nvPr/>
       </p:nvGrpSpPr>
-      <p:grpSpPr/>
+      <p:grpSpPr>
+        <a:xfrm>
+          <a:off x="0" y="0"/>
+          <a:ext cx="0" cy="0"/>
+          <a:chOff x="0" y="0"/>
+          <a:chExt cx="0" cy="0"/>
+        </a:xfrm>
+      </p:grpSpPr>
       <p:sp>
         <p:nvSpPr>
           <p:cNvPr id="2" name="Rectangle 1"/>
@@ -23364,6 +24332,7 @@
           <a:lstStyle/>
           <a:p>
             <a:pPr algn="ctr"/>
+            <a:endParaRPr/>
           </a:p>
         </p:txBody>
       </p:sp>
@@ -23477,6 +24446,7 @@
           <a:lstStyle/>
           <a:p>
             <a:pPr algn="ctr"/>
+            <a:endParaRPr/>
           </a:p>
         </p:txBody>
       </p:sp>
@@ -23590,6 +24560,7 @@
           <a:lstStyle/>
           <a:p>
             <a:pPr algn="ctr"/>
+            <a:endParaRPr/>
           </a:p>
         </p:txBody>
       </p:sp>
@@ -23774,6 +24745,7 @@
           <a:lstStyle/>
           <a:p>
             <a:pPr algn="ctr"/>
+            <a:endParaRPr/>
           </a:p>
         </p:txBody>
       </p:sp>
@@ -23957,6 +24929,7 @@
           <a:lstStyle/>
           <a:p>
             <a:pPr algn="ctr"/>
+            <a:endParaRPr/>
           </a:p>
         </p:txBody>
       </p:sp>
@@ -24140,6 +25113,7 @@
           <a:lstStyle/>
           <a:p>
             <a:pPr algn="ctr"/>
+            <a:endParaRPr/>
           </a:p>
         </p:txBody>
       </p:sp>
@@ -24268,10 +25242,34 @@
                 <a:tableStyleId>{5C22544A-7EE6-4342-B048-85BDC9FD1C3A}</a:tableStyleId>
               </a:tblPr>
               <a:tblGrid>
-                <a:gridCol w="1828800"/>
-                <a:gridCol w="1828800"/>
-                <a:gridCol w="3657600"/>
-                <a:gridCol w="4206240"/>
+                <a:gridCol w="1828800">
+                  <a:extLst>
+                    <a:ext uri="{9D8B030D-6E8A-4147-A177-3AD203B41FA5}">
+                      <a16:colId xmlns:a16="http://schemas.microsoft.com/office/drawing/2014/main" val="20000"/>
+                    </a:ext>
+                  </a:extLst>
+                </a:gridCol>
+                <a:gridCol w="1828800">
+                  <a:extLst>
+                    <a:ext uri="{9D8B030D-6E8A-4147-A177-3AD203B41FA5}">
+                      <a16:colId xmlns:a16="http://schemas.microsoft.com/office/drawing/2014/main" val="20001"/>
+                    </a:ext>
+                  </a:extLst>
+                </a:gridCol>
+                <a:gridCol w="3657600">
+                  <a:extLst>
+                    <a:ext uri="{9D8B030D-6E8A-4147-A177-3AD203B41FA5}">
+                      <a16:colId xmlns:a16="http://schemas.microsoft.com/office/drawing/2014/main" val="20002"/>
+                    </a:ext>
+                  </a:extLst>
+                </a:gridCol>
+                <a:gridCol w="4206240">
+                  <a:extLst>
+                    <a:ext uri="{9D8B030D-6E8A-4147-A177-3AD203B41FA5}">
+                      <a16:colId xmlns:a16="http://schemas.microsoft.com/office/drawing/2014/main" val="20003"/>
+                    </a:ext>
+                  </a:extLst>
+                </a:gridCol>
               </a:tblGrid>
               <a:tr h="402336">
                 <a:tc>
@@ -24366,6 +25364,11 @@
                     </a:solidFill>
                   </a:tcPr>
                 </a:tc>
+                <a:extLst>
+                  <a:ext uri="{0D108BD9-81ED-4DB2-BD59-A6C34878D82A}">
+                    <a16:rowId xmlns:a16="http://schemas.microsoft.com/office/drawing/2014/main" val="10000"/>
+                  </a:ext>
+                </a:extLst>
               </a:tr>
               <a:tr h="402336">
                 <a:tc>
@@ -24460,6 +25463,11 @@
                     </a:solidFill>
                   </a:tcPr>
                 </a:tc>
+                <a:extLst>
+                  <a:ext uri="{0D108BD9-81ED-4DB2-BD59-A6C34878D82A}">
+                    <a16:rowId xmlns:a16="http://schemas.microsoft.com/office/drawing/2014/main" val="10001"/>
+                  </a:ext>
+                </a:extLst>
               </a:tr>
               <a:tr h="402336">
                 <a:tc>
@@ -24554,6 +25562,11 @@
                     </a:solidFill>
                   </a:tcPr>
                 </a:tc>
+                <a:extLst>
+                  <a:ext uri="{0D108BD9-81ED-4DB2-BD59-A6C34878D82A}">
+                    <a16:rowId xmlns:a16="http://schemas.microsoft.com/office/drawing/2014/main" val="10002"/>
+                  </a:ext>
+                </a:extLst>
               </a:tr>
               <a:tr h="402336">
                 <a:tc>
@@ -24648,6 +25661,11 @@
                     </a:solidFill>
                   </a:tcPr>
                 </a:tc>
+                <a:extLst>
+                  <a:ext uri="{0D108BD9-81ED-4DB2-BD59-A6C34878D82A}">
+                    <a16:rowId xmlns:a16="http://schemas.microsoft.com/office/drawing/2014/main" val="10003"/>
+                  </a:ext>
+                </a:extLst>
               </a:tr>
               <a:tr h="402336">
                 <a:tc>
@@ -24742,6 +25760,11 @@
                     </a:solidFill>
                   </a:tcPr>
                 </a:tc>
+                <a:extLst>
+                  <a:ext uri="{0D108BD9-81ED-4DB2-BD59-A6C34878D82A}">
+                    <a16:rowId xmlns:a16="http://schemas.microsoft.com/office/drawing/2014/main" val="10004"/>
+                  </a:ext>
+                </a:extLst>
               </a:tr>
               <a:tr h="402336">
                 <a:tc>
@@ -24836,6 +25859,11 @@
                     </a:solidFill>
                   </a:tcPr>
                 </a:tc>
+                <a:extLst>
+                  <a:ext uri="{0D108BD9-81ED-4DB2-BD59-A6C34878D82A}">
+                    <a16:rowId xmlns:a16="http://schemas.microsoft.com/office/drawing/2014/main" val="10005"/>
+                  </a:ext>
+                </a:extLst>
               </a:tr>
             </a:tbl>
           </a:graphicData>

</xml_diff>